<commit_message>
docs(planning) : add Confluence reference document for HyDE feed project
</commit_message>
<xml_diff>
--- a/logs/Ghostdeck.pptx
+++ b/logs/Ghostdeck.pptx
@@ -5,7 +5,7 @@
     <p:sldMasterId id="2147483648" r:id="rId1"/>
   </p:sldMasterIdLst>
   <p:notesMasterIdLst>
-    <p:notesMasterId r:id="rId34"/>
+    <p:notesMasterId r:id="rId40"/>
   </p:notesMasterIdLst>
   <p:sldIdLst>
     <p:sldId id="2147481407" r:id="rId2"/>
@@ -28,18 +28,24 @@
     <p:sldId id="2147481414" r:id="rId19"/>
     <p:sldId id="2147481431" r:id="rId20"/>
     <p:sldId id="2147481412" r:id="rId21"/>
-    <p:sldId id="2147481445" r:id="rId22"/>
+    <p:sldId id="2147481452" r:id="rId22"/>
     <p:sldId id="2147481446" r:id="rId23"/>
-    <p:sldId id="2147481413" r:id="rId24"/>
-    <p:sldId id="2147481419" r:id="rId25"/>
-    <p:sldId id="2147481427" r:id="rId26"/>
-    <p:sldId id="2147481422" r:id="rId27"/>
-    <p:sldId id="2147481423" r:id="rId28"/>
-    <p:sldId id="2147481425" r:id="rId29"/>
-    <p:sldId id="2147481426" r:id="rId30"/>
-    <p:sldId id="2147481429" r:id="rId31"/>
-    <p:sldId id="2147481428" r:id="rId32"/>
-    <p:sldId id="2147481430" r:id="rId33"/>
+    <p:sldId id="2147481449" r:id="rId24"/>
+    <p:sldId id="2147481448" r:id="rId25"/>
+    <p:sldId id="2147481447" r:id="rId26"/>
+    <p:sldId id="2147481451" r:id="rId27"/>
+    <p:sldId id="2147481450" r:id="rId28"/>
+    <p:sldId id="2147481445" r:id="rId29"/>
+    <p:sldId id="2147481413" r:id="rId30"/>
+    <p:sldId id="2147481419" r:id="rId31"/>
+    <p:sldId id="2147481427" r:id="rId32"/>
+    <p:sldId id="2147481422" r:id="rId33"/>
+    <p:sldId id="2147481423" r:id="rId34"/>
+    <p:sldId id="2147481425" r:id="rId35"/>
+    <p:sldId id="2147481426" r:id="rId36"/>
+    <p:sldId id="2147481429" r:id="rId37"/>
+    <p:sldId id="2147481428" r:id="rId38"/>
+    <p:sldId id="2147481430" r:id="rId39"/>
   </p:sldIdLst>
   <p:sldSz cx="12192000" cy="6858000"/>
   <p:notesSz cx="6858000" cy="9144000"/>
@@ -228,7 +234,7 @@
           <a:p>
             <a:fld id="{6D077408-611F-43B7-A58B-066AB354FAB6}" type="datetimeFigureOut">
               <a:rPr lang="en-US" smtClean="0"/>
-              <a:t>2/3/2026</a:t>
+              <a:t>2/5/2026</a:t>
             </a:fld>
             <a:endParaRPr lang="en-US"/>
           </a:p>
@@ -1152,6 +1158,117 @@
 </p:notes>
 </file>
 
+<file path=ppt/notesSlides/notesSlide7.xml><?xml version="1.0" encoding="utf-8"?>
+<p:notes xmlns:a="http://schemas.openxmlformats.org/drawingml/2006/main" xmlns:r="http://schemas.openxmlformats.org/officeDocument/2006/relationships" xmlns:p="http://schemas.openxmlformats.org/presentationml/2006/main">
+  <p:cSld>
+    <p:spTree>
+      <p:nvGrpSpPr>
+        <p:cNvPr id="1" name="">
+          <a:extLst>
+            <a:ext uri="{FF2B5EF4-FFF2-40B4-BE49-F238E27FC236}">
+              <a16:creationId xmlns:a16="http://schemas.microsoft.com/office/drawing/2014/main" id="{82A3BD6C-7539-AB94-3C3A-37A9F3AE8CEA}"/>
+            </a:ext>
+          </a:extLst>
+        </p:cNvPr>
+        <p:cNvGrpSpPr/>
+        <p:nvPr/>
+      </p:nvGrpSpPr>
+      <p:grpSpPr>
+        <a:xfrm>
+          <a:off x="0" y="0"/>
+          <a:ext cx="0" cy="0"/>
+          <a:chOff x="0" y="0"/>
+          <a:chExt cx="0" cy="0"/>
+        </a:xfrm>
+      </p:grpSpPr>
+      <p:sp>
+        <p:nvSpPr>
+          <p:cNvPr id="2" name="Slide Image Placeholder 1">
+            <a:extLst>
+              <a:ext uri="{FF2B5EF4-FFF2-40B4-BE49-F238E27FC236}">
+                <a16:creationId xmlns:a16="http://schemas.microsoft.com/office/drawing/2014/main" id="{727F1212-E606-FF40-FBD5-8F981EB3B654}"/>
+              </a:ext>
+            </a:extLst>
+          </p:cNvPr>
+          <p:cNvSpPr>
+            <a:spLocks noGrp="1" noRot="1" noChangeAspect="1"/>
+          </p:cNvSpPr>
+          <p:nvPr>
+            <p:ph type="sldImg"/>
+          </p:nvPr>
+        </p:nvSpPr>
+        <p:spPr/>
+      </p:sp>
+      <p:sp>
+        <p:nvSpPr>
+          <p:cNvPr id="3" name="Notes Placeholder 2">
+            <a:extLst>
+              <a:ext uri="{FF2B5EF4-FFF2-40B4-BE49-F238E27FC236}">
+                <a16:creationId xmlns:a16="http://schemas.microsoft.com/office/drawing/2014/main" id="{33067A11-045C-7620-3ED3-03ADEB29ECA0}"/>
+              </a:ext>
+            </a:extLst>
+          </p:cNvPr>
+          <p:cNvSpPr>
+            <a:spLocks noGrp="1"/>
+          </p:cNvSpPr>
+          <p:nvPr>
+            <p:ph type="body" idx="1"/>
+          </p:nvPr>
+        </p:nvSpPr>
+        <p:spPr/>
+        <p:txBody>
+          <a:bodyPr/>
+          <a:lstStyle/>
+          <a:p>
+            <a:r>
+              <a:rPr lang="en-US" dirty="0"/>
+              <a:t>https://www.quorum.co.uk/2024/04/09/database-data-lake-data-warehouse-whats-the-difference/</a:t>
+            </a:r>
+          </a:p>
+        </p:txBody>
+      </p:sp>
+      <p:sp>
+        <p:nvSpPr>
+          <p:cNvPr id="4" name="Slide Number Placeholder 3">
+            <a:extLst>
+              <a:ext uri="{FF2B5EF4-FFF2-40B4-BE49-F238E27FC236}">
+                <a16:creationId xmlns:a16="http://schemas.microsoft.com/office/drawing/2014/main" id="{9619D0D1-B850-4B2B-308E-C661AE72D7CD}"/>
+              </a:ext>
+            </a:extLst>
+          </p:cNvPr>
+          <p:cNvSpPr>
+            <a:spLocks noGrp="1"/>
+          </p:cNvSpPr>
+          <p:nvPr>
+            <p:ph type="sldNum" sz="quarter" idx="5"/>
+          </p:nvPr>
+        </p:nvSpPr>
+        <p:spPr/>
+        <p:txBody>
+          <a:bodyPr/>
+          <a:lstStyle/>
+          <a:p>
+            <a:fld id="{5744687F-F839-4783-9AA2-9E2F10A9DB4B}" type="slidenum">
+              <a:rPr lang="en-US" smtClean="0"/>
+              <a:t>24</a:t>
+            </a:fld>
+            <a:endParaRPr lang="en-US"/>
+          </a:p>
+        </p:txBody>
+      </p:sp>
+    </p:spTree>
+    <p:extLst>
+      <p:ext uri="{BB962C8B-B14F-4D97-AF65-F5344CB8AC3E}">
+        <p14:creationId xmlns:p14="http://schemas.microsoft.com/office/powerpoint/2010/main" val="4230411242"/>
+      </p:ext>
+    </p:extLst>
+  </p:cSld>
+  <p:clrMapOvr>
+    <a:masterClrMapping/>
+  </p:clrMapOvr>
+</p:notes>
+</file>
+
 <file path=ppt/slideLayouts/slideLayout1.xml><?xml version="1.0" encoding="utf-8"?>
 <p:sldLayout xmlns:a="http://schemas.openxmlformats.org/drawingml/2006/main" xmlns:r="http://schemas.openxmlformats.org/officeDocument/2006/relationships" xmlns:p="http://schemas.openxmlformats.org/presentationml/2006/main" type="title" preserve="1">
   <p:cSld name="Title Slide">
@@ -1299,7 +1416,7 @@
           <a:p>
             <a:fld id="{9DA1BED4-5DFC-4D8B-BC40-12FD5FE4AB0F}" type="datetimeFigureOut">
               <a:rPr lang="en-US" smtClean="0"/>
-              <a:t>2/3/2026</a:t>
+              <a:t>2/5/2026</a:t>
             </a:fld>
             <a:endParaRPr lang="en-US"/>
           </a:p>
@@ -1497,7 +1614,7 @@
           <a:p>
             <a:fld id="{9DA1BED4-5DFC-4D8B-BC40-12FD5FE4AB0F}" type="datetimeFigureOut">
               <a:rPr lang="en-US" smtClean="0"/>
-              <a:t>2/3/2026</a:t>
+              <a:t>2/5/2026</a:t>
             </a:fld>
             <a:endParaRPr lang="en-US"/>
           </a:p>
@@ -1705,7 +1822,7 @@
           <a:p>
             <a:fld id="{9DA1BED4-5DFC-4D8B-BC40-12FD5FE4AB0F}" type="datetimeFigureOut">
               <a:rPr lang="en-US" smtClean="0"/>
-              <a:t>2/3/2026</a:t>
+              <a:t>2/5/2026</a:t>
             </a:fld>
             <a:endParaRPr lang="en-US"/>
           </a:p>
@@ -2134,7 +2251,7 @@
           <a:p>
             <a:fld id="{9DA1BED4-5DFC-4D8B-BC40-12FD5FE4AB0F}" type="datetimeFigureOut">
               <a:rPr lang="en-US" smtClean="0"/>
-              <a:t>2/3/2026</a:t>
+              <a:t>2/5/2026</a:t>
             </a:fld>
             <a:endParaRPr lang="en-US"/>
           </a:p>
@@ -2409,7 +2526,7 @@
           <a:p>
             <a:fld id="{9DA1BED4-5DFC-4D8B-BC40-12FD5FE4AB0F}" type="datetimeFigureOut">
               <a:rPr lang="en-US" smtClean="0"/>
-              <a:t>2/3/2026</a:t>
+              <a:t>2/5/2026</a:t>
             </a:fld>
             <a:endParaRPr lang="en-US"/>
           </a:p>
@@ -2674,7 +2791,7 @@
           <a:p>
             <a:fld id="{9DA1BED4-5DFC-4D8B-BC40-12FD5FE4AB0F}" type="datetimeFigureOut">
               <a:rPr lang="en-US" smtClean="0"/>
-              <a:t>2/3/2026</a:t>
+              <a:t>2/5/2026</a:t>
             </a:fld>
             <a:endParaRPr lang="en-US"/>
           </a:p>
@@ -3086,7 +3203,7 @@
           <a:p>
             <a:fld id="{9DA1BED4-5DFC-4D8B-BC40-12FD5FE4AB0F}" type="datetimeFigureOut">
               <a:rPr lang="en-US" smtClean="0"/>
-              <a:t>2/3/2026</a:t>
+              <a:t>2/5/2026</a:t>
             </a:fld>
             <a:endParaRPr lang="en-US"/>
           </a:p>
@@ -3227,7 +3344,7 @@
           <a:p>
             <a:fld id="{9DA1BED4-5DFC-4D8B-BC40-12FD5FE4AB0F}" type="datetimeFigureOut">
               <a:rPr lang="en-US" smtClean="0"/>
-              <a:t>2/3/2026</a:t>
+              <a:t>2/5/2026</a:t>
             </a:fld>
             <a:endParaRPr lang="en-US"/>
           </a:p>
@@ -3340,7 +3457,7 @@
           <a:p>
             <a:fld id="{9DA1BED4-5DFC-4D8B-BC40-12FD5FE4AB0F}" type="datetimeFigureOut">
               <a:rPr lang="en-US" smtClean="0"/>
-              <a:t>2/3/2026</a:t>
+              <a:t>2/5/2026</a:t>
             </a:fld>
             <a:endParaRPr lang="en-US"/>
           </a:p>
@@ -3651,7 +3768,7 @@
           <a:p>
             <a:fld id="{9DA1BED4-5DFC-4D8B-BC40-12FD5FE4AB0F}" type="datetimeFigureOut">
               <a:rPr lang="en-US" smtClean="0"/>
-              <a:t>2/3/2026</a:t>
+              <a:t>2/5/2026</a:t>
             </a:fld>
             <a:endParaRPr lang="en-US"/>
           </a:p>
@@ -3939,7 +4056,7 @@
           <a:p>
             <a:fld id="{9DA1BED4-5DFC-4D8B-BC40-12FD5FE4AB0F}" type="datetimeFigureOut">
               <a:rPr lang="en-US" smtClean="0"/>
-              <a:t>2/3/2026</a:t>
+              <a:t>2/5/2026</a:t>
             </a:fld>
             <a:endParaRPr lang="en-US"/>
           </a:p>
@@ -4180,7 +4297,7 @@
           <a:p>
             <a:fld id="{9DA1BED4-5DFC-4D8B-BC40-12FD5FE4AB0F}" type="datetimeFigureOut">
               <a:rPr lang="en-US" smtClean="0"/>
-              <a:t>2/3/2026</a:t>
+              <a:t>2/5/2026</a:t>
             </a:fld>
             <a:endParaRPr lang="en-US"/>
           </a:p>
@@ -24258,6 +24375,1683 @@
 </file>
 
 <file path=ppt/slides/slide21.xml><?xml version="1.0" encoding="utf-8"?>
+<p:sld xmlns:a="http://schemas.openxmlformats.org/drawingml/2006/main" xmlns:r="http://schemas.openxmlformats.org/officeDocument/2006/relationships" xmlns:p="http://schemas.openxmlformats.org/presentationml/2006/main">
+  <p:cSld>
+    <p:spTree>
+      <p:nvGrpSpPr>
+        <p:cNvPr id="1" name="">
+          <a:extLst>
+            <a:ext uri="{FF2B5EF4-FFF2-40B4-BE49-F238E27FC236}">
+              <a16:creationId xmlns:a16="http://schemas.microsoft.com/office/drawing/2014/main" id="{C7BE941F-70D2-FB27-A0B2-86FD51169124}"/>
+            </a:ext>
+          </a:extLst>
+        </p:cNvPr>
+        <p:cNvGrpSpPr/>
+        <p:nvPr/>
+      </p:nvGrpSpPr>
+      <p:grpSpPr>
+        <a:xfrm>
+          <a:off x="0" y="0"/>
+          <a:ext cx="0" cy="0"/>
+          <a:chOff x="0" y="0"/>
+          <a:chExt cx="0" cy="0"/>
+        </a:xfrm>
+      </p:grpSpPr>
+      <p:sp>
+        <p:nvSpPr>
+          <p:cNvPr id="2" name="Title 1">
+            <a:extLst>
+              <a:ext uri="{FF2B5EF4-FFF2-40B4-BE49-F238E27FC236}">
+                <a16:creationId xmlns:a16="http://schemas.microsoft.com/office/drawing/2014/main" id="{6FCBFEDE-DA0B-F13A-F573-9B4A176533E2}"/>
+              </a:ext>
+            </a:extLst>
+          </p:cNvPr>
+          <p:cNvSpPr>
+            <a:spLocks noGrp="1"/>
+          </p:cNvSpPr>
+          <p:nvPr>
+            <p:ph type="title"/>
+          </p:nvPr>
+        </p:nvSpPr>
+        <p:spPr>
+          <a:xfrm>
+            <a:off x="342901" y="186666"/>
+            <a:ext cx="10515600" cy="625474"/>
+          </a:xfrm>
+        </p:spPr>
+        <p:txBody>
+          <a:bodyPr>
+            <a:noAutofit/>
+          </a:bodyPr>
+          <a:lstStyle/>
+          <a:p>
+            <a:r>
+              <a:rPr lang="en-US" sz="3200" dirty="0"/>
+              <a:t>Thu,050226</a:t>
+            </a:r>
+          </a:p>
+        </p:txBody>
+      </p:sp>
+      <p:sp>
+        <p:nvSpPr>
+          <p:cNvPr id="4" name="Content Placeholder 3">
+            <a:extLst>
+              <a:ext uri="{FF2B5EF4-FFF2-40B4-BE49-F238E27FC236}">
+                <a16:creationId xmlns:a16="http://schemas.microsoft.com/office/drawing/2014/main" id="{E4D23895-89DB-1145-D0B3-790DD0026EFA}"/>
+              </a:ext>
+            </a:extLst>
+          </p:cNvPr>
+          <p:cNvSpPr>
+            <a:spLocks noGrp="1"/>
+          </p:cNvSpPr>
+          <p:nvPr>
+            <p:ph idx="1"/>
+          </p:nvPr>
+        </p:nvSpPr>
+        <p:spPr>
+          <a:xfrm>
+            <a:off x="342901" y="1019175"/>
+            <a:ext cx="11515724" cy="5206072"/>
+          </a:xfrm>
+        </p:spPr>
+        <p:txBody>
+          <a:bodyPr>
+            <a:normAutofit lnSpcReduction="10000"/>
+          </a:bodyPr>
+          <a:lstStyle/>
+          <a:p>
+            <a:r>
+              <a:rPr lang="en-US" sz="2400" dirty="0"/>
+              <a:t>Done</a:t>
+            </a:r>
+          </a:p>
+          <a:p>
+            <a:pPr lvl="1"/>
+            <a:r>
+              <a:rPr lang="en-US" sz="2000" dirty="0"/>
+              <a:t>Read and understood the QA Test Plan for the CV Evaluation Pipeline link</a:t>
+            </a:r>
+          </a:p>
+          <a:p>
+            <a:pPr lvl="1"/>
+            <a:r>
+              <a:rPr lang="en-US" sz="2000" dirty="0"/>
+              <a:t>Understanding task for sprint 11 then prepare material to discuss (B4 </a:t>
+            </a:r>
+            <a:r>
+              <a:rPr lang="en-US" sz="2000" dirty="0" err="1"/>
+              <a:t>P’bloom</a:t>
+            </a:r>
+            <a:r>
+              <a:rPr lang="en-US" sz="2000" dirty="0"/>
+              <a:t> vacation)</a:t>
+            </a:r>
+          </a:p>
+          <a:p>
+            <a:r>
+              <a:rPr lang="en-US" sz="2400" dirty="0"/>
+              <a:t>Todo</a:t>
+            </a:r>
+          </a:p>
+          <a:p>
+            <a:pPr lvl="1"/>
+            <a:r>
+              <a:rPr lang="en-US" sz="2000" dirty="0"/>
+              <a:t>Align </a:t>
+            </a:r>
+            <a:r>
+              <a:rPr lang="en-US" sz="2000" dirty="0" err="1"/>
+              <a:t>CVEvaluation</a:t>
+            </a:r>
+            <a:r>
+              <a:rPr lang="en-US" sz="2000" dirty="0"/>
+              <a:t> QA  with </a:t>
+            </a:r>
+            <a:r>
+              <a:rPr lang="en-US" sz="2000" dirty="0" err="1"/>
+              <a:t>P’bloom</a:t>
+            </a:r>
+            <a:endParaRPr lang="en-US" sz="2000" dirty="0"/>
+          </a:p>
+          <a:p>
+            <a:pPr lvl="1"/>
+            <a:r>
+              <a:rPr lang="en-US" sz="2000" dirty="0"/>
+              <a:t>Align Feed </a:t>
+            </a:r>
+            <a:r>
+              <a:rPr lang="en-US" sz="2000" dirty="0" err="1"/>
+              <a:t>recommentdation</a:t>
+            </a:r>
+            <a:r>
+              <a:rPr lang="en-US" sz="2000" dirty="0"/>
+              <a:t> (*pipeline with flowchart)</a:t>
+            </a:r>
+          </a:p>
+          <a:p>
+            <a:pPr lvl="2"/>
+            <a:r>
+              <a:rPr lang="en-US" sz="1600" dirty="0"/>
+              <a:t>Functions/core/subscore.py</a:t>
+            </a:r>
+          </a:p>
+          <a:p>
+            <a:pPr lvl="2"/>
+            <a:r>
+              <a:rPr lang="en-US" sz="1600" dirty="0"/>
+              <a:t>Pipeline_3_gold_validate.py</a:t>
+            </a:r>
+          </a:p>
+          <a:p>
+            <a:pPr lvl="1"/>
+            <a:r>
+              <a:rPr lang="en-US" sz="2000" dirty="0">
+                <a:solidFill>
+                  <a:schemeClr val="tx2">
+                    <a:lumMod val="50000"/>
+                    <a:lumOff val="50000"/>
+                  </a:schemeClr>
+                </a:solidFill>
+              </a:rPr>
+              <a:t>Align with shin about How vector embedding should be</a:t>
+            </a:r>
+          </a:p>
+          <a:p>
+            <a:pPr lvl="1"/>
+            <a:r>
+              <a:rPr lang="en-US" sz="2000" dirty="0">
+                <a:solidFill>
+                  <a:schemeClr val="tx2">
+                    <a:lumMod val="50000"/>
+                    <a:lumOff val="50000"/>
+                  </a:schemeClr>
+                </a:solidFill>
+              </a:rPr>
+              <a:t>Plan tasks for Sprint 11 in Jira</a:t>
+            </a:r>
+            <a:endParaRPr lang="th-TH" sz="2000" dirty="0">
+              <a:solidFill>
+                <a:schemeClr val="tx2">
+                  <a:lumMod val="50000"/>
+                  <a:lumOff val="50000"/>
+                </a:schemeClr>
+              </a:solidFill>
+            </a:endParaRPr>
+          </a:p>
+          <a:p>
+            <a:pPr lvl="1"/>
+            <a:r>
+              <a:rPr lang="en-US" sz="2000" dirty="0"/>
+              <a:t>Update GCS Retrieval class with new 3 conditions</a:t>
+            </a:r>
+          </a:p>
+          <a:p>
+            <a:pPr lvl="1"/>
+            <a:r>
+              <a:rPr lang="en-US" sz="2000" dirty="0"/>
+              <a:t>Update Embedding vector with shin format style</a:t>
+            </a:r>
+          </a:p>
+          <a:p>
+            <a:pPr lvl="1"/>
+            <a:r>
+              <a:rPr lang="en-US" sz="2000" dirty="0"/>
+              <a:t>Develop pipeline to bundle data for each student (Pipeline_2_user_hyde_refresh.py)</a:t>
+            </a:r>
+          </a:p>
+          <a:p>
+            <a:r>
+              <a:rPr lang="en-US" sz="2400" dirty="0"/>
+              <a:t>Issue</a:t>
+            </a:r>
+          </a:p>
+          <a:p>
+            <a:pPr lvl="1"/>
+            <a:r>
+              <a:rPr lang="en-US" sz="2000" dirty="0"/>
+              <a:t>Question in Slack</a:t>
+            </a:r>
+          </a:p>
+          <a:p>
+            <a:pPr lvl="1"/>
+            <a:r>
+              <a:rPr lang="en-US" sz="2000" dirty="0"/>
+              <a:t>Question in Figma</a:t>
+            </a:r>
+          </a:p>
+          <a:p>
+            <a:endParaRPr lang="en-US" sz="2400" dirty="0"/>
+          </a:p>
+          <a:p>
+            <a:pPr lvl="1"/>
+            <a:endParaRPr lang="en-US" sz="2000" dirty="0"/>
+          </a:p>
+        </p:txBody>
+      </p:sp>
+    </p:spTree>
+    <p:extLst>
+      <p:ext uri="{BB962C8B-B14F-4D97-AF65-F5344CB8AC3E}">
+        <p14:creationId xmlns:p14="http://schemas.microsoft.com/office/powerpoint/2010/main" val="1712727689"/>
+      </p:ext>
+    </p:extLst>
+  </p:cSld>
+  <p:clrMapOvr>
+    <a:masterClrMapping/>
+  </p:clrMapOvr>
+</p:sld>
+</file>
+
+<file path=ppt/slides/slide22.xml><?xml version="1.0" encoding="utf-8"?>
+<p:sld xmlns:a="http://schemas.openxmlformats.org/drawingml/2006/main" xmlns:r="http://schemas.openxmlformats.org/officeDocument/2006/relationships" xmlns:p="http://schemas.openxmlformats.org/presentationml/2006/main">
+  <p:cSld>
+    <p:spTree>
+      <p:nvGrpSpPr>
+        <p:cNvPr id="1" name="">
+          <a:extLst>
+            <a:ext uri="{FF2B5EF4-FFF2-40B4-BE49-F238E27FC236}">
+              <a16:creationId xmlns:a16="http://schemas.microsoft.com/office/drawing/2014/main" id="{3B73CD7D-98B3-51A9-3D8E-296579E163CD}"/>
+            </a:ext>
+          </a:extLst>
+        </p:cNvPr>
+        <p:cNvGrpSpPr/>
+        <p:nvPr/>
+      </p:nvGrpSpPr>
+      <p:grpSpPr>
+        <a:xfrm>
+          <a:off x="0" y="0"/>
+          <a:ext cx="0" cy="0"/>
+          <a:chOff x="0" y="0"/>
+          <a:chExt cx="0" cy="0"/>
+        </a:xfrm>
+      </p:grpSpPr>
+      <p:sp>
+        <p:nvSpPr>
+          <p:cNvPr id="2" name="Title 1">
+            <a:extLst>
+              <a:ext uri="{FF2B5EF4-FFF2-40B4-BE49-F238E27FC236}">
+                <a16:creationId xmlns:a16="http://schemas.microsoft.com/office/drawing/2014/main" id="{FE93B09D-2D52-E43E-C6CF-3CA0AC97EFE4}"/>
+              </a:ext>
+            </a:extLst>
+          </p:cNvPr>
+          <p:cNvSpPr>
+            <a:spLocks noGrp="1"/>
+          </p:cNvSpPr>
+          <p:nvPr>
+            <p:ph type="title"/>
+          </p:nvPr>
+        </p:nvSpPr>
+        <p:spPr>
+          <a:xfrm>
+            <a:off x="838200" y="365126"/>
+            <a:ext cx="10515600" cy="1126050"/>
+          </a:xfrm>
+        </p:spPr>
+        <p:txBody>
+          <a:bodyPr>
+            <a:normAutofit/>
+          </a:bodyPr>
+          <a:lstStyle/>
+          <a:p>
+            <a:r>
+              <a:rPr lang="en-US" dirty="0"/>
+              <a:t>Wed,040226</a:t>
+            </a:r>
+          </a:p>
+        </p:txBody>
+      </p:sp>
+      <p:sp>
+        <p:nvSpPr>
+          <p:cNvPr id="4" name="Content Placeholder 3">
+            <a:extLst>
+              <a:ext uri="{FF2B5EF4-FFF2-40B4-BE49-F238E27FC236}">
+                <a16:creationId xmlns:a16="http://schemas.microsoft.com/office/drawing/2014/main" id="{7D455007-E3D6-B60F-1520-AE698CA873D1}"/>
+              </a:ext>
+            </a:extLst>
+          </p:cNvPr>
+          <p:cNvSpPr>
+            <a:spLocks noGrp="1"/>
+          </p:cNvSpPr>
+          <p:nvPr>
+            <p:ph idx="1"/>
+          </p:nvPr>
+        </p:nvSpPr>
+        <p:spPr>
+          <a:xfrm>
+            <a:off x="838200" y="1491175"/>
+            <a:ext cx="6477000" cy="4867422"/>
+          </a:xfrm>
+        </p:spPr>
+        <p:txBody>
+          <a:bodyPr>
+            <a:normAutofit/>
+          </a:bodyPr>
+          <a:lstStyle/>
+          <a:p>
+            <a:r>
+              <a:rPr lang="en-US" dirty="0"/>
+              <a:t>Done</a:t>
+            </a:r>
+          </a:p>
+          <a:p>
+            <a:pPr lvl="1"/>
+            <a:r>
+              <a:rPr lang="en-US" dirty="0"/>
+              <a:t>Sprint review deck for Sprint 10</a:t>
+            </a:r>
+          </a:p>
+          <a:p>
+            <a:pPr lvl="1"/>
+            <a:r>
+              <a:rPr lang="en-US" dirty="0"/>
+              <a:t>Develop an endpoint to query data from Cloud Storage</a:t>
+            </a:r>
+          </a:p>
+          <a:p>
+            <a:r>
+              <a:rPr lang="en-US" dirty="0"/>
+              <a:t>Todo</a:t>
+            </a:r>
+          </a:p>
+          <a:p>
+            <a:pPr lvl="1"/>
+            <a:r>
+              <a:rPr lang="en-US" dirty="0"/>
+              <a:t>Read and understood the QA Test Plan for the CV Evaluation Pipeline link</a:t>
+            </a:r>
+          </a:p>
+          <a:p>
+            <a:pPr lvl="1"/>
+            <a:r>
+              <a:rPr lang="en-US" dirty="0"/>
+              <a:t>Plan tasks for Sprint 11 in Jira</a:t>
+            </a:r>
+          </a:p>
+          <a:p>
+            <a:pPr lvl="1"/>
+            <a:r>
+              <a:rPr lang="en-US" dirty="0"/>
+              <a:t>Develop pipeline to bundle data for each student (Pipeline_2_user_hyde_refresh.py)</a:t>
+            </a:r>
+          </a:p>
+          <a:p>
+            <a:r>
+              <a:rPr lang="en-US" dirty="0"/>
+              <a:t>Issue</a:t>
+            </a:r>
+          </a:p>
+          <a:p>
+            <a:pPr lvl="1"/>
+            <a:r>
+              <a:rPr lang="en-US" dirty="0"/>
+              <a:t> -</a:t>
+            </a:r>
+          </a:p>
+          <a:p>
+            <a:endParaRPr lang="en-US" dirty="0"/>
+          </a:p>
+          <a:p>
+            <a:pPr lvl="1"/>
+            <a:endParaRPr lang="en-US" dirty="0"/>
+          </a:p>
+        </p:txBody>
+      </p:sp>
+      <p:pic>
+        <p:nvPicPr>
+          <p:cNvPr id="5" name="Picture 4">
+            <a:extLst>
+              <a:ext uri="{FF2B5EF4-FFF2-40B4-BE49-F238E27FC236}">
+                <a16:creationId xmlns:a16="http://schemas.microsoft.com/office/drawing/2014/main" id="{B59F566A-B162-9099-425A-040887AEE44B}"/>
+              </a:ext>
+            </a:extLst>
+          </p:cNvPr>
+          <p:cNvPicPr>
+            <a:picLocks noChangeAspect="1"/>
+          </p:cNvPicPr>
+          <p:nvPr/>
+        </p:nvPicPr>
+        <p:blipFill>
+          <a:blip r:embed="rId2"/>
+          <a:stretch>
+            <a:fillRect/>
+          </a:stretch>
+        </p:blipFill>
+        <p:spPr>
+          <a:xfrm>
+            <a:off x="8335076" y="365125"/>
+            <a:ext cx="2757477" cy="6323428"/>
+          </a:xfrm>
+          <a:prstGeom prst="rect">
+            <a:avLst/>
+          </a:prstGeom>
+        </p:spPr>
+      </p:pic>
+    </p:spTree>
+    <p:extLst>
+      <p:ext uri="{BB962C8B-B14F-4D97-AF65-F5344CB8AC3E}">
+        <p14:creationId xmlns:p14="http://schemas.microsoft.com/office/powerpoint/2010/main" val="2789201605"/>
+      </p:ext>
+    </p:extLst>
+  </p:cSld>
+  <p:clrMapOvr>
+    <a:masterClrMapping/>
+  </p:clrMapOvr>
+</p:sld>
+</file>
+
+<file path=ppt/slides/slide23.xml><?xml version="1.0" encoding="utf-8"?>
+<p:sld xmlns:a="http://schemas.openxmlformats.org/drawingml/2006/main" xmlns:r="http://schemas.openxmlformats.org/officeDocument/2006/relationships" xmlns:p="http://schemas.openxmlformats.org/presentationml/2006/main">
+  <p:cSld>
+    <p:spTree>
+      <p:nvGrpSpPr>
+        <p:cNvPr id="1" name="">
+          <a:extLst>
+            <a:ext uri="{FF2B5EF4-FFF2-40B4-BE49-F238E27FC236}">
+              <a16:creationId xmlns:a16="http://schemas.microsoft.com/office/drawing/2014/main" id="{093446A3-8D06-E2BD-3022-2CE52E77AB1B}"/>
+            </a:ext>
+          </a:extLst>
+        </p:cNvPr>
+        <p:cNvGrpSpPr/>
+        <p:nvPr/>
+      </p:nvGrpSpPr>
+      <p:grpSpPr>
+        <a:xfrm>
+          <a:off x="0" y="0"/>
+          <a:ext cx="0" cy="0"/>
+          <a:chOff x="0" y="0"/>
+          <a:chExt cx="0" cy="0"/>
+        </a:xfrm>
+      </p:grpSpPr>
+      <p:sp>
+        <p:nvSpPr>
+          <p:cNvPr id="2" name="Title 1">
+            <a:extLst>
+              <a:ext uri="{FF2B5EF4-FFF2-40B4-BE49-F238E27FC236}">
+                <a16:creationId xmlns:a16="http://schemas.microsoft.com/office/drawing/2014/main" id="{A2167554-4189-3912-5DD1-B564582E8F20}"/>
+              </a:ext>
+            </a:extLst>
+          </p:cNvPr>
+          <p:cNvSpPr>
+            <a:spLocks noGrp="1"/>
+          </p:cNvSpPr>
+          <p:nvPr>
+            <p:ph type="title"/>
+          </p:nvPr>
+        </p:nvSpPr>
+        <p:spPr>
+          <a:xfrm>
+            <a:off x="838200" y="365126"/>
+            <a:ext cx="10515600" cy="1126050"/>
+          </a:xfrm>
+        </p:spPr>
+        <p:txBody>
+          <a:bodyPr>
+            <a:normAutofit/>
+          </a:bodyPr>
+          <a:lstStyle/>
+          <a:p>
+            <a:r>
+              <a:rPr lang="en-US" dirty="0"/>
+              <a:t>Tue,050226</a:t>
+            </a:r>
+          </a:p>
+        </p:txBody>
+      </p:sp>
+      <p:sp>
+        <p:nvSpPr>
+          <p:cNvPr id="4" name="Content Placeholder 3">
+            <a:extLst>
+              <a:ext uri="{FF2B5EF4-FFF2-40B4-BE49-F238E27FC236}">
+                <a16:creationId xmlns:a16="http://schemas.microsoft.com/office/drawing/2014/main" id="{2D7CABDD-1BA0-72C5-A353-2A5C1F281EFE}"/>
+              </a:ext>
+            </a:extLst>
+          </p:cNvPr>
+          <p:cNvSpPr>
+            <a:spLocks noGrp="1"/>
+          </p:cNvSpPr>
+          <p:nvPr>
+            <p:ph idx="1"/>
+          </p:nvPr>
+        </p:nvSpPr>
+        <p:spPr>
+          <a:xfrm>
+            <a:off x="838200" y="1491175"/>
+            <a:ext cx="10515600" cy="4867422"/>
+          </a:xfrm>
+        </p:spPr>
+        <p:txBody>
+          <a:bodyPr>
+            <a:normAutofit/>
+          </a:bodyPr>
+          <a:lstStyle/>
+          <a:p>
+            <a:r>
+              <a:rPr lang="en-US" dirty="0"/>
+              <a:t>Done</a:t>
+            </a:r>
+          </a:p>
+          <a:p>
+            <a:pPr lvl="1"/>
+            <a:r>
+              <a:rPr lang="en-US" dirty="0"/>
+              <a:t>Read and understood the QA Test Plan for the CV Evaluation Pipeline link</a:t>
+            </a:r>
+          </a:p>
+          <a:p>
+            <a:r>
+              <a:rPr lang="en-US" dirty="0"/>
+              <a:t>Todo</a:t>
+            </a:r>
+          </a:p>
+          <a:p>
+            <a:pPr lvl="1"/>
+            <a:r>
+              <a:rPr lang="en-US" dirty="0"/>
+              <a:t>Plan tasks for Sprint 11 in Jira</a:t>
+            </a:r>
+          </a:p>
+          <a:p>
+            <a:pPr lvl="1"/>
+            <a:r>
+              <a:rPr lang="en-US" dirty="0"/>
+              <a:t>Develop pipeline to bundle data for each student (Pipeline_2_user_hyde_refresh.py)</a:t>
+            </a:r>
+          </a:p>
+          <a:p>
+            <a:r>
+              <a:rPr lang="en-US" dirty="0"/>
+              <a:t>Issue</a:t>
+            </a:r>
+          </a:p>
+          <a:p>
+            <a:pPr lvl="1"/>
+            <a:r>
+              <a:rPr lang="en-US" dirty="0"/>
+              <a:t> -</a:t>
+            </a:r>
+          </a:p>
+          <a:p>
+            <a:endParaRPr lang="en-US" dirty="0"/>
+          </a:p>
+          <a:p>
+            <a:pPr lvl="1"/>
+            <a:endParaRPr lang="en-US" dirty="0"/>
+          </a:p>
+        </p:txBody>
+      </p:sp>
+    </p:spTree>
+    <p:extLst>
+      <p:ext uri="{BB962C8B-B14F-4D97-AF65-F5344CB8AC3E}">
+        <p14:creationId xmlns:p14="http://schemas.microsoft.com/office/powerpoint/2010/main" val="2709007082"/>
+      </p:ext>
+    </p:extLst>
+  </p:cSld>
+  <p:clrMapOvr>
+    <a:masterClrMapping/>
+  </p:clrMapOvr>
+</p:sld>
+</file>
+
+<file path=ppt/slides/slide24.xml><?xml version="1.0" encoding="utf-8"?>
+<p:sld xmlns:a="http://schemas.openxmlformats.org/drawingml/2006/main" xmlns:r="http://schemas.openxmlformats.org/officeDocument/2006/relationships" xmlns:p="http://schemas.openxmlformats.org/presentationml/2006/main">
+  <p:cSld>
+    <p:bg>
+      <p:bgPr>
+        <a:solidFill>
+          <a:schemeClr val="bg1"/>
+        </a:solidFill>
+        <a:effectLst/>
+      </p:bgPr>
+    </p:bg>
+    <p:spTree>
+      <p:nvGrpSpPr>
+        <p:cNvPr id="1" name="">
+          <a:extLst>
+            <a:ext uri="{FF2B5EF4-FFF2-40B4-BE49-F238E27FC236}">
+              <a16:creationId xmlns:a16="http://schemas.microsoft.com/office/drawing/2014/main" id="{85EBE9D7-86D7-D016-EC91-308E146DBC95}"/>
+            </a:ext>
+          </a:extLst>
+        </p:cNvPr>
+        <p:cNvGrpSpPr/>
+        <p:nvPr/>
+      </p:nvGrpSpPr>
+      <p:grpSpPr>
+        <a:xfrm>
+          <a:off x="0" y="0"/>
+          <a:ext cx="0" cy="0"/>
+          <a:chOff x="0" y="0"/>
+          <a:chExt cx="0" cy="0"/>
+        </a:xfrm>
+      </p:grpSpPr>
+      <p:pic>
+        <p:nvPicPr>
+          <p:cNvPr id="3" name="Picture 2">
+            <a:extLst>
+              <a:ext uri="{FF2B5EF4-FFF2-40B4-BE49-F238E27FC236}">
+                <a16:creationId xmlns:a16="http://schemas.microsoft.com/office/drawing/2014/main" id="{8DA36735-67FC-AD35-8BC4-EC837B910CEB}"/>
+              </a:ext>
+            </a:extLst>
+          </p:cNvPr>
+          <p:cNvPicPr>
+            <a:picLocks noChangeAspect="1"/>
+          </p:cNvPicPr>
+          <p:nvPr/>
+        </p:nvPicPr>
+        <p:blipFill>
+          <a:blip r:embed="rId3"/>
+          <a:stretch>
+            <a:fillRect/>
+          </a:stretch>
+        </p:blipFill>
+        <p:spPr>
+          <a:xfrm>
+            <a:off x="357040" y="1962895"/>
+            <a:ext cx="1704935" cy="528254"/>
+          </a:xfrm>
+          <a:prstGeom prst="rect">
+            <a:avLst/>
+          </a:prstGeom>
+        </p:spPr>
+      </p:pic>
+      <p:sp>
+        <p:nvSpPr>
+          <p:cNvPr id="6" name="Title 1">
+            <a:extLst>
+              <a:ext uri="{FF2B5EF4-FFF2-40B4-BE49-F238E27FC236}">
+                <a16:creationId xmlns:a16="http://schemas.microsoft.com/office/drawing/2014/main" id="{A19E6855-EEF6-5783-F577-649B02043E73}"/>
+              </a:ext>
+            </a:extLst>
+          </p:cNvPr>
+          <p:cNvSpPr txBox="1">
+            <a:spLocks/>
+          </p:cNvSpPr>
+          <p:nvPr/>
+        </p:nvSpPr>
+        <p:spPr>
+          <a:xfrm>
+            <a:off x="-343093" y="382201"/>
+            <a:ext cx="7631973" cy="528254"/>
+          </a:xfrm>
+          <a:prstGeom prst="rect">
+            <a:avLst/>
+          </a:prstGeom>
+        </p:spPr>
+        <p:txBody>
+          <a:bodyPr vert="horz" lIns="91440" tIns="45720" rIns="91440" bIns="45720" rtlCol="0" anchor="ctr">
+            <a:noAutofit/>
+          </a:bodyPr>
+          <a:lstStyle>
+            <a:lvl1pPr algn="ctr" defTabSz="914400" rtl="0" eaLnBrk="1" latinLnBrk="0" hangingPunct="1">
+              <a:lnSpc>
+                <a:spcPct val="90000"/>
+              </a:lnSpc>
+              <a:spcBef>
+                <a:spcPct val="0"/>
+              </a:spcBef>
+              <a:buNone/>
+              <a:defRPr sz="6000" kern="1200">
+                <a:solidFill>
+                  <a:schemeClr val="tx1"/>
+                </a:solidFill>
+                <a:latin typeface="+mj-lt"/>
+                <a:ea typeface="+mj-ea"/>
+                <a:cs typeface="+mj-cs"/>
+              </a:defRPr>
+            </a:lvl1pPr>
+          </a:lstStyle>
+          <a:p>
+            <a:r>
+              <a:rPr lang="en-US" sz="2400" dirty="0" err="1">
+                <a:cs typeface="Poppins Light"/>
+              </a:rPr>
+              <a:t>HyDE</a:t>
+            </a:r>
+            <a:r>
+              <a:rPr lang="en-US" sz="2400" dirty="0">
+                <a:cs typeface="Poppins Light"/>
+              </a:rPr>
+              <a:t> Feed Recommendation - </a:t>
+            </a:r>
+            <a:r>
+              <a:rPr lang="en-TH" sz="2400" dirty="0"/>
+              <a:t>System Overview</a:t>
+            </a:r>
+            <a:endParaRPr lang="en-US" sz="2400" dirty="0">
+              <a:cs typeface="Poppins Light"/>
+            </a:endParaRPr>
+          </a:p>
+        </p:txBody>
+      </p:sp>
+      <p:pic>
+        <p:nvPicPr>
+          <p:cNvPr id="7" name="Picture 6">
+            <a:extLst>
+              <a:ext uri="{FF2B5EF4-FFF2-40B4-BE49-F238E27FC236}">
+                <a16:creationId xmlns:a16="http://schemas.microsoft.com/office/drawing/2014/main" id="{4155D806-6B92-7201-74D6-BE2CD15D10FA}"/>
+              </a:ext>
+            </a:extLst>
+          </p:cNvPr>
+          <p:cNvPicPr>
+            <a:picLocks noChangeAspect="1"/>
+          </p:cNvPicPr>
+          <p:nvPr/>
+        </p:nvPicPr>
+        <p:blipFill>
+          <a:blip r:embed="rId4"/>
+          <a:stretch>
+            <a:fillRect/>
+          </a:stretch>
+        </p:blipFill>
+        <p:spPr>
+          <a:xfrm>
+            <a:off x="1024591" y="2933708"/>
+            <a:ext cx="4034790" cy="3126434"/>
+          </a:xfrm>
+          <a:prstGeom prst="rect">
+            <a:avLst/>
+          </a:prstGeom>
+        </p:spPr>
+      </p:pic>
+      <p:pic>
+        <p:nvPicPr>
+          <p:cNvPr id="8" name="Picture 4" descr="FastAPI · GitHub">
+            <a:extLst>
+              <a:ext uri="{FF2B5EF4-FFF2-40B4-BE49-F238E27FC236}">
+                <a16:creationId xmlns:a16="http://schemas.microsoft.com/office/drawing/2014/main" id="{054BDE27-EEAE-BF52-A6C1-4EF52174D6F1}"/>
+              </a:ext>
+            </a:extLst>
+          </p:cNvPr>
+          <p:cNvPicPr>
+            <a:picLocks noChangeAspect="1" noChangeArrowheads="1"/>
+          </p:cNvPicPr>
+          <p:nvPr/>
+        </p:nvPicPr>
+        <p:blipFill>
+          <a:blip r:embed="rId5">
+            <a:extLst>
+              <a:ext uri="{28A0092B-C50C-407E-A947-70E740481C1C}">
+                <a14:useLocalDpi xmlns:a14="http://schemas.microsoft.com/office/drawing/2010/main" val="0"/>
+              </a:ext>
+            </a:extLst>
+          </a:blip>
+          <a:srcRect/>
+          <a:stretch>
+            <a:fillRect/>
+          </a:stretch>
+        </p:blipFill>
+        <p:spPr bwMode="auto">
+          <a:xfrm>
+            <a:off x="5957666" y="2763393"/>
+            <a:ext cx="1331214" cy="1331214"/>
+          </a:xfrm>
+          <a:prstGeom prst="rect">
+            <a:avLst/>
+          </a:prstGeom>
+          <a:noFill/>
+          <a:extLst>
+            <a:ext uri="{909E8E84-426E-40DD-AFC4-6F175D3DCCD1}">
+              <a14:hiddenFill xmlns:a14="http://schemas.microsoft.com/office/drawing/2010/main">
+                <a:solidFill>
+                  <a:srgbClr val="FFFFFF"/>
+                </a:solidFill>
+              </a14:hiddenFill>
+            </a:ext>
+          </a:extLst>
+        </p:spPr>
+      </p:pic>
+      <p:cxnSp>
+        <p:nvCxnSpPr>
+          <p:cNvPr id="17" name="Straight Arrow Connector 16">
+            <a:extLst>
+              <a:ext uri="{FF2B5EF4-FFF2-40B4-BE49-F238E27FC236}">
+                <a16:creationId xmlns:a16="http://schemas.microsoft.com/office/drawing/2014/main" id="{A66DE43A-CF1E-6357-A4CA-3D74CE8527BF}"/>
+              </a:ext>
+            </a:extLst>
+          </p:cNvPr>
+          <p:cNvCxnSpPr>
+            <a:cxnSpLocks/>
+          </p:cNvCxnSpPr>
+          <p:nvPr/>
+        </p:nvCxnSpPr>
+        <p:spPr>
+          <a:xfrm>
+            <a:off x="5334118" y="3429000"/>
+            <a:ext cx="272106" cy="0"/>
+          </a:xfrm>
+          <a:prstGeom prst="straightConnector1">
+            <a:avLst/>
+          </a:prstGeom>
+          <a:ln w="12700">
+            <a:solidFill>
+              <a:srgbClr val="C00000"/>
+            </a:solidFill>
+            <a:tailEnd type="triangle"/>
+          </a:ln>
+        </p:spPr>
+        <p:style>
+          <a:lnRef idx="2">
+            <a:schemeClr val="dk1"/>
+          </a:lnRef>
+          <a:fillRef idx="0">
+            <a:schemeClr val="dk1"/>
+          </a:fillRef>
+          <a:effectRef idx="1">
+            <a:schemeClr val="dk1"/>
+          </a:effectRef>
+          <a:fontRef idx="minor">
+            <a:schemeClr val="tx1"/>
+          </a:fontRef>
+        </p:style>
+      </p:cxnSp>
+      <p:cxnSp>
+        <p:nvCxnSpPr>
+          <p:cNvPr id="18" name="Straight Arrow Connector 17">
+            <a:extLst>
+              <a:ext uri="{FF2B5EF4-FFF2-40B4-BE49-F238E27FC236}">
+                <a16:creationId xmlns:a16="http://schemas.microsoft.com/office/drawing/2014/main" id="{29668BA2-F026-7DC9-9B93-3EDDA3A40CE1}"/>
+              </a:ext>
+            </a:extLst>
+          </p:cNvPr>
+          <p:cNvCxnSpPr>
+            <a:cxnSpLocks/>
+          </p:cNvCxnSpPr>
+          <p:nvPr/>
+        </p:nvCxnSpPr>
+        <p:spPr>
+          <a:xfrm>
+            <a:off x="7484130" y="3429000"/>
+            <a:ext cx="272106" cy="0"/>
+          </a:xfrm>
+          <a:prstGeom prst="straightConnector1">
+            <a:avLst/>
+          </a:prstGeom>
+          <a:ln w="12700">
+            <a:solidFill>
+              <a:srgbClr val="C00000"/>
+            </a:solidFill>
+            <a:tailEnd type="triangle"/>
+          </a:ln>
+        </p:spPr>
+        <p:style>
+          <a:lnRef idx="2">
+            <a:schemeClr val="dk1"/>
+          </a:lnRef>
+          <a:fillRef idx="0">
+            <a:schemeClr val="dk1"/>
+          </a:fillRef>
+          <a:effectRef idx="1">
+            <a:schemeClr val="dk1"/>
+          </a:effectRef>
+          <a:fontRef idx="minor">
+            <a:schemeClr val="tx1"/>
+          </a:fontRef>
+        </p:style>
+      </p:cxnSp>
+      <p:pic>
+        <p:nvPicPr>
+          <p:cNvPr id="19" name="Picture 18">
+            <a:extLst>
+              <a:ext uri="{FF2B5EF4-FFF2-40B4-BE49-F238E27FC236}">
+                <a16:creationId xmlns:a16="http://schemas.microsoft.com/office/drawing/2014/main" id="{6BF387B3-2E8B-2A05-5A54-4C9508B25B6B}"/>
+              </a:ext>
+            </a:extLst>
+          </p:cNvPr>
+          <p:cNvPicPr>
+            <a:picLocks noChangeAspect="1"/>
+          </p:cNvPicPr>
+          <p:nvPr/>
+        </p:nvPicPr>
+        <p:blipFill>
+          <a:blip r:embed="rId6"/>
+          <a:stretch>
+            <a:fillRect/>
+          </a:stretch>
+        </p:blipFill>
+        <p:spPr>
+          <a:xfrm>
+            <a:off x="8187165" y="267286"/>
+            <a:ext cx="2757477" cy="6323428"/>
+          </a:xfrm>
+          <a:prstGeom prst="rect">
+            <a:avLst/>
+          </a:prstGeom>
+        </p:spPr>
+      </p:pic>
+      <p:sp>
+        <p:nvSpPr>
+          <p:cNvPr id="21" name="TextBox 20">
+            <a:extLst>
+              <a:ext uri="{FF2B5EF4-FFF2-40B4-BE49-F238E27FC236}">
+                <a16:creationId xmlns:a16="http://schemas.microsoft.com/office/drawing/2014/main" id="{61EAE8BC-BC2C-6A78-EE1F-556BBA1B5564}"/>
+              </a:ext>
+            </a:extLst>
+          </p:cNvPr>
+          <p:cNvSpPr txBox="1"/>
+          <p:nvPr/>
+        </p:nvSpPr>
+        <p:spPr>
+          <a:xfrm>
+            <a:off x="357040" y="1021227"/>
+            <a:ext cx="6958965" cy="1631394"/>
+          </a:xfrm>
+          <a:prstGeom prst="roundRect">
+            <a:avLst>
+              <a:gd name="adj" fmla="val 4406"/>
+            </a:avLst>
+          </a:prstGeom>
+          <a:solidFill>
+            <a:srgbClr val="E96060"/>
+          </a:solidFill>
+        </p:spPr>
+        <p:txBody>
+          <a:bodyPr wrap="square" rtlCol="0">
+            <a:spAutoFit/>
+          </a:bodyPr>
+          <a:lstStyle/>
+          <a:p>
+            <a:r>
+              <a:rPr lang="en-US" sz="1400" dirty="0">
+                <a:latin typeface="Consolas" panose="020B0609020204030204" pitchFamily="49" charset="0"/>
+              </a:rPr>
+              <a:t>Case 1 : </a:t>
+            </a:r>
+            <a:r>
+              <a:rPr lang="th-TH" sz="1400" dirty="0">
+                <a:latin typeface="Consolas" panose="020B0609020204030204" pitchFamily="49" charset="0"/>
+              </a:rPr>
+              <a:t>เจอ </a:t>
+            </a:r>
+            <a:r>
+              <a:rPr lang="en-US" sz="1400" dirty="0" err="1">
+                <a:latin typeface="Consolas" panose="020B0609020204030204" pitchFamily="49" charset="0"/>
+              </a:rPr>
+              <a:t>bucget</a:t>
+            </a:r>
+            <a:r>
+              <a:rPr lang="en-US" sz="1400" dirty="0">
+                <a:latin typeface="Consolas" panose="020B0609020204030204" pitchFamily="49" charset="0"/>
+              </a:rPr>
+              <a:t> + metadata</a:t>
+            </a:r>
+          </a:p>
+          <a:p>
+            <a:r>
+              <a:rPr lang="en-US" sz="1400" dirty="0">
+                <a:latin typeface="Consolas" panose="020B0609020204030204" pitchFamily="49" charset="0"/>
+              </a:rPr>
+              <a:t>Case 2 : Storage(</a:t>
+            </a:r>
+            <a:r>
+              <a:rPr lang="en-US" sz="1400" dirty="0" err="1">
+                <a:latin typeface="Consolas" panose="020B0609020204030204" pitchFamily="49" charset="0"/>
+              </a:rPr>
+              <a:t>bugget</a:t>
+            </a:r>
+            <a:r>
+              <a:rPr lang="en-US" sz="1400" dirty="0">
+                <a:latin typeface="Consolas" panose="020B0609020204030204" pitchFamily="49" charset="0"/>
+              </a:rPr>
+              <a:t> x metadata)-&gt; return Only metadata</a:t>
+            </a:r>
+          </a:p>
+          <a:p>
+            <a:r>
+              <a:rPr lang="en-US" sz="1400" dirty="0">
+                <a:latin typeface="Consolas" panose="020B0609020204030204" pitchFamily="49" charset="0"/>
+              </a:rPr>
+              <a:t>Case 3 : Have no </a:t>
+            </a:r>
+            <a:r>
+              <a:rPr lang="en-US" sz="1400" dirty="0" err="1">
+                <a:latin typeface="Consolas" panose="020B0609020204030204" pitchFamily="49" charset="0"/>
+              </a:rPr>
+              <a:t>bugget</a:t>
+            </a:r>
+            <a:r>
+              <a:rPr lang="en-US" sz="1400" dirty="0">
+                <a:latin typeface="Consolas" panose="020B0609020204030204" pitchFamily="49" charset="0"/>
+              </a:rPr>
+              <a:t> -&gt; return data from </a:t>
+            </a:r>
+            <a:r>
+              <a:rPr lang="en-US" sz="1400" dirty="0" err="1">
+                <a:latin typeface="Consolas" panose="020B0609020204030204" pitchFamily="49" charset="0"/>
+              </a:rPr>
+              <a:t>bigquery</a:t>
+            </a:r>
+            <a:endParaRPr lang="en-US" sz="1400" dirty="0">
+              <a:latin typeface="Consolas" panose="020B0609020204030204" pitchFamily="49" charset="0"/>
+            </a:endParaRPr>
+          </a:p>
+          <a:p>
+            <a:r>
+              <a:rPr lang="en-US" sz="1400" dirty="0">
+                <a:latin typeface="Consolas" panose="020B0609020204030204" pitchFamily="49" charset="0"/>
+              </a:rPr>
+              <a:t>If case 2 or case 3 -&gt; talk with shin what going on?</a:t>
+            </a:r>
+          </a:p>
+          <a:p>
+            <a:endParaRPr lang="en-US" sz="1400" dirty="0">
+              <a:latin typeface="Consolas" panose="020B0609020204030204" pitchFamily="49" charset="0"/>
+            </a:endParaRPr>
+          </a:p>
+          <a:p>
+            <a:r>
+              <a:rPr lang="en-US" sz="1400" dirty="0">
+                <a:latin typeface="Consolas" panose="020B0609020204030204" pitchFamily="49" charset="0"/>
+              </a:rPr>
+              <a:t>If some vector is missing or not complete return only complete vector and other “error”</a:t>
+            </a:r>
+          </a:p>
+        </p:txBody>
+      </p:sp>
+    </p:spTree>
+    <p:extLst>
+      <p:ext uri="{BB962C8B-B14F-4D97-AF65-F5344CB8AC3E}">
+        <p14:creationId xmlns:p14="http://schemas.microsoft.com/office/powerpoint/2010/main" val="947446297"/>
+      </p:ext>
+    </p:extLst>
+  </p:cSld>
+  <p:clrMapOvr>
+    <a:masterClrMapping/>
+  </p:clrMapOvr>
+</p:sld>
+</file>
+
+<file path=ppt/slides/slide25.xml><?xml version="1.0" encoding="utf-8"?>
+<p:sld xmlns:a="http://schemas.openxmlformats.org/drawingml/2006/main" xmlns:r="http://schemas.openxmlformats.org/officeDocument/2006/relationships" xmlns:p="http://schemas.openxmlformats.org/presentationml/2006/main">
+  <p:cSld>
+    <p:spTree>
+      <p:nvGrpSpPr>
+        <p:cNvPr id="1" name="">
+          <a:extLst>
+            <a:ext uri="{FF2B5EF4-FFF2-40B4-BE49-F238E27FC236}">
+              <a16:creationId xmlns:a16="http://schemas.microsoft.com/office/drawing/2014/main" id="{F7DD16A6-5009-1697-C160-8AF6CDCAB466}"/>
+            </a:ext>
+          </a:extLst>
+        </p:cNvPr>
+        <p:cNvGrpSpPr/>
+        <p:nvPr/>
+      </p:nvGrpSpPr>
+      <p:grpSpPr>
+        <a:xfrm>
+          <a:off x="0" y="0"/>
+          <a:ext cx="0" cy="0"/>
+          <a:chOff x="0" y="0"/>
+          <a:chExt cx="0" cy="0"/>
+        </a:xfrm>
+      </p:grpSpPr>
+      <p:sp>
+        <p:nvSpPr>
+          <p:cNvPr id="2" name="Title 1">
+            <a:extLst>
+              <a:ext uri="{FF2B5EF4-FFF2-40B4-BE49-F238E27FC236}">
+                <a16:creationId xmlns:a16="http://schemas.microsoft.com/office/drawing/2014/main" id="{1A837164-399A-A263-CD90-2792F8A45107}"/>
+              </a:ext>
+            </a:extLst>
+          </p:cNvPr>
+          <p:cNvSpPr>
+            <a:spLocks noGrp="1"/>
+          </p:cNvSpPr>
+          <p:nvPr>
+            <p:ph type="title"/>
+          </p:nvPr>
+        </p:nvSpPr>
+        <p:spPr/>
+        <p:txBody>
+          <a:bodyPr>
+            <a:normAutofit/>
+          </a:bodyPr>
+          <a:lstStyle/>
+          <a:p>
+            <a:r>
+              <a:rPr lang="en-US" dirty="0"/>
+              <a:t>Tue,030226</a:t>
+            </a:r>
+          </a:p>
+        </p:txBody>
+      </p:sp>
+      <p:sp>
+        <p:nvSpPr>
+          <p:cNvPr id="4" name="Content Placeholder 3">
+            <a:extLst>
+              <a:ext uri="{FF2B5EF4-FFF2-40B4-BE49-F238E27FC236}">
+                <a16:creationId xmlns:a16="http://schemas.microsoft.com/office/drawing/2014/main" id="{B3196FA5-590C-C324-254E-A726932FE246}"/>
+              </a:ext>
+            </a:extLst>
+          </p:cNvPr>
+          <p:cNvSpPr>
+            <a:spLocks noGrp="1"/>
+          </p:cNvSpPr>
+          <p:nvPr>
+            <p:ph idx="1"/>
+          </p:nvPr>
+        </p:nvSpPr>
+        <p:spPr/>
+        <p:txBody>
+          <a:bodyPr/>
+          <a:lstStyle/>
+          <a:p>
+            <a:r>
+              <a:rPr lang="en-US" dirty="0"/>
+              <a:t>Done</a:t>
+            </a:r>
+          </a:p>
+          <a:p>
+            <a:pPr lvl="1"/>
+            <a:r>
+              <a:rPr lang="en-US" dirty="0"/>
+              <a:t>Prepared sprint review deck for Sprint 10</a:t>
+            </a:r>
+          </a:p>
+          <a:p>
+            <a:r>
+              <a:rPr lang="en-US" dirty="0"/>
+              <a:t>Todo</a:t>
+            </a:r>
+          </a:p>
+          <a:p>
+            <a:pPr lvl="1"/>
+            <a:r>
+              <a:rPr lang="en-US" dirty="0"/>
+              <a:t>Implement item retirement on Cloud Storage (code + </a:t>
+            </a:r>
+            <a:r>
+              <a:rPr lang="en-US" dirty="0" err="1"/>
+              <a:t>cron</a:t>
+            </a:r>
+            <a:r>
+              <a:rPr lang="en-US" dirty="0"/>
+              <a:t> job)</a:t>
+            </a:r>
+          </a:p>
+          <a:p>
+            <a:pPr lvl="1"/>
+            <a:r>
+              <a:rPr lang="en-US" dirty="0"/>
+              <a:t>Plan tasks for Sprint 11 in Jira</a:t>
+            </a:r>
+          </a:p>
+          <a:p>
+            <a:pPr lvl="1"/>
+            <a:r>
+              <a:rPr lang="en-US" dirty="0"/>
+              <a:t>Develop pipeline to bundle data for each student</a:t>
+            </a:r>
+          </a:p>
+          <a:p>
+            <a:pPr lvl="1"/>
+            <a:r>
+              <a:rPr lang="en-US" dirty="0"/>
+              <a:t>Read and understood the QA Test Plan for the CV Evaluation Pipeline link</a:t>
+            </a:r>
+          </a:p>
+          <a:p>
+            <a:pPr lvl="1"/>
+            <a:endParaRPr lang="en-US" dirty="0"/>
+          </a:p>
+          <a:p>
+            <a:endParaRPr lang="en-US" dirty="0"/>
+          </a:p>
+          <a:p>
+            <a:pPr lvl="1"/>
+            <a:endParaRPr lang="en-US" dirty="0"/>
+          </a:p>
+        </p:txBody>
+      </p:sp>
+    </p:spTree>
+    <p:extLst>
+      <p:ext uri="{BB962C8B-B14F-4D97-AF65-F5344CB8AC3E}">
+        <p14:creationId xmlns:p14="http://schemas.microsoft.com/office/powerpoint/2010/main" val="1507337214"/>
+      </p:ext>
+    </p:extLst>
+  </p:cSld>
+  <p:clrMapOvr>
+    <a:masterClrMapping/>
+  </p:clrMapOvr>
+</p:sld>
+</file>
+
+<file path=ppt/slides/slide26.xml><?xml version="1.0" encoding="utf-8"?>
+<p:sld xmlns:a="http://schemas.openxmlformats.org/drawingml/2006/main" xmlns:r="http://schemas.openxmlformats.org/officeDocument/2006/relationships" xmlns:p="http://schemas.openxmlformats.org/presentationml/2006/main">
+  <p:cSld>
+    <p:spTree>
+      <p:nvGrpSpPr>
+        <p:cNvPr id="1" name="">
+          <a:extLst>
+            <a:ext uri="{FF2B5EF4-FFF2-40B4-BE49-F238E27FC236}">
+              <a16:creationId xmlns:a16="http://schemas.microsoft.com/office/drawing/2014/main" id="{13678FBA-8682-67FB-7403-762F28E85AFF}"/>
+            </a:ext>
+          </a:extLst>
+        </p:cNvPr>
+        <p:cNvGrpSpPr/>
+        <p:nvPr/>
+      </p:nvGrpSpPr>
+      <p:grpSpPr>
+        <a:xfrm>
+          <a:off x="0" y="0"/>
+          <a:ext cx="0" cy="0"/>
+          <a:chOff x="0" y="0"/>
+          <a:chExt cx="0" cy="0"/>
+        </a:xfrm>
+      </p:grpSpPr>
+      <p:sp>
+        <p:nvSpPr>
+          <p:cNvPr id="4" name="Title 1">
+            <a:extLst>
+              <a:ext uri="{FF2B5EF4-FFF2-40B4-BE49-F238E27FC236}">
+                <a16:creationId xmlns:a16="http://schemas.microsoft.com/office/drawing/2014/main" id="{273BB931-0887-2834-8B68-DE9282036EA5}"/>
+              </a:ext>
+            </a:extLst>
+          </p:cNvPr>
+          <p:cNvSpPr txBox="1">
+            <a:spLocks/>
+          </p:cNvSpPr>
+          <p:nvPr/>
+        </p:nvSpPr>
+        <p:spPr>
+          <a:xfrm>
+            <a:off x="479425" y="3121223"/>
+            <a:ext cx="11233150" cy="615553"/>
+          </a:xfrm>
+          <a:prstGeom prst="rect">
+            <a:avLst/>
+          </a:prstGeom>
+        </p:spPr>
+        <p:txBody>
+          <a:bodyPr vert="horz" lIns="0" tIns="0" rIns="0" bIns="0" rtlCol="0" anchor="ctr">
+            <a:spAutoFit/>
+          </a:bodyPr>
+          <a:lstStyle>
+            <a:lvl1pPr algn="l" defTabSz="914400" rtl="0" eaLnBrk="1" latinLnBrk="0" hangingPunct="1">
+              <a:lnSpc>
+                <a:spcPct val="100000"/>
+              </a:lnSpc>
+              <a:spcBef>
+                <a:spcPct val="0"/>
+              </a:spcBef>
+              <a:spcAft>
+                <a:spcPts val="300"/>
+              </a:spcAft>
+              <a:buNone/>
+              <a:defRPr sz="3200" kern="1200">
+                <a:solidFill>
+                  <a:schemeClr val="tx1"/>
+                </a:solidFill>
+                <a:latin typeface="+mj-lt"/>
+                <a:ea typeface="+mj-ea"/>
+                <a:cs typeface="+mj-cs"/>
+                <a:sym typeface="Trebuchet MS" panose="020B0603020202020204" pitchFamily="34" charset="0"/>
+              </a:defRPr>
+            </a:lvl1pPr>
+          </a:lstStyle>
+          <a:p>
+            <a:pPr algn="ctr"/>
+            <a:r>
+              <a:rPr lang="en-US" sz="4000" b="1" dirty="0"/>
+              <a:t>Process of work</a:t>
+            </a:r>
+          </a:p>
+        </p:txBody>
+      </p:sp>
+      <p:sp>
+        <p:nvSpPr>
+          <p:cNvPr id="9" name="Title 1">
+            <a:extLst>
+              <a:ext uri="{FF2B5EF4-FFF2-40B4-BE49-F238E27FC236}">
+                <a16:creationId xmlns:a16="http://schemas.microsoft.com/office/drawing/2014/main" id="{A24781CD-06F9-A773-75B5-02AFD538D8FF}"/>
+              </a:ext>
+            </a:extLst>
+          </p:cNvPr>
+          <p:cNvSpPr txBox="1">
+            <a:spLocks/>
+          </p:cNvSpPr>
+          <p:nvPr/>
+        </p:nvSpPr>
+        <p:spPr>
+          <a:xfrm>
+            <a:off x="152399" y="5933461"/>
+            <a:ext cx="11820525" cy="229935"/>
+          </a:xfrm>
+          <a:prstGeom prst="rect">
+            <a:avLst/>
+          </a:prstGeom>
+        </p:spPr>
+        <p:txBody>
+          <a:bodyPr vert="horz" wrap="square" lIns="0" tIns="0" rIns="0" bIns="0" rtlCol="0" anchor="ctr">
+            <a:spAutoFit/>
+          </a:bodyPr>
+          <a:lstStyle>
+            <a:lvl1pPr algn="l" defTabSz="914400" rtl="0" eaLnBrk="1" latinLnBrk="0" hangingPunct="1">
+              <a:lnSpc>
+                <a:spcPct val="100000"/>
+              </a:lnSpc>
+              <a:spcBef>
+                <a:spcPct val="0"/>
+              </a:spcBef>
+              <a:spcAft>
+                <a:spcPts val="300"/>
+              </a:spcAft>
+              <a:buNone/>
+              <a:defRPr sz="3200" kern="1200">
+                <a:solidFill>
+                  <a:schemeClr val="tx1"/>
+                </a:solidFill>
+                <a:latin typeface="+mj-lt"/>
+                <a:ea typeface="+mj-ea"/>
+                <a:cs typeface="+mj-cs"/>
+                <a:sym typeface="Trebuchet MS" panose="020B0603020202020204" pitchFamily="34" charset="0"/>
+              </a:defRPr>
+            </a:lvl1pPr>
+          </a:lstStyle>
+          <a:p>
+            <a:pPr>
+              <a:lnSpc>
+                <a:spcPct val="150000"/>
+              </a:lnSpc>
+            </a:pPr>
+            <a:endParaRPr lang="en-US" sz="1100">
+              <a:solidFill>
+                <a:srgbClr val="0432FF"/>
+              </a:solidFill>
+            </a:endParaRPr>
+          </a:p>
+        </p:txBody>
+      </p:sp>
+    </p:spTree>
+    <p:extLst>
+      <p:ext uri="{BB962C8B-B14F-4D97-AF65-F5344CB8AC3E}">
+        <p14:creationId xmlns:p14="http://schemas.microsoft.com/office/powerpoint/2010/main" val="859127213"/>
+      </p:ext>
+    </p:extLst>
+  </p:cSld>
+  <p:clrMapOvr>
+    <a:masterClrMapping/>
+  </p:clrMapOvr>
+  <mc:AlternateContent xmlns:mc="http://schemas.openxmlformats.org/markup-compatibility/2006" xmlns:p14="http://schemas.microsoft.com/office/powerpoint/2010/main">
+    <mc:Choice Requires="p14">
+      <p:transition p14:dur="250">
+        <p:fade/>
+      </p:transition>
+    </mc:Choice>
+    <mc:Fallback xmlns="">
+      <p:transition>
+        <p:fade/>
+      </p:transition>
+    </mc:Fallback>
+  </mc:AlternateContent>
+</p:sld>
+</file>
+
+<file path=ppt/slides/slide27.xml><?xml version="1.0" encoding="utf-8"?>
+<p:sld xmlns:a="http://schemas.openxmlformats.org/drawingml/2006/main" xmlns:r="http://schemas.openxmlformats.org/officeDocument/2006/relationships" xmlns:p="http://schemas.openxmlformats.org/presentationml/2006/main">
+  <p:cSld>
+    <p:spTree>
+      <p:nvGrpSpPr>
+        <p:cNvPr id="1" name="">
+          <a:extLst>
+            <a:ext uri="{FF2B5EF4-FFF2-40B4-BE49-F238E27FC236}">
+              <a16:creationId xmlns:a16="http://schemas.microsoft.com/office/drawing/2014/main" id="{B2338AA2-1EF5-9E8F-CDFE-880FD0D6FC42}"/>
+            </a:ext>
+          </a:extLst>
+        </p:cNvPr>
+        <p:cNvGrpSpPr/>
+        <p:nvPr/>
+      </p:nvGrpSpPr>
+      <p:grpSpPr>
+        <a:xfrm>
+          <a:off x="0" y="0"/>
+          <a:ext cx="0" cy="0"/>
+          <a:chOff x="0" y="0"/>
+          <a:chExt cx="0" cy="0"/>
+        </a:xfrm>
+      </p:grpSpPr>
+      <p:sp>
+        <p:nvSpPr>
+          <p:cNvPr id="4" name="Content Placeholder 3">
+            <a:extLst>
+              <a:ext uri="{FF2B5EF4-FFF2-40B4-BE49-F238E27FC236}">
+                <a16:creationId xmlns:a16="http://schemas.microsoft.com/office/drawing/2014/main" id="{28AD12FB-CD52-6225-8CBA-0447DEC206BD}"/>
+              </a:ext>
+            </a:extLst>
+          </p:cNvPr>
+          <p:cNvSpPr>
+            <a:spLocks noGrp="1"/>
+          </p:cNvSpPr>
+          <p:nvPr>
+            <p:ph idx="1"/>
+          </p:nvPr>
+        </p:nvSpPr>
+        <p:spPr>
+          <a:xfrm>
+            <a:off x="838200" y="542925"/>
+            <a:ext cx="10515600" cy="5962650"/>
+          </a:xfrm>
+        </p:spPr>
+        <p:txBody>
+          <a:bodyPr>
+            <a:normAutofit fontScale="92500" lnSpcReduction="10000"/>
+          </a:bodyPr>
+          <a:lstStyle/>
+          <a:p>
+            <a:pPr marL="914400" lvl="1" indent="-457200">
+              <a:buAutoNum type="arabicPeriod"/>
+            </a:pPr>
+            <a:r>
+              <a:rPr lang="en-US" dirty="0"/>
+              <a:t>POC -&gt; MVP</a:t>
+            </a:r>
+            <a:br>
+              <a:rPr lang="th-TH" dirty="0"/>
+            </a:br>
+            <a:r>
+              <a:rPr lang="en-US" dirty="0"/>
+              <a:t>- POC : all full pipeline code</a:t>
+            </a:r>
+            <a:br>
+              <a:rPr lang="en-US" dirty="0"/>
+            </a:br>
+            <a:r>
+              <a:rPr lang="en-US" dirty="0"/>
+              <a:t>- MVP : POC + production plan + owner</a:t>
+            </a:r>
+          </a:p>
+          <a:p>
+            <a:pPr marL="914400" lvl="1" indent="-457200">
+              <a:buAutoNum type="arabicPeriod"/>
+            </a:pPr>
+            <a:r>
+              <a:rPr lang="en-US" dirty="0"/>
+              <a:t>Estimate cost man-day and </a:t>
+            </a:r>
+            <a:r>
+              <a:rPr lang="en-US"/>
+              <a:t>grant chart</a:t>
+            </a:r>
+            <a:br>
+              <a:rPr lang="en-US"/>
+            </a:br>
+            <a:endParaRPr lang="en-US" dirty="0"/>
+          </a:p>
+          <a:p>
+            <a:pPr lvl="1"/>
+            <a:r>
+              <a:rPr lang="en-US" dirty="0"/>
+              <a:t>1 Sprint = 2 weeks</a:t>
+            </a:r>
+          </a:p>
+          <a:p>
+            <a:pPr lvl="1"/>
+            <a:r>
+              <a:rPr lang="en-US" dirty="0"/>
+              <a:t>We have sprint glooming before sprint start</a:t>
+            </a:r>
+          </a:p>
+          <a:p>
+            <a:pPr lvl="1"/>
+            <a:r>
+              <a:rPr lang="en-US" dirty="0"/>
+              <a:t>We use Jira to estimate timeline and ticket</a:t>
+            </a:r>
+          </a:p>
+          <a:p>
+            <a:pPr lvl="1"/>
+            <a:r>
+              <a:rPr lang="en-US" dirty="0"/>
+              <a:t>There are </a:t>
+            </a:r>
+            <a:r>
+              <a:rPr lang="en-US" dirty="0" err="1"/>
+              <a:t>ghostdeck</a:t>
+            </a:r>
+            <a:endParaRPr lang="en-US" dirty="0"/>
+          </a:p>
+          <a:p>
+            <a:pPr lvl="1"/>
+            <a:r>
+              <a:rPr lang="en-US" dirty="0"/>
+              <a:t>There are confluence for project detail</a:t>
+            </a:r>
+          </a:p>
+          <a:p>
+            <a:pPr lvl="1"/>
+            <a:r>
+              <a:rPr lang="en-US" dirty="0"/>
+              <a:t>There are POC </a:t>
+            </a:r>
+            <a:endParaRPr lang="th-TH" dirty="0"/>
+          </a:p>
+          <a:p>
+            <a:pPr lvl="1"/>
+            <a:r>
+              <a:rPr lang="en-US" dirty="0"/>
+              <a:t>Estimate </a:t>
+            </a:r>
+            <a:r>
+              <a:rPr lang="en-US" dirty="0" err="1"/>
+              <a:t>manday</a:t>
+            </a:r>
+            <a:r>
+              <a:rPr lang="en-US" dirty="0"/>
+              <a:t> cost</a:t>
+            </a:r>
+          </a:p>
+          <a:p>
+            <a:pPr lvl="1"/>
+            <a:r>
+              <a:rPr lang="en-US" dirty="0"/>
+              <a:t>Design database</a:t>
+            </a:r>
+          </a:p>
+          <a:p>
+            <a:pPr lvl="1"/>
+            <a:r>
+              <a:rPr lang="en-US" dirty="0"/>
+              <a:t>Architecture</a:t>
+            </a:r>
+          </a:p>
+          <a:p>
+            <a:pPr lvl="1"/>
+            <a:r>
+              <a:rPr lang="en-US" dirty="0"/>
+              <a:t>RACI</a:t>
+            </a:r>
+          </a:p>
+          <a:p>
+            <a:pPr lvl="1"/>
+            <a:r>
+              <a:rPr lang="en-US" dirty="0"/>
+              <a:t>SIT </a:t>
+            </a:r>
+            <a:r>
+              <a:rPr lang="th-TH" dirty="0"/>
+              <a:t>เหลืออีก </a:t>
+            </a:r>
+            <a:r>
+              <a:rPr lang="en-US" dirty="0"/>
+              <a:t>4 </a:t>
+            </a:r>
+            <a:r>
+              <a:rPr lang="th-TH" dirty="0"/>
+              <a:t>เดือน เดือน </a:t>
+            </a:r>
+            <a:r>
+              <a:rPr lang="en-US" dirty="0" err="1"/>
+              <a:t>june</a:t>
+            </a:r>
+            <a:endParaRPr lang="th-TH" dirty="0"/>
+          </a:p>
+          <a:p>
+            <a:pPr lvl="1"/>
+            <a:r>
+              <a:rPr lang="en-US" dirty="0"/>
+              <a:t>UAT </a:t>
+            </a:r>
+            <a:r>
+              <a:rPr lang="th-TH" dirty="0"/>
+              <a:t>เหลืออีก </a:t>
+            </a:r>
+            <a:r>
+              <a:rPr lang="en-US" dirty="0"/>
+              <a:t>6 </a:t>
+            </a:r>
+            <a:r>
+              <a:rPr lang="th-TH" dirty="0"/>
+              <a:t>เดือน </a:t>
+            </a:r>
+            <a:r>
+              <a:rPr lang="en-US" dirty="0"/>
+              <a:t> </a:t>
+            </a:r>
+            <a:r>
+              <a:rPr lang="th-TH" dirty="0"/>
+              <a:t>เดือน สิงหา</a:t>
+            </a:r>
+            <a:endParaRPr lang="en-US" dirty="0"/>
+          </a:p>
+          <a:p>
+            <a:pPr lvl="1"/>
+            <a:r>
+              <a:rPr lang="en-US" dirty="0" err="1"/>
+              <a:t>Golive</a:t>
+            </a:r>
+            <a:r>
+              <a:rPr lang="en-US" dirty="0"/>
+              <a:t> </a:t>
+            </a:r>
+            <a:r>
+              <a:rPr lang="th-TH" dirty="0"/>
+              <a:t>เหลืออีก </a:t>
+            </a:r>
+            <a:r>
+              <a:rPr lang="en-US" dirty="0"/>
+              <a:t>… </a:t>
+            </a:r>
+            <a:r>
+              <a:rPr lang="th-TH" dirty="0"/>
+              <a:t>เดือน เดือน </a:t>
+            </a:r>
+            <a:r>
+              <a:rPr lang="en-US" dirty="0"/>
+              <a:t>October</a:t>
+            </a:r>
+          </a:p>
+        </p:txBody>
+      </p:sp>
+    </p:spTree>
+    <p:extLst>
+      <p:ext uri="{BB962C8B-B14F-4D97-AF65-F5344CB8AC3E}">
+        <p14:creationId xmlns:p14="http://schemas.microsoft.com/office/powerpoint/2010/main" val="3036491009"/>
+      </p:ext>
+    </p:extLst>
+  </p:cSld>
+  <p:clrMapOvr>
+    <a:masterClrMapping/>
+  </p:clrMapOvr>
+</p:sld>
+</file>
+
+<file path=ppt/slides/slide28.xml><?xml version="1.0" encoding="utf-8"?>
 <p:sld xmlns:a="http://schemas.openxmlformats.org/drawingml/2006/main" xmlns:r="http://schemas.openxmlformats.org/officeDocument/2006/relationships" xmlns:p="http://schemas.openxmlformats.org/presentationml/2006/main" show="0">
   <p:cSld>
     <p:spTree>
@@ -24395,161 +26189,7 @@
 </p:sld>
 </file>
 
-<file path=ppt/slides/slide22.xml><?xml version="1.0" encoding="utf-8"?>
-<p:sld xmlns:a="http://schemas.openxmlformats.org/drawingml/2006/main" xmlns:r="http://schemas.openxmlformats.org/officeDocument/2006/relationships" xmlns:p="http://schemas.openxmlformats.org/presentationml/2006/main" show="0">
-  <p:cSld>
-    <p:spTree>
-      <p:nvGrpSpPr>
-        <p:cNvPr id="1" name="">
-          <a:extLst>
-            <a:ext uri="{FF2B5EF4-FFF2-40B4-BE49-F238E27FC236}">
-              <a16:creationId xmlns:a16="http://schemas.microsoft.com/office/drawing/2014/main" id="{3B73CD7D-98B3-51A9-3D8E-296579E163CD}"/>
-            </a:ext>
-          </a:extLst>
-        </p:cNvPr>
-        <p:cNvGrpSpPr/>
-        <p:nvPr/>
-      </p:nvGrpSpPr>
-      <p:grpSpPr>
-        <a:xfrm>
-          <a:off x="0" y="0"/>
-          <a:ext cx="0" cy="0"/>
-          <a:chOff x="0" y="0"/>
-          <a:chExt cx="0" cy="0"/>
-        </a:xfrm>
-      </p:grpSpPr>
-      <p:sp>
-        <p:nvSpPr>
-          <p:cNvPr id="2" name="Title 1">
-            <a:extLst>
-              <a:ext uri="{FF2B5EF4-FFF2-40B4-BE49-F238E27FC236}">
-                <a16:creationId xmlns:a16="http://schemas.microsoft.com/office/drawing/2014/main" id="{FE93B09D-2D52-E43E-C6CF-3CA0AC97EFE4}"/>
-              </a:ext>
-            </a:extLst>
-          </p:cNvPr>
-          <p:cNvSpPr>
-            <a:spLocks noGrp="1"/>
-          </p:cNvSpPr>
-          <p:nvPr>
-            <p:ph type="title"/>
-          </p:nvPr>
-        </p:nvSpPr>
-        <p:spPr/>
-        <p:txBody>
-          <a:bodyPr>
-            <a:normAutofit/>
-          </a:bodyPr>
-          <a:lstStyle/>
-          <a:p>
-            <a:r>
-              <a:rPr lang="en-US" dirty="0"/>
-              <a:t>Tue,030226</a:t>
-            </a:r>
-          </a:p>
-        </p:txBody>
-      </p:sp>
-      <p:sp>
-        <p:nvSpPr>
-          <p:cNvPr id="4" name="Content Placeholder 3">
-            <a:extLst>
-              <a:ext uri="{FF2B5EF4-FFF2-40B4-BE49-F238E27FC236}">
-                <a16:creationId xmlns:a16="http://schemas.microsoft.com/office/drawing/2014/main" id="{7D455007-E3D6-B60F-1520-AE698CA873D1}"/>
-              </a:ext>
-            </a:extLst>
-          </p:cNvPr>
-          <p:cNvSpPr>
-            <a:spLocks noGrp="1"/>
-          </p:cNvSpPr>
-          <p:nvPr>
-            <p:ph idx="1"/>
-          </p:nvPr>
-        </p:nvSpPr>
-        <p:spPr/>
-        <p:txBody>
-          <a:bodyPr/>
-          <a:lstStyle/>
-          <a:p>
-            <a:r>
-              <a:rPr lang="en-US" dirty="0"/>
-              <a:t>Done</a:t>
-            </a:r>
-          </a:p>
-          <a:p>
-            <a:pPr lvl="1"/>
-            <a:r>
-              <a:rPr lang="en-US" dirty="0"/>
-              <a:t>Prepared sprint review deck for Sprint 10</a:t>
-            </a:r>
-          </a:p>
-          <a:p>
-            <a:r>
-              <a:rPr lang="en-US" dirty="0"/>
-              <a:t>Todo</a:t>
-            </a:r>
-          </a:p>
-          <a:p>
-            <a:pPr lvl="1"/>
-            <a:r>
-              <a:rPr lang="en-US" dirty="0"/>
-              <a:t>Implement item retirement on Cloud Storage (code + </a:t>
-            </a:r>
-            <a:r>
-              <a:rPr lang="en-US" dirty="0" err="1"/>
-              <a:t>cron</a:t>
-            </a:r>
-            <a:r>
-              <a:rPr lang="en-US" dirty="0"/>
-              <a:t> job)</a:t>
-            </a:r>
-          </a:p>
-          <a:p>
-            <a:pPr lvl="1"/>
-            <a:r>
-              <a:rPr lang="en-US" dirty="0"/>
-              <a:t>Plan tasks for Sprint 11 in Jira</a:t>
-            </a:r>
-          </a:p>
-          <a:p>
-            <a:pPr lvl="1"/>
-            <a:r>
-              <a:rPr lang="en-US" dirty="0"/>
-              <a:t>Develop pipeline to bundle data for each student</a:t>
-            </a:r>
-          </a:p>
-          <a:p>
-            <a:pPr lvl="1"/>
-            <a:r>
-              <a:rPr lang="en-US" dirty="0"/>
-              <a:t>Read and understood the QA Test Plan for the CV Evaluation Pipeline link</a:t>
-            </a:r>
-          </a:p>
-          <a:p>
-            <a:pPr lvl="1"/>
-            <a:endParaRPr lang="en-US" dirty="0"/>
-          </a:p>
-          <a:p>
-            <a:endParaRPr lang="en-US" dirty="0"/>
-          </a:p>
-          <a:p>
-            <a:pPr lvl="1"/>
-            <a:endParaRPr lang="en-US" dirty="0"/>
-          </a:p>
-        </p:txBody>
-      </p:sp>
-    </p:spTree>
-    <p:extLst>
-      <p:ext uri="{BB962C8B-B14F-4D97-AF65-F5344CB8AC3E}">
-        <p14:creationId xmlns:p14="http://schemas.microsoft.com/office/powerpoint/2010/main" val="2789201605"/>
-      </p:ext>
-    </p:extLst>
-  </p:cSld>
-  <p:clrMapOvr>
-    <a:masterClrMapping/>
-  </p:clrMapOvr>
-</p:sld>
-</file>
-
-<file path=ppt/slides/slide23.xml><?xml version="1.0" encoding="utf-8"?>
+<file path=ppt/slides/slide29.xml><?xml version="1.0" encoding="utf-8"?>
 <p:sld xmlns:a="http://schemas.openxmlformats.org/drawingml/2006/main" xmlns:r="http://schemas.openxmlformats.org/officeDocument/2006/relationships" xmlns:p="http://schemas.openxmlformats.org/presentationml/2006/main" show="0">
   <p:cSld>
     <p:spTree>
@@ -24656,7 +26296,852 @@
 </p:sld>
 </file>
 
-<file path=ppt/slides/slide24.xml><?xml version="1.0" encoding="utf-8"?>
+<file path=ppt/slides/slide3.xml><?xml version="1.0" encoding="utf-8"?>
+<p:sld xmlns:a="http://schemas.openxmlformats.org/drawingml/2006/main" xmlns:r="http://schemas.openxmlformats.org/officeDocument/2006/relationships" xmlns:p="http://schemas.openxmlformats.org/presentationml/2006/main">
+  <p:cSld>
+    <p:spTree>
+      <p:nvGrpSpPr>
+        <p:cNvPr id="1" name="">
+          <a:extLst>
+            <a:ext uri="{FF2B5EF4-FFF2-40B4-BE49-F238E27FC236}">
+              <a16:creationId xmlns:a16="http://schemas.microsoft.com/office/drawing/2014/main" id="{3929D3EC-AFF5-567E-E3A0-3150C0D21C35}"/>
+            </a:ext>
+          </a:extLst>
+        </p:cNvPr>
+        <p:cNvGrpSpPr/>
+        <p:nvPr/>
+      </p:nvGrpSpPr>
+      <p:grpSpPr>
+        <a:xfrm>
+          <a:off x="0" y="0"/>
+          <a:ext cx="0" cy="0"/>
+          <a:chOff x="0" y="0"/>
+          <a:chExt cx="0" cy="0"/>
+        </a:xfrm>
+      </p:grpSpPr>
+      <p:sp>
+        <p:nvSpPr>
+          <p:cNvPr id="45" name="Rectangle 44">
+            <a:extLst>
+              <a:ext uri="{FF2B5EF4-FFF2-40B4-BE49-F238E27FC236}">
+                <a16:creationId xmlns:a16="http://schemas.microsoft.com/office/drawing/2014/main" id="{888B5FE1-B1EE-48AE-0122-ADD0802056CE}"/>
+              </a:ext>
+            </a:extLst>
+          </p:cNvPr>
+          <p:cNvSpPr/>
+          <p:nvPr/>
+        </p:nvSpPr>
+        <p:spPr>
+          <a:xfrm>
+            <a:off x="1265795" y="3476850"/>
+            <a:ext cx="1355834" cy="504000"/>
+          </a:xfrm>
+          <a:prstGeom prst="rect">
+            <a:avLst/>
+          </a:prstGeom>
+          <a:solidFill>
+            <a:schemeClr val="tx2">
+              <a:lumMod val="25000"/>
+              <a:lumOff val="75000"/>
+            </a:schemeClr>
+          </a:solidFill>
+        </p:spPr>
+        <p:style>
+          <a:lnRef idx="2">
+            <a:schemeClr val="accent1">
+              <a:shade val="15000"/>
+            </a:schemeClr>
+          </a:lnRef>
+          <a:fillRef idx="1">
+            <a:schemeClr val="accent1"/>
+          </a:fillRef>
+          <a:effectRef idx="0">
+            <a:schemeClr val="accent1"/>
+          </a:effectRef>
+          <a:fontRef idx="minor">
+            <a:schemeClr val="lt1"/>
+          </a:fontRef>
+        </p:style>
+        <p:txBody>
+          <a:bodyPr rtlCol="0" anchor="ctr"/>
+          <a:lstStyle>
+            <a:defPPr>
+              <a:defRPr lang="en-TH"/>
+            </a:defPPr>
+            <a:lvl1pPr marL="0" algn="l" defTabSz="914400" rtl="0" eaLnBrk="1" latinLnBrk="0" hangingPunct="1">
+              <a:defRPr sz="1800" kern="1200">
+                <a:solidFill>
+                  <a:schemeClr val="lt1"/>
+                </a:solidFill>
+                <a:latin typeface="+mn-lt"/>
+                <a:ea typeface="+mn-ea"/>
+                <a:cs typeface="+mn-cs"/>
+              </a:defRPr>
+            </a:lvl1pPr>
+            <a:lvl2pPr marL="457200" algn="l" defTabSz="914400" rtl="0" eaLnBrk="1" latinLnBrk="0" hangingPunct="1">
+              <a:defRPr sz="1800" kern="1200">
+                <a:solidFill>
+                  <a:schemeClr val="lt1"/>
+                </a:solidFill>
+                <a:latin typeface="+mn-lt"/>
+                <a:ea typeface="+mn-ea"/>
+                <a:cs typeface="+mn-cs"/>
+              </a:defRPr>
+            </a:lvl2pPr>
+            <a:lvl3pPr marL="914400" algn="l" defTabSz="914400" rtl="0" eaLnBrk="1" latinLnBrk="0" hangingPunct="1">
+              <a:defRPr sz="1800" kern="1200">
+                <a:solidFill>
+                  <a:schemeClr val="lt1"/>
+                </a:solidFill>
+                <a:latin typeface="+mn-lt"/>
+                <a:ea typeface="+mn-ea"/>
+                <a:cs typeface="+mn-cs"/>
+              </a:defRPr>
+            </a:lvl3pPr>
+            <a:lvl4pPr marL="1371600" algn="l" defTabSz="914400" rtl="0" eaLnBrk="1" latinLnBrk="0" hangingPunct="1">
+              <a:defRPr sz="1800" kern="1200">
+                <a:solidFill>
+                  <a:schemeClr val="lt1"/>
+                </a:solidFill>
+                <a:latin typeface="+mn-lt"/>
+                <a:ea typeface="+mn-ea"/>
+                <a:cs typeface="+mn-cs"/>
+              </a:defRPr>
+            </a:lvl4pPr>
+            <a:lvl5pPr marL="1828800" algn="l" defTabSz="914400" rtl="0" eaLnBrk="1" latinLnBrk="0" hangingPunct="1">
+              <a:defRPr sz="1800" kern="1200">
+                <a:solidFill>
+                  <a:schemeClr val="lt1"/>
+                </a:solidFill>
+                <a:latin typeface="+mn-lt"/>
+                <a:ea typeface="+mn-ea"/>
+                <a:cs typeface="+mn-cs"/>
+              </a:defRPr>
+            </a:lvl5pPr>
+            <a:lvl6pPr marL="2286000" algn="l" defTabSz="914400" rtl="0" eaLnBrk="1" latinLnBrk="0" hangingPunct="1">
+              <a:defRPr sz="1800" kern="1200">
+                <a:solidFill>
+                  <a:schemeClr val="lt1"/>
+                </a:solidFill>
+                <a:latin typeface="+mn-lt"/>
+                <a:ea typeface="+mn-ea"/>
+                <a:cs typeface="+mn-cs"/>
+              </a:defRPr>
+            </a:lvl6pPr>
+            <a:lvl7pPr marL="2743200" algn="l" defTabSz="914400" rtl="0" eaLnBrk="1" latinLnBrk="0" hangingPunct="1">
+              <a:defRPr sz="1800" kern="1200">
+                <a:solidFill>
+                  <a:schemeClr val="lt1"/>
+                </a:solidFill>
+                <a:latin typeface="+mn-lt"/>
+                <a:ea typeface="+mn-ea"/>
+                <a:cs typeface="+mn-cs"/>
+              </a:defRPr>
+            </a:lvl7pPr>
+            <a:lvl8pPr marL="3200400" algn="l" defTabSz="914400" rtl="0" eaLnBrk="1" latinLnBrk="0" hangingPunct="1">
+              <a:defRPr sz="1800" kern="1200">
+                <a:solidFill>
+                  <a:schemeClr val="lt1"/>
+                </a:solidFill>
+                <a:latin typeface="+mn-lt"/>
+                <a:ea typeface="+mn-ea"/>
+                <a:cs typeface="+mn-cs"/>
+              </a:defRPr>
+            </a:lvl8pPr>
+            <a:lvl9pPr marL="3657600" algn="l" defTabSz="914400" rtl="0" eaLnBrk="1" latinLnBrk="0" hangingPunct="1">
+              <a:defRPr sz="1800" kern="1200">
+                <a:solidFill>
+                  <a:schemeClr val="lt1"/>
+                </a:solidFill>
+                <a:latin typeface="+mn-lt"/>
+                <a:ea typeface="+mn-ea"/>
+                <a:cs typeface="+mn-cs"/>
+              </a:defRPr>
+            </a:lvl9pPr>
+          </a:lstStyle>
+          <a:p>
+            <a:pPr marL="0" marR="0" lvl="0" indent="0" algn="ctr" defTabSz="914400" rtl="0" eaLnBrk="1" fontAlgn="auto" latinLnBrk="0" hangingPunct="1">
+              <a:lnSpc>
+                <a:spcPct val="100000"/>
+              </a:lnSpc>
+              <a:spcBef>
+                <a:spcPts val="0"/>
+              </a:spcBef>
+              <a:spcAft>
+                <a:spcPts val="0"/>
+              </a:spcAft>
+              <a:buClrTx/>
+              <a:buSzTx/>
+              <a:buFontTx/>
+              <a:buNone/>
+              <a:tabLst/>
+              <a:defRPr/>
+            </a:pPr>
+            <a:r>
+              <a:rPr kumimoji="0" lang="en-US" sz="1000" b="0" i="0" u="none" strike="noStrike" kern="1200" cap="none" spc="0" normalizeH="0" baseline="0" noProof="0" dirty="0">
+                <a:ln>
+                  <a:noFill/>
+                </a:ln>
+                <a:solidFill>
+                  <a:srgbClr val="272428"/>
+                </a:solidFill>
+                <a:effectLst/>
+                <a:uLnTx/>
+                <a:uFillTx/>
+                <a:latin typeface="Poppins Light"/>
+                <a:ea typeface="+mn-ea"/>
+                <a:cs typeface="Sarabun Light"/>
+              </a:rPr>
+              <a:t>Interactions.csv</a:t>
+            </a:r>
+            <a:endParaRPr kumimoji="0" lang="en-TH" sz="1000" b="0" i="0" u="none" strike="noStrike" kern="1200" cap="none" spc="0" normalizeH="0" baseline="0" noProof="0" dirty="0">
+              <a:ln>
+                <a:noFill/>
+              </a:ln>
+              <a:solidFill>
+                <a:srgbClr val="272428"/>
+              </a:solidFill>
+              <a:effectLst/>
+              <a:uLnTx/>
+              <a:uFillTx/>
+              <a:latin typeface="Poppins Light"/>
+              <a:ea typeface="+mn-ea"/>
+              <a:cs typeface="Sarabun Light"/>
+            </a:endParaRPr>
+          </a:p>
+        </p:txBody>
+      </p:sp>
+      <p:cxnSp>
+        <p:nvCxnSpPr>
+          <p:cNvPr id="46" name="Straight Arrow Connector 45">
+            <a:extLst>
+              <a:ext uri="{FF2B5EF4-FFF2-40B4-BE49-F238E27FC236}">
+                <a16:creationId xmlns:a16="http://schemas.microsoft.com/office/drawing/2014/main" id="{1C7B2808-7D52-F428-2F20-78BE0A3A13F6}"/>
+              </a:ext>
+            </a:extLst>
+          </p:cNvPr>
+          <p:cNvCxnSpPr>
+            <a:cxnSpLocks/>
+          </p:cNvCxnSpPr>
+          <p:nvPr/>
+        </p:nvCxnSpPr>
+        <p:spPr>
+          <a:xfrm>
+            <a:off x="2855188" y="3709225"/>
+            <a:ext cx="272106" cy="0"/>
+          </a:xfrm>
+          <a:prstGeom prst="straightConnector1">
+            <a:avLst/>
+          </a:prstGeom>
+          <a:ln w="12700">
+            <a:solidFill>
+              <a:srgbClr val="C00000"/>
+            </a:solidFill>
+            <a:tailEnd type="triangle"/>
+          </a:ln>
+        </p:spPr>
+        <p:style>
+          <a:lnRef idx="2">
+            <a:schemeClr val="dk1"/>
+          </a:lnRef>
+          <a:fillRef idx="0">
+            <a:schemeClr val="dk1"/>
+          </a:fillRef>
+          <a:effectRef idx="1">
+            <a:schemeClr val="dk1"/>
+          </a:effectRef>
+          <a:fontRef idx="minor">
+            <a:schemeClr val="tx1"/>
+          </a:fontRef>
+        </p:style>
+      </p:cxnSp>
+      <p:sp>
+        <p:nvSpPr>
+          <p:cNvPr id="47" name="Rectangle 46">
+            <a:extLst>
+              <a:ext uri="{FF2B5EF4-FFF2-40B4-BE49-F238E27FC236}">
+                <a16:creationId xmlns:a16="http://schemas.microsoft.com/office/drawing/2014/main" id="{5BADBA4E-44A1-92EE-AD49-AC89F95BF31D}"/>
+              </a:ext>
+            </a:extLst>
+          </p:cNvPr>
+          <p:cNvSpPr/>
+          <p:nvPr/>
+        </p:nvSpPr>
+        <p:spPr>
+          <a:xfrm>
+            <a:off x="1265795" y="4134950"/>
+            <a:ext cx="1355834" cy="504000"/>
+          </a:xfrm>
+          <a:prstGeom prst="rect">
+            <a:avLst/>
+          </a:prstGeom>
+          <a:solidFill>
+            <a:schemeClr val="tx2">
+              <a:lumMod val="25000"/>
+              <a:lumOff val="75000"/>
+            </a:schemeClr>
+          </a:solidFill>
+        </p:spPr>
+        <p:style>
+          <a:lnRef idx="2">
+            <a:schemeClr val="accent1">
+              <a:shade val="15000"/>
+            </a:schemeClr>
+          </a:lnRef>
+          <a:fillRef idx="1">
+            <a:schemeClr val="accent1"/>
+          </a:fillRef>
+          <a:effectRef idx="0">
+            <a:schemeClr val="accent1"/>
+          </a:effectRef>
+          <a:fontRef idx="minor">
+            <a:schemeClr val="lt1"/>
+          </a:fontRef>
+        </p:style>
+        <p:txBody>
+          <a:bodyPr rtlCol="0" anchor="ctr"/>
+          <a:lstStyle>
+            <a:defPPr>
+              <a:defRPr lang="en-TH"/>
+            </a:defPPr>
+            <a:lvl1pPr marL="0" algn="l" defTabSz="914400" rtl="0" eaLnBrk="1" latinLnBrk="0" hangingPunct="1">
+              <a:defRPr sz="1800" kern="1200">
+                <a:solidFill>
+                  <a:schemeClr val="lt1"/>
+                </a:solidFill>
+                <a:latin typeface="+mn-lt"/>
+                <a:ea typeface="+mn-ea"/>
+                <a:cs typeface="+mn-cs"/>
+              </a:defRPr>
+            </a:lvl1pPr>
+            <a:lvl2pPr marL="457200" algn="l" defTabSz="914400" rtl="0" eaLnBrk="1" latinLnBrk="0" hangingPunct="1">
+              <a:defRPr sz="1800" kern="1200">
+                <a:solidFill>
+                  <a:schemeClr val="lt1"/>
+                </a:solidFill>
+                <a:latin typeface="+mn-lt"/>
+                <a:ea typeface="+mn-ea"/>
+                <a:cs typeface="+mn-cs"/>
+              </a:defRPr>
+            </a:lvl2pPr>
+            <a:lvl3pPr marL="914400" algn="l" defTabSz="914400" rtl="0" eaLnBrk="1" latinLnBrk="0" hangingPunct="1">
+              <a:defRPr sz="1800" kern="1200">
+                <a:solidFill>
+                  <a:schemeClr val="lt1"/>
+                </a:solidFill>
+                <a:latin typeface="+mn-lt"/>
+                <a:ea typeface="+mn-ea"/>
+                <a:cs typeface="+mn-cs"/>
+              </a:defRPr>
+            </a:lvl3pPr>
+            <a:lvl4pPr marL="1371600" algn="l" defTabSz="914400" rtl="0" eaLnBrk="1" latinLnBrk="0" hangingPunct="1">
+              <a:defRPr sz="1800" kern="1200">
+                <a:solidFill>
+                  <a:schemeClr val="lt1"/>
+                </a:solidFill>
+                <a:latin typeface="+mn-lt"/>
+                <a:ea typeface="+mn-ea"/>
+                <a:cs typeface="+mn-cs"/>
+              </a:defRPr>
+            </a:lvl4pPr>
+            <a:lvl5pPr marL="1828800" algn="l" defTabSz="914400" rtl="0" eaLnBrk="1" latinLnBrk="0" hangingPunct="1">
+              <a:defRPr sz="1800" kern="1200">
+                <a:solidFill>
+                  <a:schemeClr val="lt1"/>
+                </a:solidFill>
+                <a:latin typeface="+mn-lt"/>
+                <a:ea typeface="+mn-ea"/>
+                <a:cs typeface="+mn-cs"/>
+              </a:defRPr>
+            </a:lvl5pPr>
+            <a:lvl6pPr marL="2286000" algn="l" defTabSz="914400" rtl="0" eaLnBrk="1" latinLnBrk="0" hangingPunct="1">
+              <a:defRPr sz="1800" kern="1200">
+                <a:solidFill>
+                  <a:schemeClr val="lt1"/>
+                </a:solidFill>
+                <a:latin typeface="+mn-lt"/>
+                <a:ea typeface="+mn-ea"/>
+                <a:cs typeface="+mn-cs"/>
+              </a:defRPr>
+            </a:lvl6pPr>
+            <a:lvl7pPr marL="2743200" algn="l" defTabSz="914400" rtl="0" eaLnBrk="1" latinLnBrk="0" hangingPunct="1">
+              <a:defRPr sz="1800" kern="1200">
+                <a:solidFill>
+                  <a:schemeClr val="lt1"/>
+                </a:solidFill>
+                <a:latin typeface="+mn-lt"/>
+                <a:ea typeface="+mn-ea"/>
+                <a:cs typeface="+mn-cs"/>
+              </a:defRPr>
+            </a:lvl7pPr>
+            <a:lvl8pPr marL="3200400" algn="l" defTabSz="914400" rtl="0" eaLnBrk="1" latinLnBrk="0" hangingPunct="1">
+              <a:defRPr sz="1800" kern="1200">
+                <a:solidFill>
+                  <a:schemeClr val="lt1"/>
+                </a:solidFill>
+                <a:latin typeface="+mn-lt"/>
+                <a:ea typeface="+mn-ea"/>
+                <a:cs typeface="+mn-cs"/>
+              </a:defRPr>
+            </a:lvl8pPr>
+            <a:lvl9pPr marL="3657600" algn="l" defTabSz="914400" rtl="0" eaLnBrk="1" latinLnBrk="0" hangingPunct="1">
+              <a:defRPr sz="1800" kern="1200">
+                <a:solidFill>
+                  <a:schemeClr val="lt1"/>
+                </a:solidFill>
+                <a:latin typeface="+mn-lt"/>
+                <a:ea typeface="+mn-ea"/>
+                <a:cs typeface="+mn-cs"/>
+              </a:defRPr>
+            </a:lvl9pPr>
+          </a:lstStyle>
+          <a:p>
+            <a:pPr marL="0" marR="0" lvl="0" indent="0" algn="ctr" defTabSz="914400" rtl="0" eaLnBrk="1" fontAlgn="auto" latinLnBrk="0" hangingPunct="1">
+              <a:lnSpc>
+                <a:spcPct val="100000"/>
+              </a:lnSpc>
+              <a:spcBef>
+                <a:spcPts val="0"/>
+              </a:spcBef>
+              <a:spcAft>
+                <a:spcPts val="0"/>
+              </a:spcAft>
+              <a:buClrTx/>
+              <a:buSzTx/>
+              <a:buFontTx/>
+              <a:buNone/>
+              <a:tabLst/>
+              <a:defRPr/>
+            </a:pPr>
+            <a:r>
+              <a:rPr kumimoji="0" lang="en-US" sz="1000" b="0" i="0" u="none" strike="noStrike" kern="1200" cap="none" spc="0" normalizeH="0" baseline="0" noProof="0" dirty="0">
+                <a:ln>
+                  <a:noFill/>
+                </a:ln>
+                <a:solidFill>
+                  <a:srgbClr val="272428"/>
+                </a:solidFill>
+                <a:effectLst/>
+                <a:uLnTx/>
+                <a:uFillTx/>
+                <a:latin typeface="Poppins Light"/>
+                <a:ea typeface="+mn-ea"/>
+                <a:cs typeface="Sarabun Light"/>
+              </a:rPr>
+              <a:t>Students.csv</a:t>
+            </a:r>
+            <a:endParaRPr kumimoji="0" lang="en-TH" sz="1000" b="0" i="0" u="none" strike="noStrike" kern="1200" cap="none" spc="0" normalizeH="0" baseline="0" noProof="0" dirty="0">
+              <a:ln>
+                <a:noFill/>
+              </a:ln>
+              <a:solidFill>
+                <a:srgbClr val="272428"/>
+              </a:solidFill>
+              <a:effectLst/>
+              <a:uLnTx/>
+              <a:uFillTx/>
+              <a:latin typeface="Poppins Light"/>
+              <a:ea typeface="+mn-ea"/>
+              <a:cs typeface="Sarabun Light"/>
+            </a:endParaRPr>
+          </a:p>
+        </p:txBody>
+      </p:sp>
+      <p:sp>
+        <p:nvSpPr>
+          <p:cNvPr id="48" name="Rectangle 47">
+            <a:extLst>
+              <a:ext uri="{FF2B5EF4-FFF2-40B4-BE49-F238E27FC236}">
+                <a16:creationId xmlns:a16="http://schemas.microsoft.com/office/drawing/2014/main" id="{6ECDE6DC-B4A8-04C0-5503-190D811805EF}"/>
+              </a:ext>
+            </a:extLst>
+          </p:cNvPr>
+          <p:cNvSpPr/>
+          <p:nvPr/>
+        </p:nvSpPr>
+        <p:spPr>
+          <a:xfrm>
+            <a:off x="1265795" y="2818750"/>
+            <a:ext cx="1355834" cy="504000"/>
+          </a:xfrm>
+          <a:prstGeom prst="rect">
+            <a:avLst/>
+          </a:prstGeom>
+          <a:solidFill>
+            <a:schemeClr val="tx2">
+              <a:lumMod val="25000"/>
+              <a:lumOff val="75000"/>
+            </a:schemeClr>
+          </a:solidFill>
+        </p:spPr>
+        <p:style>
+          <a:lnRef idx="2">
+            <a:schemeClr val="accent1">
+              <a:shade val="15000"/>
+            </a:schemeClr>
+          </a:lnRef>
+          <a:fillRef idx="1">
+            <a:schemeClr val="accent1"/>
+          </a:fillRef>
+          <a:effectRef idx="0">
+            <a:schemeClr val="accent1"/>
+          </a:effectRef>
+          <a:fontRef idx="minor">
+            <a:schemeClr val="lt1"/>
+          </a:fontRef>
+        </p:style>
+        <p:txBody>
+          <a:bodyPr rtlCol="0" anchor="ctr"/>
+          <a:lstStyle>
+            <a:defPPr>
+              <a:defRPr lang="en-TH"/>
+            </a:defPPr>
+            <a:lvl1pPr marL="0" algn="l" defTabSz="914400" rtl="0" eaLnBrk="1" latinLnBrk="0" hangingPunct="1">
+              <a:defRPr sz="1800" kern="1200">
+                <a:solidFill>
+                  <a:schemeClr val="lt1"/>
+                </a:solidFill>
+                <a:latin typeface="+mn-lt"/>
+                <a:ea typeface="+mn-ea"/>
+                <a:cs typeface="+mn-cs"/>
+              </a:defRPr>
+            </a:lvl1pPr>
+            <a:lvl2pPr marL="457200" algn="l" defTabSz="914400" rtl="0" eaLnBrk="1" latinLnBrk="0" hangingPunct="1">
+              <a:defRPr sz="1800" kern="1200">
+                <a:solidFill>
+                  <a:schemeClr val="lt1"/>
+                </a:solidFill>
+                <a:latin typeface="+mn-lt"/>
+                <a:ea typeface="+mn-ea"/>
+                <a:cs typeface="+mn-cs"/>
+              </a:defRPr>
+            </a:lvl2pPr>
+            <a:lvl3pPr marL="914400" algn="l" defTabSz="914400" rtl="0" eaLnBrk="1" latinLnBrk="0" hangingPunct="1">
+              <a:defRPr sz="1800" kern="1200">
+                <a:solidFill>
+                  <a:schemeClr val="lt1"/>
+                </a:solidFill>
+                <a:latin typeface="+mn-lt"/>
+                <a:ea typeface="+mn-ea"/>
+                <a:cs typeface="+mn-cs"/>
+              </a:defRPr>
+            </a:lvl3pPr>
+            <a:lvl4pPr marL="1371600" algn="l" defTabSz="914400" rtl="0" eaLnBrk="1" latinLnBrk="0" hangingPunct="1">
+              <a:defRPr sz="1800" kern="1200">
+                <a:solidFill>
+                  <a:schemeClr val="lt1"/>
+                </a:solidFill>
+                <a:latin typeface="+mn-lt"/>
+                <a:ea typeface="+mn-ea"/>
+                <a:cs typeface="+mn-cs"/>
+              </a:defRPr>
+            </a:lvl4pPr>
+            <a:lvl5pPr marL="1828800" algn="l" defTabSz="914400" rtl="0" eaLnBrk="1" latinLnBrk="0" hangingPunct="1">
+              <a:defRPr sz="1800" kern="1200">
+                <a:solidFill>
+                  <a:schemeClr val="lt1"/>
+                </a:solidFill>
+                <a:latin typeface="+mn-lt"/>
+                <a:ea typeface="+mn-ea"/>
+                <a:cs typeface="+mn-cs"/>
+              </a:defRPr>
+            </a:lvl5pPr>
+            <a:lvl6pPr marL="2286000" algn="l" defTabSz="914400" rtl="0" eaLnBrk="1" latinLnBrk="0" hangingPunct="1">
+              <a:defRPr sz="1800" kern="1200">
+                <a:solidFill>
+                  <a:schemeClr val="lt1"/>
+                </a:solidFill>
+                <a:latin typeface="+mn-lt"/>
+                <a:ea typeface="+mn-ea"/>
+                <a:cs typeface="+mn-cs"/>
+              </a:defRPr>
+            </a:lvl6pPr>
+            <a:lvl7pPr marL="2743200" algn="l" defTabSz="914400" rtl="0" eaLnBrk="1" latinLnBrk="0" hangingPunct="1">
+              <a:defRPr sz="1800" kern="1200">
+                <a:solidFill>
+                  <a:schemeClr val="lt1"/>
+                </a:solidFill>
+                <a:latin typeface="+mn-lt"/>
+                <a:ea typeface="+mn-ea"/>
+                <a:cs typeface="+mn-cs"/>
+              </a:defRPr>
+            </a:lvl7pPr>
+            <a:lvl8pPr marL="3200400" algn="l" defTabSz="914400" rtl="0" eaLnBrk="1" latinLnBrk="0" hangingPunct="1">
+              <a:defRPr sz="1800" kern="1200">
+                <a:solidFill>
+                  <a:schemeClr val="lt1"/>
+                </a:solidFill>
+                <a:latin typeface="+mn-lt"/>
+                <a:ea typeface="+mn-ea"/>
+                <a:cs typeface="+mn-cs"/>
+              </a:defRPr>
+            </a:lvl8pPr>
+            <a:lvl9pPr marL="3657600" algn="l" defTabSz="914400" rtl="0" eaLnBrk="1" latinLnBrk="0" hangingPunct="1">
+              <a:defRPr sz="1800" kern="1200">
+                <a:solidFill>
+                  <a:schemeClr val="lt1"/>
+                </a:solidFill>
+                <a:latin typeface="+mn-lt"/>
+                <a:ea typeface="+mn-ea"/>
+                <a:cs typeface="+mn-cs"/>
+              </a:defRPr>
+            </a:lvl9pPr>
+          </a:lstStyle>
+          <a:p>
+            <a:pPr marL="0" marR="0" lvl="0" indent="0" algn="ctr" defTabSz="914400" rtl="0" eaLnBrk="1" fontAlgn="auto" latinLnBrk="0" hangingPunct="1">
+              <a:lnSpc>
+                <a:spcPct val="100000"/>
+              </a:lnSpc>
+              <a:spcBef>
+                <a:spcPts val="0"/>
+              </a:spcBef>
+              <a:spcAft>
+                <a:spcPts val="0"/>
+              </a:spcAft>
+              <a:buClrTx/>
+              <a:buSzTx/>
+              <a:buFontTx/>
+              <a:buNone/>
+              <a:tabLst/>
+              <a:defRPr/>
+            </a:pPr>
+            <a:r>
+              <a:rPr lang="en-US" sz="1000" dirty="0" err="1">
+                <a:solidFill>
+                  <a:srgbClr val="272428"/>
+                </a:solidFill>
+                <a:latin typeface="Poppins Light"/>
+                <a:cs typeface="Sarabun Light"/>
+              </a:rPr>
+              <a:t>feeds.jsonl</a:t>
+            </a:r>
+            <a:endParaRPr kumimoji="0" lang="en-TH" sz="1000" b="0" i="0" u="none" strike="noStrike" kern="1200" cap="none" spc="0" normalizeH="0" baseline="0" noProof="0" dirty="0">
+              <a:ln>
+                <a:noFill/>
+              </a:ln>
+              <a:solidFill>
+                <a:srgbClr val="272428"/>
+              </a:solidFill>
+              <a:effectLst/>
+              <a:uLnTx/>
+              <a:uFillTx/>
+              <a:latin typeface="Poppins Light"/>
+              <a:ea typeface="+mn-ea"/>
+              <a:cs typeface="Sarabun Light"/>
+            </a:endParaRPr>
+          </a:p>
+        </p:txBody>
+      </p:sp>
+      <p:pic>
+        <p:nvPicPr>
+          <p:cNvPr id="1026" name="Picture 2" descr="What Is BigQuery And How Do You Load Data Into It? - Seattle Data Guy">
+            <a:extLst>
+              <a:ext uri="{FF2B5EF4-FFF2-40B4-BE49-F238E27FC236}">
+                <a16:creationId xmlns:a16="http://schemas.microsoft.com/office/drawing/2014/main" id="{F9602F6A-EFA2-16D3-10D7-431656411664}"/>
+              </a:ext>
+            </a:extLst>
+          </p:cNvPr>
+          <p:cNvPicPr>
+            <a:picLocks noChangeAspect="1" noChangeArrowheads="1"/>
+          </p:cNvPicPr>
+          <p:nvPr/>
+        </p:nvPicPr>
+        <p:blipFill>
+          <a:blip r:embed="rId2">
+            <a:extLst>
+              <a:ext uri="{28A0092B-C50C-407E-A947-70E740481C1C}">
+                <a14:useLocalDpi xmlns:a14="http://schemas.microsoft.com/office/drawing/2010/main" val="0"/>
+              </a:ext>
+            </a:extLst>
+          </a:blip>
+          <a:srcRect/>
+          <a:stretch>
+            <a:fillRect/>
+          </a:stretch>
+        </p:blipFill>
+        <p:spPr bwMode="auto">
+          <a:xfrm>
+            <a:off x="3338437" y="3136996"/>
+            <a:ext cx="2019300" cy="1135857"/>
+          </a:xfrm>
+          <a:prstGeom prst="rect">
+            <a:avLst/>
+          </a:prstGeom>
+          <a:noFill/>
+          <a:extLst>
+            <a:ext uri="{909E8E84-426E-40DD-AFC4-6F175D3DCCD1}">
+              <a14:hiddenFill xmlns:a14="http://schemas.microsoft.com/office/drawing/2010/main">
+                <a:solidFill>
+                  <a:srgbClr val="FFFFFF"/>
+                </a:solidFill>
+              </a14:hiddenFill>
+            </a:ext>
+          </a:extLst>
+        </p:spPr>
+      </p:pic>
+      <p:cxnSp>
+        <p:nvCxnSpPr>
+          <p:cNvPr id="3" name="Straight Arrow Connector 2">
+            <a:extLst>
+              <a:ext uri="{FF2B5EF4-FFF2-40B4-BE49-F238E27FC236}">
+                <a16:creationId xmlns:a16="http://schemas.microsoft.com/office/drawing/2014/main" id="{39E74994-9AB4-C632-1081-59D8C36CDD17}"/>
+              </a:ext>
+            </a:extLst>
+          </p:cNvPr>
+          <p:cNvCxnSpPr>
+            <a:cxnSpLocks/>
+          </p:cNvCxnSpPr>
+          <p:nvPr/>
+        </p:nvCxnSpPr>
+        <p:spPr>
+          <a:xfrm>
+            <a:off x="5514256" y="3704575"/>
+            <a:ext cx="272106" cy="0"/>
+          </a:xfrm>
+          <a:prstGeom prst="straightConnector1">
+            <a:avLst/>
+          </a:prstGeom>
+          <a:ln w="12700">
+            <a:solidFill>
+              <a:srgbClr val="C00000"/>
+            </a:solidFill>
+            <a:tailEnd type="triangle"/>
+          </a:ln>
+        </p:spPr>
+        <p:style>
+          <a:lnRef idx="2">
+            <a:schemeClr val="dk1"/>
+          </a:lnRef>
+          <a:fillRef idx="0">
+            <a:schemeClr val="dk1"/>
+          </a:fillRef>
+          <a:effectRef idx="1">
+            <a:schemeClr val="dk1"/>
+          </a:effectRef>
+          <a:fontRef idx="minor">
+            <a:schemeClr val="tx1"/>
+          </a:fontRef>
+        </p:style>
+      </p:cxnSp>
+      <p:pic>
+        <p:nvPicPr>
+          <p:cNvPr id="4" name="Picture 3">
+            <a:extLst>
+              <a:ext uri="{FF2B5EF4-FFF2-40B4-BE49-F238E27FC236}">
+                <a16:creationId xmlns:a16="http://schemas.microsoft.com/office/drawing/2014/main" id="{EE7BE979-4626-6F9B-335F-2560BD679BE6}"/>
+              </a:ext>
+            </a:extLst>
+          </p:cNvPr>
+          <p:cNvPicPr>
+            <a:picLocks noChangeAspect="1"/>
+          </p:cNvPicPr>
+          <p:nvPr/>
+        </p:nvPicPr>
+        <p:blipFill>
+          <a:blip r:embed="rId3">
+            <a:extLst>
+              <a:ext uri="{28A0092B-C50C-407E-A947-70E740481C1C}">
+                <a14:useLocalDpi xmlns:a14="http://schemas.microsoft.com/office/drawing/2010/main" val="0"/>
+              </a:ext>
+            </a:extLst>
+          </a:blip>
+          <a:stretch>
+            <a:fillRect/>
+          </a:stretch>
+        </p:blipFill>
+        <p:spPr>
+          <a:xfrm>
+            <a:off x="6096000" y="1468521"/>
+            <a:ext cx="5137039" cy="4472808"/>
+          </a:xfrm>
+          <a:prstGeom prst="rect">
+            <a:avLst/>
+          </a:prstGeom>
+        </p:spPr>
+      </p:pic>
+      <p:sp>
+        <p:nvSpPr>
+          <p:cNvPr id="2" name="Title 1">
+            <a:extLst>
+              <a:ext uri="{FF2B5EF4-FFF2-40B4-BE49-F238E27FC236}">
+                <a16:creationId xmlns:a16="http://schemas.microsoft.com/office/drawing/2014/main" id="{FD97EA77-AB81-EF31-E372-18A4CEAF26A8}"/>
+              </a:ext>
+            </a:extLst>
+          </p:cNvPr>
+          <p:cNvSpPr txBox="1">
+            <a:spLocks/>
+          </p:cNvSpPr>
+          <p:nvPr/>
+        </p:nvSpPr>
+        <p:spPr>
+          <a:xfrm>
+            <a:off x="365759" y="649487"/>
+            <a:ext cx="11183815" cy="528254"/>
+          </a:xfrm>
+          <a:prstGeom prst="rect">
+            <a:avLst/>
+          </a:prstGeom>
+        </p:spPr>
+        <p:txBody>
+          <a:bodyPr vert="horz" lIns="91440" tIns="45720" rIns="91440" bIns="45720" rtlCol="0" anchor="ctr">
+            <a:noAutofit/>
+          </a:bodyPr>
+          <a:lstStyle>
+            <a:lvl1pPr algn="ctr" defTabSz="914400" rtl="0" eaLnBrk="1" latinLnBrk="0" hangingPunct="1">
+              <a:lnSpc>
+                <a:spcPct val="90000"/>
+              </a:lnSpc>
+              <a:spcBef>
+                <a:spcPct val="0"/>
+              </a:spcBef>
+              <a:buNone/>
+              <a:defRPr sz="6000" kern="1200">
+                <a:solidFill>
+                  <a:schemeClr val="tx1"/>
+                </a:solidFill>
+                <a:latin typeface="+mj-lt"/>
+                <a:ea typeface="+mj-ea"/>
+                <a:cs typeface="+mj-cs"/>
+              </a:defRPr>
+            </a:lvl1pPr>
+          </a:lstStyle>
+          <a:p>
+            <a:r>
+              <a:rPr lang="en-US" sz="2400" dirty="0" err="1">
+                <a:cs typeface="Poppins Light"/>
+              </a:rPr>
+              <a:t>HyDE</a:t>
+            </a:r>
+            <a:r>
+              <a:rPr lang="en-US" sz="2400" dirty="0">
+                <a:cs typeface="Poppins Light"/>
+              </a:rPr>
+              <a:t> Feed Recommendation - </a:t>
+            </a:r>
+            <a:r>
+              <a:rPr lang="en-TH" sz="2400" dirty="0"/>
+              <a:t>System Overview</a:t>
+            </a:r>
+            <a:endParaRPr lang="en-US" sz="2400" dirty="0">
+              <a:cs typeface="Poppins Light"/>
+            </a:endParaRPr>
+          </a:p>
+        </p:txBody>
+      </p:sp>
+    </p:spTree>
+    <p:extLst>
+      <p:ext uri="{BB962C8B-B14F-4D97-AF65-F5344CB8AC3E}">
+        <p14:creationId xmlns:p14="http://schemas.microsoft.com/office/powerpoint/2010/main" val="2108206429"/>
+      </p:ext>
+    </p:extLst>
+  </p:cSld>
+  <p:clrMapOvr>
+    <a:masterClrMapping/>
+  </p:clrMapOvr>
+</p:sld>
+</file>
+
+<file path=ppt/slides/slide30.xml><?xml version="1.0" encoding="utf-8"?>
 <p:sld xmlns:a="http://schemas.openxmlformats.org/drawingml/2006/main" xmlns:r="http://schemas.openxmlformats.org/officeDocument/2006/relationships" xmlns:p="http://schemas.openxmlformats.org/presentationml/2006/main" show="0">
   <p:cSld>
     <p:spTree>
@@ -25011,7 +27496,7 @@
 </p:sld>
 </file>
 
-<file path=ppt/slides/slide25.xml><?xml version="1.0" encoding="utf-8"?>
+<file path=ppt/slides/slide31.xml><?xml version="1.0" encoding="utf-8"?>
 <p:sld xmlns:a="http://schemas.openxmlformats.org/drawingml/2006/main" xmlns:r="http://schemas.openxmlformats.org/officeDocument/2006/relationships" xmlns:p="http://schemas.openxmlformats.org/presentationml/2006/main" show="0">
   <p:cSld>
     <p:spTree>
@@ -25346,7 +27831,7 @@
 </p:sld>
 </file>
 
-<file path=ppt/slides/slide26.xml><?xml version="1.0" encoding="utf-8"?>
+<file path=ppt/slides/slide32.xml><?xml version="1.0" encoding="utf-8"?>
 <p:sld xmlns:a="http://schemas.openxmlformats.org/drawingml/2006/main" xmlns:r="http://schemas.openxmlformats.org/officeDocument/2006/relationships" xmlns:p="http://schemas.openxmlformats.org/presentationml/2006/main" show="0">
   <p:cSld>
     <p:spTree>
@@ -27139,7 +29624,7 @@
 </p:sld>
 </file>
 
-<file path=ppt/slides/slide27.xml><?xml version="1.0" encoding="utf-8"?>
+<file path=ppt/slides/slide33.xml><?xml version="1.0" encoding="utf-8"?>
 <p:sld xmlns:a="http://schemas.openxmlformats.org/drawingml/2006/main" xmlns:r="http://schemas.openxmlformats.org/officeDocument/2006/relationships" xmlns:p="http://schemas.openxmlformats.org/presentationml/2006/main" show="0">
   <p:cSld>
     <p:spTree>
@@ -27272,7 +29757,7 @@
 </p:sld>
 </file>
 
-<file path=ppt/slides/slide28.xml><?xml version="1.0" encoding="utf-8"?>
+<file path=ppt/slides/slide34.xml><?xml version="1.0" encoding="utf-8"?>
 <p:sld xmlns:a="http://schemas.openxmlformats.org/drawingml/2006/main" xmlns:r="http://schemas.openxmlformats.org/officeDocument/2006/relationships" xmlns:p="http://schemas.openxmlformats.org/presentationml/2006/main" show="0">
   <p:cSld>
     <p:spTree>
@@ -27399,7 +29884,7 @@
 </p:sld>
 </file>
 
-<file path=ppt/slides/slide29.xml><?xml version="1.0" encoding="utf-8"?>
+<file path=ppt/slides/slide35.xml><?xml version="1.0" encoding="utf-8"?>
 <p:sld xmlns:a="http://schemas.openxmlformats.org/drawingml/2006/main" xmlns:r="http://schemas.openxmlformats.org/officeDocument/2006/relationships" xmlns:p="http://schemas.openxmlformats.org/presentationml/2006/main" show="0">
   <p:cSld>
     <p:spTree>
@@ -27526,852 +30011,7 @@
 </p:sld>
 </file>
 
-<file path=ppt/slides/slide3.xml><?xml version="1.0" encoding="utf-8"?>
-<p:sld xmlns:a="http://schemas.openxmlformats.org/drawingml/2006/main" xmlns:r="http://schemas.openxmlformats.org/officeDocument/2006/relationships" xmlns:p="http://schemas.openxmlformats.org/presentationml/2006/main">
-  <p:cSld>
-    <p:spTree>
-      <p:nvGrpSpPr>
-        <p:cNvPr id="1" name="">
-          <a:extLst>
-            <a:ext uri="{FF2B5EF4-FFF2-40B4-BE49-F238E27FC236}">
-              <a16:creationId xmlns:a16="http://schemas.microsoft.com/office/drawing/2014/main" id="{3929D3EC-AFF5-567E-E3A0-3150C0D21C35}"/>
-            </a:ext>
-          </a:extLst>
-        </p:cNvPr>
-        <p:cNvGrpSpPr/>
-        <p:nvPr/>
-      </p:nvGrpSpPr>
-      <p:grpSpPr>
-        <a:xfrm>
-          <a:off x="0" y="0"/>
-          <a:ext cx="0" cy="0"/>
-          <a:chOff x="0" y="0"/>
-          <a:chExt cx="0" cy="0"/>
-        </a:xfrm>
-      </p:grpSpPr>
-      <p:sp>
-        <p:nvSpPr>
-          <p:cNvPr id="45" name="Rectangle 44">
-            <a:extLst>
-              <a:ext uri="{FF2B5EF4-FFF2-40B4-BE49-F238E27FC236}">
-                <a16:creationId xmlns:a16="http://schemas.microsoft.com/office/drawing/2014/main" id="{888B5FE1-B1EE-48AE-0122-ADD0802056CE}"/>
-              </a:ext>
-            </a:extLst>
-          </p:cNvPr>
-          <p:cNvSpPr/>
-          <p:nvPr/>
-        </p:nvSpPr>
-        <p:spPr>
-          <a:xfrm>
-            <a:off x="1265795" y="3476850"/>
-            <a:ext cx="1355834" cy="504000"/>
-          </a:xfrm>
-          <a:prstGeom prst="rect">
-            <a:avLst/>
-          </a:prstGeom>
-          <a:solidFill>
-            <a:schemeClr val="tx2">
-              <a:lumMod val="25000"/>
-              <a:lumOff val="75000"/>
-            </a:schemeClr>
-          </a:solidFill>
-        </p:spPr>
-        <p:style>
-          <a:lnRef idx="2">
-            <a:schemeClr val="accent1">
-              <a:shade val="15000"/>
-            </a:schemeClr>
-          </a:lnRef>
-          <a:fillRef idx="1">
-            <a:schemeClr val="accent1"/>
-          </a:fillRef>
-          <a:effectRef idx="0">
-            <a:schemeClr val="accent1"/>
-          </a:effectRef>
-          <a:fontRef idx="minor">
-            <a:schemeClr val="lt1"/>
-          </a:fontRef>
-        </p:style>
-        <p:txBody>
-          <a:bodyPr rtlCol="0" anchor="ctr"/>
-          <a:lstStyle>
-            <a:defPPr>
-              <a:defRPr lang="en-TH"/>
-            </a:defPPr>
-            <a:lvl1pPr marL="0" algn="l" defTabSz="914400" rtl="0" eaLnBrk="1" latinLnBrk="0" hangingPunct="1">
-              <a:defRPr sz="1800" kern="1200">
-                <a:solidFill>
-                  <a:schemeClr val="lt1"/>
-                </a:solidFill>
-                <a:latin typeface="+mn-lt"/>
-                <a:ea typeface="+mn-ea"/>
-                <a:cs typeface="+mn-cs"/>
-              </a:defRPr>
-            </a:lvl1pPr>
-            <a:lvl2pPr marL="457200" algn="l" defTabSz="914400" rtl="0" eaLnBrk="1" latinLnBrk="0" hangingPunct="1">
-              <a:defRPr sz="1800" kern="1200">
-                <a:solidFill>
-                  <a:schemeClr val="lt1"/>
-                </a:solidFill>
-                <a:latin typeface="+mn-lt"/>
-                <a:ea typeface="+mn-ea"/>
-                <a:cs typeface="+mn-cs"/>
-              </a:defRPr>
-            </a:lvl2pPr>
-            <a:lvl3pPr marL="914400" algn="l" defTabSz="914400" rtl="0" eaLnBrk="1" latinLnBrk="0" hangingPunct="1">
-              <a:defRPr sz="1800" kern="1200">
-                <a:solidFill>
-                  <a:schemeClr val="lt1"/>
-                </a:solidFill>
-                <a:latin typeface="+mn-lt"/>
-                <a:ea typeface="+mn-ea"/>
-                <a:cs typeface="+mn-cs"/>
-              </a:defRPr>
-            </a:lvl3pPr>
-            <a:lvl4pPr marL="1371600" algn="l" defTabSz="914400" rtl="0" eaLnBrk="1" latinLnBrk="0" hangingPunct="1">
-              <a:defRPr sz="1800" kern="1200">
-                <a:solidFill>
-                  <a:schemeClr val="lt1"/>
-                </a:solidFill>
-                <a:latin typeface="+mn-lt"/>
-                <a:ea typeface="+mn-ea"/>
-                <a:cs typeface="+mn-cs"/>
-              </a:defRPr>
-            </a:lvl4pPr>
-            <a:lvl5pPr marL="1828800" algn="l" defTabSz="914400" rtl="0" eaLnBrk="1" latinLnBrk="0" hangingPunct="1">
-              <a:defRPr sz="1800" kern="1200">
-                <a:solidFill>
-                  <a:schemeClr val="lt1"/>
-                </a:solidFill>
-                <a:latin typeface="+mn-lt"/>
-                <a:ea typeface="+mn-ea"/>
-                <a:cs typeface="+mn-cs"/>
-              </a:defRPr>
-            </a:lvl5pPr>
-            <a:lvl6pPr marL="2286000" algn="l" defTabSz="914400" rtl="0" eaLnBrk="1" latinLnBrk="0" hangingPunct="1">
-              <a:defRPr sz="1800" kern="1200">
-                <a:solidFill>
-                  <a:schemeClr val="lt1"/>
-                </a:solidFill>
-                <a:latin typeface="+mn-lt"/>
-                <a:ea typeface="+mn-ea"/>
-                <a:cs typeface="+mn-cs"/>
-              </a:defRPr>
-            </a:lvl6pPr>
-            <a:lvl7pPr marL="2743200" algn="l" defTabSz="914400" rtl="0" eaLnBrk="1" latinLnBrk="0" hangingPunct="1">
-              <a:defRPr sz="1800" kern="1200">
-                <a:solidFill>
-                  <a:schemeClr val="lt1"/>
-                </a:solidFill>
-                <a:latin typeface="+mn-lt"/>
-                <a:ea typeface="+mn-ea"/>
-                <a:cs typeface="+mn-cs"/>
-              </a:defRPr>
-            </a:lvl7pPr>
-            <a:lvl8pPr marL="3200400" algn="l" defTabSz="914400" rtl="0" eaLnBrk="1" latinLnBrk="0" hangingPunct="1">
-              <a:defRPr sz="1800" kern="1200">
-                <a:solidFill>
-                  <a:schemeClr val="lt1"/>
-                </a:solidFill>
-                <a:latin typeface="+mn-lt"/>
-                <a:ea typeface="+mn-ea"/>
-                <a:cs typeface="+mn-cs"/>
-              </a:defRPr>
-            </a:lvl8pPr>
-            <a:lvl9pPr marL="3657600" algn="l" defTabSz="914400" rtl="0" eaLnBrk="1" latinLnBrk="0" hangingPunct="1">
-              <a:defRPr sz="1800" kern="1200">
-                <a:solidFill>
-                  <a:schemeClr val="lt1"/>
-                </a:solidFill>
-                <a:latin typeface="+mn-lt"/>
-                <a:ea typeface="+mn-ea"/>
-                <a:cs typeface="+mn-cs"/>
-              </a:defRPr>
-            </a:lvl9pPr>
-          </a:lstStyle>
-          <a:p>
-            <a:pPr marL="0" marR="0" lvl="0" indent="0" algn="ctr" defTabSz="914400" rtl="0" eaLnBrk="1" fontAlgn="auto" latinLnBrk="0" hangingPunct="1">
-              <a:lnSpc>
-                <a:spcPct val="100000"/>
-              </a:lnSpc>
-              <a:spcBef>
-                <a:spcPts val="0"/>
-              </a:spcBef>
-              <a:spcAft>
-                <a:spcPts val="0"/>
-              </a:spcAft>
-              <a:buClrTx/>
-              <a:buSzTx/>
-              <a:buFontTx/>
-              <a:buNone/>
-              <a:tabLst/>
-              <a:defRPr/>
-            </a:pPr>
-            <a:r>
-              <a:rPr kumimoji="0" lang="en-US" sz="1000" b="0" i="0" u="none" strike="noStrike" kern="1200" cap="none" spc="0" normalizeH="0" baseline="0" noProof="0" dirty="0">
-                <a:ln>
-                  <a:noFill/>
-                </a:ln>
-                <a:solidFill>
-                  <a:srgbClr val="272428"/>
-                </a:solidFill>
-                <a:effectLst/>
-                <a:uLnTx/>
-                <a:uFillTx/>
-                <a:latin typeface="Poppins Light"/>
-                <a:ea typeface="+mn-ea"/>
-                <a:cs typeface="Sarabun Light"/>
-              </a:rPr>
-              <a:t>Interactions.csv</a:t>
-            </a:r>
-            <a:endParaRPr kumimoji="0" lang="en-TH" sz="1000" b="0" i="0" u="none" strike="noStrike" kern="1200" cap="none" spc="0" normalizeH="0" baseline="0" noProof="0" dirty="0">
-              <a:ln>
-                <a:noFill/>
-              </a:ln>
-              <a:solidFill>
-                <a:srgbClr val="272428"/>
-              </a:solidFill>
-              <a:effectLst/>
-              <a:uLnTx/>
-              <a:uFillTx/>
-              <a:latin typeface="Poppins Light"/>
-              <a:ea typeface="+mn-ea"/>
-              <a:cs typeface="Sarabun Light"/>
-            </a:endParaRPr>
-          </a:p>
-        </p:txBody>
-      </p:sp>
-      <p:cxnSp>
-        <p:nvCxnSpPr>
-          <p:cNvPr id="46" name="Straight Arrow Connector 45">
-            <a:extLst>
-              <a:ext uri="{FF2B5EF4-FFF2-40B4-BE49-F238E27FC236}">
-                <a16:creationId xmlns:a16="http://schemas.microsoft.com/office/drawing/2014/main" id="{1C7B2808-7D52-F428-2F20-78BE0A3A13F6}"/>
-              </a:ext>
-            </a:extLst>
-          </p:cNvPr>
-          <p:cNvCxnSpPr>
-            <a:cxnSpLocks/>
-          </p:cNvCxnSpPr>
-          <p:nvPr/>
-        </p:nvCxnSpPr>
-        <p:spPr>
-          <a:xfrm>
-            <a:off x="2855188" y="3709225"/>
-            <a:ext cx="272106" cy="0"/>
-          </a:xfrm>
-          <a:prstGeom prst="straightConnector1">
-            <a:avLst/>
-          </a:prstGeom>
-          <a:ln w="12700">
-            <a:solidFill>
-              <a:srgbClr val="C00000"/>
-            </a:solidFill>
-            <a:tailEnd type="triangle"/>
-          </a:ln>
-        </p:spPr>
-        <p:style>
-          <a:lnRef idx="2">
-            <a:schemeClr val="dk1"/>
-          </a:lnRef>
-          <a:fillRef idx="0">
-            <a:schemeClr val="dk1"/>
-          </a:fillRef>
-          <a:effectRef idx="1">
-            <a:schemeClr val="dk1"/>
-          </a:effectRef>
-          <a:fontRef idx="minor">
-            <a:schemeClr val="tx1"/>
-          </a:fontRef>
-        </p:style>
-      </p:cxnSp>
-      <p:sp>
-        <p:nvSpPr>
-          <p:cNvPr id="47" name="Rectangle 46">
-            <a:extLst>
-              <a:ext uri="{FF2B5EF4-FFF2-40B4-BE49-F238E27FC236}">
-                <a16:creationId xmlns:a16="http://schemas.microsoft.com/office/drawing/2014/main" id="{5BADBA4E-44A1-92EE-AD49-AC89F95BF31D}"/>
-              </a:ext>
-            </a:extLst>
-          </p:cNvPr>
-          <p:cNvSpPr/>
-          <p:nvPr/>
-        </p:nvSpPr>
-        <p:spPr>
-          <a:xfrm>
-            <a:off x="1265795" y="4134950"/>
-            <a:ext cx="1355834" cy="504000"/>
-          </a:xfrm>
-          <a:prstGeom prst="rect">
-            <a:avLst/>
-          </a:prstGeom>
-          <a:solidFill>
-            <a:schemeClr val="tx2">
-              <a:lumMod val="25000"/>
-              <a:lumOff val="75000"/>
-            </a:schemeClr>
-          </a:solidFill>
-        </p:spPr>
-        <p:style>
-          <a:lnRef idx="2">
-            <a:schemeClr val="accent1">
-              <a:shade val="15000"/>
-            </a:schemeClr>
-          </a:lnRef>
-          <a:fillRef idx="1">
-            <a:schemeClr val="accent1"/>
-          </a:fillRef>
-          <a:effectRef idx="0">
-            <a:schemeClr val="accent1"/>
-          </a:effectRef>
-          <a:fontRef idx="minor">
-            <a:schemeClr val="lt1"/>
-          </a:fontRef>
-        </p:style>
-        <p:txBody>
-          <a:bodyPr rtlCol="0" anchor="ctr"/>
-          <a:lstStyle>
-            <a:defPPr>
-              <a:defRPr lang="en-TH"/>
-            </a:defPPr>
-            <a:lvl1pPr marL="0" algn="l" defTabSz="914400" rtl="0" eaLnBrk="1" latinLnBrk="0" hangingPunct="1">
-              <a:defRPr sz="1800" kern="1200">
-                <a:solidFill>
-                  <a:schemeClr val="lt1"/>
-                </a:solidFill>
-                <a:latin typeface="+mn-lt"/>
-                <a:ea typeface="+mn-ea"/>
-                <a:cs typeface="+mn-cs"/>
-              </a:defRPr>
-            </a:lvl1pPr>
-            <a:lvl2pPr marL="457200" algn="l" defTabSz="914400" rtl="0" eaLnBrk="1" latinLnBrk="0" hangingPunct="1">
-              <a:defRPr sz="1800" kern="1200">
-                <a:solidFill>
-                  <a:schemeClr val="lt1"/>
-                </a:solidFill>
-                <a:latin typeface="+mn-lt"/>
-                <a:ea typeface="+mn-ea"/>
-                <a:cs typeface="+mn-cs"/>
-              </a:defRPr>
-            </a:lvl2pPr>
-            <a:lvl3pPr marL="914400" algn="l" defTabSz="914400" rtl="0" eaLnBrk="1" latinLnBrk="0" hangingPunct="1">
-              <a:defRPr sz="1800" kern="1200">
-                <a:solidFill>
-                  <a:schemeClr val="lt1"/>
-                </a:solidFill>
-                <a:latin typeface="+mn-lt"/>
-                <a:ea typeface="+mn-ea"/>
-                <a:cs typeface="+mn-cs"/>
-              </a:defRPr>
-            </a:lvl3pPr>
-            <a:lvl4pPr marL="1371600" algn="l" defTabSz="914400" rtl="0" eaLnBrk="1" latinLnBrk="0" hangingPunct="1">
-              <a:defRPr sz="1800" kern="1200">
-                <a:solidFill>
-                  <a:schemeClr val="lt1"/>
-                </a:solidFill>
-                <a:latin typeface="+mn-lt"/>
-                <a:ea typeface="+mn-ea"/>
-                <a:cs typeface="+mn-cs"/>
-              </a:defRPr>
-            </a:lvl4pPr>
-            <a:lvl5pPr marL="1828800" algn="l" defTabSz="914400" rtl="0" eaLnBrk="1" latinLnBrk="0" hangingPunct="1">
-              <a:defRPr sz="1800" kern="1200">
-                <a:solidFill>
-                  <a:schemeClr val="lt1"/>
-                </a:solidFill>
-                <a:latin typeface="+mn-lt"/>
-                <a:ea typeface="+mn-ea"/>
-                <a:cs typeface="+mn-cs"/>
-              </a:defRPr>
-            </a:lvl5pPr>
-            <a:lvl6pPr marL="2286000" algn="l" defTabSz="914400" rtl="0" eaLnBrk="1" latinLnBrk="0" hangingPunct="1">
-              <a:defRPr sz="1800" kern="1200">
-                <a:solidFill>
-                  <a:schemeClr val="lt1"/>
-                </a:solidFill>
-                <a:latin typeface="+mn-lt"/>
-                <a:ea typeface="+mn-ea"/>
-                <a:cs typeface="+mn-cs"/>
-              </a:defRPr>
-            </a:lvl6pPr>
-            <a:lvl7pPr marL="2743200" algn="l" defTabSz="914400" rtl="0" eaLnBrk="1" latinLnBrk="0" hangingPunct="1">
-              <a:defRPr sz="1800" kern="1200">
-                <a:solidFill>
-                  <a:schemeClr val="lt1"/>
-                </a:solidFill>
-                <a:latin typeface="+mn-lt"/>
-                <a:ea typeface="+mn-ea"/>
-                <a:cs typeface="+mn-cs"/>
-              </a:defRPr>
-            </a:lvl7pPr>
-            <a:lvl8pPr marL="3200400" algn="l" defTabSz="914400" rtl="0" eaLnBrk="1" latinLnBrk="0" hangingPunct="1">
-              <a:defRPr sz="1800" kern="1200">
-                <a:solidFill>
-                  <a:schemeClr val="lt1"/>
-                </a:solidFill>
-                <a:latin typeface="+mn-lt"/>
-                <a:ea typeface="+mn-ea"/>
-                <a:cs typeface="+mn-cs"/>
-              </a:defRPr>
-            </a:lvl8pPr>
-            <a:lvl9pPr marL="3657600" algn="l" defTabSz="914400" rtl="0" eaLnBrk="1" latinLnBrk="0" hangingPunct="1">
-              <a:defRPr sz="1800" kern="1200">
-                <a:solidFill>
-                  <a:schemeClr val="lt1"/>
-                </a:solidFill>
-                <a:latin typeface="+mn-lt"/>
-                <a:ea typeface="+mn-ea"/>
-                <a:cs typeface="+mn-cs"/>
-              </a:defRPr>
-            </a:lvl9pPr>
-          </a:lstStyle>
-          <a:p>
-            <a:pPr marL="0" marR="0" lvl="0" indent="0" algn="ctr" defTabSz="914400" rtl="0" eaLnBrk="1" fontAlgn="auto" latinLnBrk="0" hangingPunct="1">
-              <a:lnSpc>
-                <a:spcPct val="100000"/>
-              </a:lnSpc>
-              <a:spcBef>
-                <a:spcPts val="0"/>
-              </a:spcBef>
-              <a:spcAft>
-                <a:spcPts val="0"/>
-              </a:spcAft>
-              <a:buClrTx/>
-              <a:buSzTx/>
-              <a:buFontTx/>
-              <a:buNone/>
-              <a:tabLst/>
-              <a:defRPr/>
-            </a:pPr>
-            <a:r>
-              <a:rPr kumimoji="0" lang="en-US" sz="1000" b="0" i="0" u="none" strike="noStrike" kern="1200" cap="none" spc="0" normalizeH="0" baseline="0" noProof="0" dirty="0">
-                <a:ln>
-                  <a:noFill/>
-                </a:ln>
-                <a:solidFill>
-                  <a:srgbClr val="272428"/>
-                </a:solidFill>
-                <a:effectLst/>
-                <a:uLnTx/>
-                <a:uFillTx/>
-                <a:latin typeface="Poppins Light"/>
-                <a:ea typeface="+mn-ea"/>
-                <a:cs typeface="Sarabun Light"/>
-              </a:rPr>
-              <a:t>Students.csv</a:t>
-            </a:r>
-            <a:endParaRPr kumimoji="0" lang="en-TH" sz="1000" b="0" i="0" u="none" strike="noStrike" kern="1200" cap="none" spc="0" normalizeH="0" baseline="0" noProof="0" dirty="0">
-              <a:ln>
-                <a:noFill/>
-              </a:ln>
-              <a:solidFill>
-                <a:srgbClr val="272428"/>
-              </a:solidFill>
-              <a:effectLst/>
-              <a:uLnTx/>
-              <a:uFillTx/>
-              <a:latin typeface="Poppins Light"/>
-              <a:ea typeface="+mn-ea"/>
-              <a:cs typeface="Sarabun Light"/>
-            </a:endParaRPr>
-          </a:p>
-        </p:txBody>
-      </p:sp>
-      <p:sp>
-        <p:nvSpPr>
-          <p:cNvPr id="48" name="Rectangle 47">
-            <a:extLst>
-              <a:ext uri="{FF2B5EF4-FFF2-40B4-BE49-F238E27FC236}">
-                <a16:creationId xmlns:a16="http://schemas.microsoft.com/office/drawing/2014/main" id="{6ECDE6DC-B4A8-04C0-5503-190D811805EF}"/>
-              </a:ext>
-            </a:extLst>
-          </p:cNvPr>
-          <p:cNvSpPr/>
-          <p:nvPr/>
-        </p:nvSpPr>
-        <p:spPr>
-          <a:xfrm>
-            <a:off x="1265795" y="2818750"/>
-            <a:ext cx="1355834" cy="504000"/>
-          </a:xfrm>
-          <a:prstGeom prst="rect">
-            <a:avLst/>
-          </a:prstGeom>
-          <a:solidFill>
-            <a:schemeClr val="tx2">
-              <a:lumMod val="25000"/>
-              <a:lumOff val="75000"/>
-            </a:schemeClr>
-          </a:solidFill>
-        </p:spPr>
-        <p:style>
-          <a:lnRef idx="2">
-            <a:schemeClr val="accent1">
-              <a:shade val="15000"/>
-            </a:schemeClr>
-          </a:lnRef>
-          <a:fillRef idx="1">
-            <a:schemeClr val="accent1"/>
-          </a:fillRef>
-          <a:effectRef idx="0">
-            <a:schemeClr val="accent1"/>
-          </a:effectRef>
-          <a:fontRef idx="minor">
-            <a:schemeClr val="lt1"/>
-          </a:fontRef>
-        </p:style>
-        <p:txBody>
-          <a:bodyPr rtlCol="0" anchor="ctr"/>
-          <a:lstStyle>
-            <a:defPPr>
-              <a:defRPr lang="en-TH"/>
-            </a:defPPr>
-            <a:lvl1pPr marL="0" algn="l" defTabSz="914400" rtl="0" eaLnBrk="1" latinLnBrk="0" hangingPunct="1">
-              <a:defRPr sz="1800" kern="1200">
-                <a:solidFill>
-                  <a:schemeClr val="lt1"/>
-                </a:solidFill>
-                <a:latin typeface="+mn-lt"/>
-                <a:ea typeface="+mn-ea"/>
-                <a:cs typeface="+mn-cs"/>
-              </a:defRPr>
-            </a:lvl1pPr>
-            <a:lvl2pPr marL="457200" algn="l" defTabSz="914400" rtl="0" eaLnBrk="1" latinLnBrk="0" hangingPunct="1">
-              <a:defRPr sz="1800" kern="1200">
-                <a:solidFill>
-                  <a:schemeClr val="lt1"/>
-                </a:solidFill>
-                <a:latin typeface="+mn-lt"/>
-                <a:ea typeface="+mn-ea"/>
-                <a:cs typeface="+mn-cs"/>
-              </a:defRPr>
-            </a:lvl2pPr>
-            <a:lvl3pPr marL="914400" algn="l" defTabSz="914400" rtl="0" eaLnBrk="1" latinLnBrk="0" hangingPunct="1">
-              <a:defRPr sz="1800" kern="1200">
-                <a:solidFill>
-                  <a:schemeClr val="lt1"/>
-                </a:solidFill>
-                <a:latin typeface="+mn-lt"/>
-                <a:ea typeface="+mn-ea"/>
-                <a:cs typeface="+mn-cs"/>
-              </a:defRPr>
-            </a:lvl3pPr>
-            <a:lvl4pPr marL="1371600" algn="l" defTabSz="914400" rtl="0" eaLnBrk="1" latinLnBrk="0" hangingPunct="1">
-              <a:defRPr sz="1800" kern="1200">
-                <a:solidFill>
-                  <a:schemeClr val="lt1"/>
-                </a:solidFill>
-                <a:latin typeface="+mn-lt"/>
-                <a:ea typeface="+mn-ea"/>
-                <a:cs typeface="+mn-cs"/>
-              </a:defRPr>
-            </a:lvl4pPr>
-            <a:lvl5pPr marL="1828800" algn="l" defTabSz="914400" rtl="0" eaLnBrk="1" latinLnBrk="0" hangingPunct="1">
-              <a:defRPr sz="1800" kern="1200">
-                <a:solidFill>
-                  <a:schemeClr val="lt1"/>
-                </a:solidFill>
-                <a:latin typeface="+mn-lt"/>
-                <a:ea typeface="+mn-ea"/>
-                <a:cs typeface="+mn-cs"/>
-              </a:defRPr>
-            </a:lvl5pPr>
-            <a:lvl6pPr marL="2286000" algn="l" defTabSz="914400" rtl="0" eaLnBrk="1" latinLnBrk="0" hangingPunct="1">
-              <a:defRPr sz="1800" kern="1200">
-                <a:solidFill>
-                  <a:schemeClr val="lt1"/>
-                </a:solidFill>
-                <a:latin typeface="+mn-lt"/>
-                <a:ea typeface="+mn-ea"/>
-                <a:cs typeface="+mn-cs"/>
-              </a:defRPr>
-            </a:lvl6pPr>
-            <a:lvl7pPr marL="2743200" algn="l" defTabSz="914400" rtl="0" eaLnBrk="1" latinLnBrk="0" hangingPunct="1">
-              <a:defRPr sz="1800" kern="1200">
-                <a:solidFill>
-                  <a:schemeClr val="lt1"/>
-                </a:solidFill>
-                <a:latin typeface="+mn-lt"/>
-                <a:ea typeface="+mn-ea"/>
-                <a:cs typeface="+mn-cs"/>
-              </a:defRPr>
-            </a:lvl7pPr>
-            <a:lvl8pPr marL="3200400" algn="l" defTabSz="914400" rtl="0" eaLnBrk="1" latinLnBrk="0" hangingPunct="1">
-              <a:defRPr sz="1800" kern="1200">
-                <a:solidFill>
-                  <a:schemeClr val="lt1"/>
-                </a:solidFill>
-                <a:latin typeface="+mn-lt"/>
-                <a:ea typeface="+mn-ea"/>
-                <a:cs typeface="+mn-cs"/>
-              </a:defRPr>
-            </a:lvl8pPr>
-            <a:lvl9pPr marL="3657600" algn="l" defTabSz="914400" rtl="0" eaLnBrk="1" latinLnBrk="0" hangingPunct="1">
-              <a:defRPr sz="1800" kern="1200">
-                <a:solidFill>
-                  <a:schemeClr val="lt1"/>
-                </a:solidFill>
-                <a:latin typeface="+mn-lt"/>
-                <a:ea typeface="+mn-ea"/>
-                <a:cs typeface="+mn-cs"/>
-              </a:defRPr>
-            </a:lvl9pPr>
-          </a:lstStyle>
-          <a:p>
-            <a:pPr marL="0" marR="0" lvl="0" indent="0" algn="ctr" defTabSz="914400" rtl="0" eaLnBrk="1" fontAlgn="auto" latinLnBrk="0" hangingPunct="1">
-              <a:lnSpc>
-                <a:spcPct val="100000"/>
-              </a:lnSpc>
-              <a:spcBef>
-                <a:spcPts val="0"/>
-              </a:spcBef>
-              <a:spcAft>
-                <a:spcPts val="0"/>
-              </a:spcAft>
-              <a:buClrTx/>
-              <a:buSzTx/>
-              <a:buFontTx/>
-              <a:buNone/>
-              <a:tabLst/>
-              <a:defRPr/>
-            </a:pPr>
-            <a:r>
-              <a:rPr lang="en-US" sz="1000" dirty="0" err="1">
-                <a:solidFill>
-                  <a:srgbClr val="272428"/>
-                </a:solidFill>
-                <a:latin typeface="Poppins Light"/>
-                <a:cs typeface="Sarabun Light"/>
-              </a:rPr>
-              <a:t>feeds.jsonl</a:t>
-            </a:r>
-            <a:endParaRPr kumimoji="0" lang="en-TH" sz="1000" b="0" i="0" u="none" strike="noStrike" kern="1200" cap="none" spc="0" normalizeH="0" baseline="0" noProof="0" dirty="0">
-              <a:ln>
-                <a:noFill/>
-              </a:ln>
-              <a:solidFill>
-                <a:srgbClr val="272428"/>
-              </a:solidFill>
-              <a:effectLst/>
-              <a:uLnTx/>
-              <a:uFillTx/>
-              <a:latin typeface="Poppins Light"/>
-              <a:ea typeface="+mn-ea"/>
-              <a:cs typeface="Sarabun Light"/>
-            </a:endParaRPr>
-          </a:p>
-        </p:txBody>
-      </p:sp>
-      <p:pic>
-        <p:nvPicPr>
-          <p:cNvPr id="1026" name="Picture 2" descr="What Is BigQuery And How Do You Load Data Into It? - Seattle Data Guy">
-            <a:extLst>
-              <a:ext uri="{FF2B5EF4-FFF2-40B4-BE49-F238E27FC236}">
-                <a16:creationId xmlns:a16="http://schemas.microsoft.com/office/drawing/2014/main" id="{F9602F6A-EFA2-16D3-10D7-431656411664}"/>
-              </a:ext>
-            </a:extLst>
-          </p:cNvPr>
-          <p:cNvPicPr>
-            <a:picLocks noChangeAspect="1" noChangeArrowheads="1"/>
-          </p:cNvPicPr>
-          <p:nvPr/>
-        </p:nvPicPr>
-        <p:blipFill>
-          <a:blip r:embed="rId2">
-            <a:extLst>
-              <a:ext uri="{28A0092B-C50C-407E-A947-70E740481C1C}">
-                <a14:useLocalDpi xmlns:a14="http://schemas.microsoft.com/office/drawing/2010/main" val="0"/>
-              </a:ext>
-            </a:extLst>
-          </a:blip>
-          <a:srcRect/>
-          <a:stretch>
-            <a:fillRect/>
-          </a:stretch>
-        </p:blipFill>
-        <p:spPr bwMode="auto">
-          <a:xfrm>
-            <a:off x="3338437" y="3136996"/>
-            <a:ext cx="2019300" cy="1135857"/>
-          </a:xfrm>
-          <a:prstGeom prst="rect">
-            <a:avLst/>
-          </a:prstGeom>
-          <a:noFill/>
-          <a:extLst>
-            <a:ext uri="{909E8E84-426E-40DD-AFC4-6F175D3DCCD1}">
-              <a14:hiddenFill xmlns:a14="http://schemas.microsoft.com/office/drawing/2010/main">
-                <a:solidFill>
-                  <a:srgbClr val="FFFFFF"/>
-                </a:solidFill>
-              </a14:hiddenFill>
-            </a:ext>
-          </a:extLst>
-        </p:spPr>
-      </p:pic>
-      <p:cxnSp>
-        <p:nvCxnSpPr>
-          <p:cNvPr id="3" name="Straight Arrow Connector 2">
-            <a:extLst>
-              <a:ext uri="{FF2B5EF4-FFF2-40B4-BE49-F238E27FC236}">
-                <a16:creationId xmlns:a16="http://schemas.microsoft.com/office/drawing/2014/main" id="{39E74994-9AB4-C632-1081-59D8C36CDD17}"/>
-              </a:ext>
-            </a:extLst>
-          </p:cNvPr>
-          <p:cNvCxnSpPr>
-            <a:cxnSpLocks/>
-          </p:cNvCxnSpPr>
-          <p:nvPr/>
-        </p:nvCxnSpPr>
-        <p:spPr>
-          <a:xfrm>
-            <a:off x="5514256" y="3704575"/>
-            <a:ext cx="272106" cy="0"/>
-          </a:xfrm>
-          <a:prstGeom prst="straightConnector1">
-            <a:avLst/>
-          </a:prstGeom>
-          <a:ln w="12700">
-            <a:solidFill>
-              <a:srgbClr val="C00000"/>
-            </a:solidFill>
-            <a:tailEnd type="triangle"/>
-          </a:ln>
-        </p:spPr>
-        <p:style>
-          <a:lnRef idx="2">
-            <a:schemeClr val="dk1"/>
-          </a:lnRef>
-          <a:fillRef idx="0">
-            <a:schemeClr val="dk1"/>
-          </a:fillRef>
-          <a:effectRef idx="1">
-            <a:schemeClr val="dk1"/>
-          </a:effectRef>
-          <a:fontRef idx="minor">
-            <a:schemeClr val="tx1"/>
-          </a:fontRef>
-        </p:style>
-      </p:cxnSp>
-      <p:pic>
-        <p:nvPicPr>
-          <p:cNvPr id="4" name="Picture 3">
-            <a:extLst>
-              <a:ext uri="{FF2B5EF4-FFF2-40B4-BE49-F238E27FC236}">
-                <a16:creationId xmlns:a16="http://schemas.microsoft.com/office/drawing/2014/main" id="{EE7BE979-4626-6F9B-335F-2560BD679BE6}"/>
-              </a:ext>
-            </a:extLst>
-          </p:cNvPr>
-          <p:cNvPicPr>
-            <a:picLocks noChangeAspect="1"/>
-          </p:cNvPicPr>
-          <p:nvPr/>
-        </p:nvPicPr>
-        <p:blipFill>
-          <a:blip r:embed="rId3">
-            <a:extLst>
-              <a:ext uri="{28A0092B-C50C-407E-A947-70E740481C1C}">
-                <a14:useLocalDpi xmlns:a14="http://schemas.microsoft.com/office/drawing/2010/main" val="0"/>
-              </a:ext>
-            </a:extLst>
-          </a:blip>
-          <a:stretch>
-            <a:fillRect/>
-          </a:stretch>
-        </p:blipFill>
-        <p:spPr>
-          <a:xfrm>
-            <a:off x="6096000" y="1468521"/>
-            <a:ext cx="5137039" cy="4472808"/>
-          </a:xfrm>
-          <a:prstGeom prst="rect">
-            <a:avLst/>
-          </a:prstGeom>
-        </p:spPr>
-      </p:pic>
-      <p:sp>
-        <p:nvSpPr>
-          <p:cNvPr id="2" name="Title 1">
-            <a:extLst>
-              <a:ext uri="{FF2B5EF4-FFF2-40B4-BE49-F238E27FC236}">
-                <a16:creationId xmlns:a16="http://schemas.microsoft.com/office/drawing/2014/main" id="{FD97EA77-AB81-EF31-E372-18A4CEAF26A8}"/>
-              </a:ext>
-            </a:extLst>
-          </p:cNvPr>
-          <p:cNvSpPr txBox="1">
-            <a:spLocks/>
-          </p:cNvSpPr>
-          <p:nvPr/>
-        </p:nvSpPr>
-        <p:spPr>
-          <a:xfrm>
-            <a:off x="365759" y="649487"/>
-            <a:ext cx="11183815" cy="528254"/>
-          </a:xfrm>
-          <a:prstGeom prst="rect">
-            <a:avLst/>
-          </a:prstGeom>
-        </p:spPr>
-        <p:txBody>
-          <a:bodyPr vert="horz" lIns="91440" tIns="45720" rIns="91440" bIns="45720" rtlCol="0" anchor="ctr">
-            <a:noAutofit/>
-          </a:bodyPr>
-          <a:lstStyle>
-            <a:lvl1pPr algn="ctr" defTabSz="914400" rtl="0" eaLnBrk="1" latinLnBrk="0" hangingPunct="1">
-              <a:lnSpc>
-                <a:spcPct val="90000"/>
-              </a:lnSpc>
-              <a:spcBef>
-                <a:spcPct val="0"/>
-              </a:spcBef>
-              <a:buNone/>
-              <a:defRPr sz="6000" kern="1200">
-                <a:solidFill>
-                  <a:schemeClr val="tx1"/>
-                </a:solidFill>
-                <a:latin typeface="+mj-lt"/>
-                <a:ea typeface="+mj-ea"/>
-                <a:cs typeface="+mj-cs"/>
-              </a:defRPr>
-            </a:lvl1pPr>
-          </a:lstStyle>
-          <a:p>
-            <a:r>
-              <a:rPr lang="en-US" sz="2400" dirty="0" err="1">
-                <a:cs typeface="Poppins Light"/>
-              </a:rPr>
-              <a:t>HyDE</a:t>
-            </a:r>
-            <a:r>
-              <a:rPr lang="en-US" sz="2400" dirty="0">
-                <a:cs typeface="Poppins Light"/>
-              </a:rPr>
-              <a:t> Feed Recommendation - </a:t>
-            </a:r>
-            <a:r>
-              <a:rPr lang="en-TH" sz="2400" dirty="0"/>
-              <a:t>System Overview</a:t>
-            </a:r>
-            <a:endParaRPr lang="en-US" sz="2400" dirty="0">
-              <a:cs typeface="Poppins Light"/>
-            </a:endParaRPr>
-          </a:p>
-        </p:txBody>
-      </p:sp>
-    </p:spTree>
-    <p:extLst>
-      <p:ext uri="{BB962C8B-B14F-4D97-AF65-F5344CB8AC3E}">
-        <p14:creationId xmlns:p14="http://schemas.microsoft.com/office/powerpoint/2010/main" val="2108206429"/>
-      </p:ext>
-    </p:extLst>
-  </p:cSld>
-  <p:clrMapOvr>
-    <a:masterClrMapping/>
-  </p:clrMapOvr>
-</p:sld>
-</file>
-
-<file path=ppt/slides/slide30.xml><?xml version="1.0" encoding="utf-8"?>
+<file path=ppt/slides/slide36.xml><?xml version="1.0" encoding="utf-8"?>
 <p:sld xmlns:a="http://schemas.openxmlformats.org/drawingml/2006/main" xmlns:r="http://schemas.openxmlformats.org/officeDocument/2006/relationships" xmlns:p="http://schemas.openxmlformats.org/presentationml/2006/main" show="0">
   <p:cSld>
     <p:spTree>
@@ -28552,7 +30192,7 @@
 </p:sld>
 </file>
 
-<file path=ppt/slides/slide31.xml><?xml version="1.0" encoding="utf-8"?>
+<file path=ppt/slides/slide37.xml><?xml version="1.0" encoding="utf-8"?>
 <p:sld xmlns:a="http://schemas.openxmlformats.org/drawingml/2006/main" xmlns:r="http://schemas.openxmlformats.org/officeDocument/2006/relationships" xmlns:p="http://schemas.openxmlformats.org/presentationml/2006/main" show="0">
   <p:cSld>
     <p:spTree>
@@ -28812,7 +30452,7 @@
 </p:sld>
 </file>
 
-<file path=ppt/slides/slide32.xml><?xml version="1.0" encoding="utf-8"?>
+<file path=ppt/slides/slide38.xml><?xml version="1.0" encoding="utf-8"?>
 <p:sld xmlns:a="http://schemas.openxmlformats.org/drawingml/2006/main" xmlns:r="http://schemas.openxmlformats.org/officeDocument/2006/relationships" xmlns:p="http://schemas.openxmlformats.org/presentationml/2006/main" show="0">
   <p:cSld>
     <p:spTree>

</xml_diff>

<commit_message>
feat(embedding) : align main pipeline with update embedding vector format
</commit_message>
<xml_diff>
--- a/logs/Ghostdeck.pptx
+++ b/logs/Ghostdeck.pptx
@@ -5,7 +5,7 @@
     <p:sldMasterId id="2147483648" r:id="rId1"/>
   </p:sldMasterIdLst>
   <p:notesMasterIdLst>
-    <p:notesMasterId r:id="rId46"/>
+    <p:notesMasterId r:id="rId47"/>
   </p:notesMasterIdLst>
   <p:sldIdLst>
     <p:sldId id="2147481407" r:id="rId2"/>
@@ -30,28 +30,29 @@
     <p:sldId id="2147481412" r:id="rId21"/>
     <p:sldId id="2147481455" r:id="rId22"/>
     <p:sldId id="2147481457" r:id="rId23"/>
-    <p:sldId id="2147481458" r:id="rId24"/>
-    <p:sldId id="2147481454" r:id="rId25"/>
-    <p:sldId id="2147481456" r:id="rId26"/>
-    <p:sldId id="2147481453" r:id="rId27"/>
-    <p:sldId id="2147481452" r:id="rId28"/>
-    <p:sldId id="2147481446" r:id="rId29"/>
-    <p:sldId id="2147481449" r:id="rId30"/>
-    <p:sldId id="2147481448" r:id="rId31"/>
-    <p:sldId id="2147481447" r:id="rId32"/>
-    <p:sldId id="2147481451" r:id="rId33"/>
-    <p:sldId id="2147481450" r:id="rId34"/>
-    <p:sldId id="2147481445" r:id="rId35"/>
-    <p:sldId id="2147481413" r:id="rId36"/>
-    <p:sldId id="2147481419" r:id="rId37"/>
-    <p:sldId id="2147481427" r:id="rId38"/>
-    <p:sldId id="2147481422" r:id="rId39"/>
-    <p:sldId id="2147481423" r:id="rId40"/>
-    <p:sldId id="2147481425" r:id="rId41"/>
-    <p:sldId id="2147481426" r:id="rId42"/>
-    <p:sldId id="2147481429" r:id="rId43"/>
-    <p:sldId id="2147481428" r:id="rId44"/>
-    <p:sldId id="2147481430" r:id="rId45"/>
+    <p:sldId id="2147481459" r:id="rId24"/>
+    <p:sldId id="2147481458" r:id="rId25"/>
+    <p:sldId id="2147481454" r:id="rId26"/>
+    <p:sldId id="2147481456" r:id="rId27"/>
+    <p:sldId id="2147481453" r:id="rId28"/>
+    <p:sldId id="2147481452" r:id="rId29"/>
+    <p:sldId id="2147481446" r:id="rId30"/>
+    <p:sldId id="2147481449" r:id="rId31"/>
+    <p:sldId id="2147481448" r:id="rId32"/>
+    <p:sldId id="2147481447" r:id="rId33"/>
+    <p:sldId id="2147481451" r:id="rId34"/>
+    <p:sldId id="2147481450" r:id="rId35"/>
+    <p:sldId id="2147481445" r:id="rId36"/>
+    <p:sldId id="2147481413" r:id="rId37"/>
+    <p:sldId id="2147481419" r:id="rId38"/>
+    <p:sldId id="2147481427" r:id="rId39"/>
+    <p:sldId id="2147481422" r:id="rId40"/>
+    <p:sldId id="2147481423" r:id="rId41"/>
+    <p:sldId id="2147481425" r:id="rId42"/>
+    <p:sldId id="2147481426" r:id="rId43"/>
+    <p:sldId id="2147481429" r:id="rId44"/>
+    <p:sldId id="2147481428" r:id="rId45"/>
+    <p:sldId id="2147481430" r:id="rId46"/>
   </p:sldIdLst>
   <p:sldSz cx="12192000" cy="6858000"/>
   <p:notesSz cx="6858000" cy="9144000"/>
@@ -240,7 +241,7 @@
           <a:p>
             <a:fld id="{6D077408-611F-43B7-A58B-066AB354FAB6}" type="datetimeFigureOut">
               <a:rPr lang="en-US" smtClean="0"/>
-              <a:t>2/6/2026</a:t>
+              <a:t>2/9/2026</a:t>
             </a:fld>
             <a:endParaRPr lang="en-US"/>
           </a:p>
@@ -1256,7 +1257,7 @@
           <a:p>
             <a:fld id="{5744687F-F839-4783-9AA2-9E2F10A9DB4B}" type="slidenum">
               <a:rPr lang="en-US" smtClean="0"/>
-              <a:t>30</a:t>
+              <a:t>31</a:t>
             </a:fld>
             <a:endParaRPr lang="en-US"/>
           </a:p>
@@ -1422,7 +1423,7 @@
           <a:p>
             <a:fld id="{9DA1BED4-5DFC-4D8B-BC40-12FD5FE4AB0F}" type="datetimeFigureOut">
               <a:rPr lang="en-US" smtClean="0"/>
-              <a:t>2/6/2026</a:t>
+              <a:t>2/9/2026</a:t>
             </a:fld>
             <a:endParaRPr lang="en-US"/>
           </a:p>
@@ -1620,7 +1621,7 @@
           <a:p>
             <a:fld id="{9DA1BED4-5DFC-4D8B-BC40-12FD5FE4AB0F}" type="datetimeFigureOut">
               <a:rPr lang="en-US" smtClean="0"/>
-              <a:t>2/6/2026</a:t>
+              <a:t>2/9/2026</a:t>
             </a:fld>
             <a:endParaRPr lang="en-US"/>
           </a:p>
@@ -1828,7 +1829,7 @@
           <a:p>
             <a:fld id="{9DA1BED4-5DFC-4D8B-BC40-12FD5FE4AB0F}" type="datetimeFigureOut">
               <a:rPr lang="en-US" smtClean="0"/>
-              <a:t>2/6/2026</a:t>
+              <a:t>2/9/2026</a:t>
             </a:fld>
             <a:endParaRPr lang="en-US"/>
           </a:p>
@@ -2257,7 +2258,7 @@
           <a:p>
             <a:fld id="{9DA1BED4-5DFC-4D8B-BC40-12FD5FE4AB0F}" type="datetimeFigureOut">
               <a:rPr lang="en-US" smtClean="0"/>
-              <a:t>2/6/2026</a:t>
+              <a:t>2/9/2026</a:t>
             </a:fld>
             <a:endParaRPr lang="en-US"/>
           </a:p>
@@ -2532,7 +2533,7 @@
           <a:p>
             <a:fld id="{9DA1BED4-5DFC-4D8B-BC40-12FD5FE4AB0F}" type="datetimeFigureOut">
               <a:rPr lang="en-US" smtClean="0"/>
-              <a:t>2/6/2026</a:t>
+              <a:t>2/9/2026</a:t>
             </a:fld>
             <a:endParaRPr lang="en-US"/>
           </a:p>
@@ -2797,7 +2798,7 @@
           <a:p>
             <a:fld id="{9DA1BED4-5DFC-4D8B-BC40-12FD5FE4AB0F}" type="datetimeFigureOut">
               <a:rPr lang="en-US" smtClean="0"/>
-              <a:t>2/6/2026</a:t>
+              <a:t>2/9/2026</a:t>
             </a:fld>
             <a:endParaRPr lang="en-US"/>
           </a:p>
@@ -3209,7 +3210,7 @@
           <a:p>
             <a:fld id="{9DA1BED4-5DFC-4D8B-BC40-12FD5FE4AB0F}" type="datetimeFigureOut">
               <a:rPr lang="en-US" smtClean="0"/>
-              <a:t>2/6/2026</a:t>
+              <a:t>2/9/2026</a:t>
             </a:fld>
             <a:endParaRPr lang="en-US"/>
           </a:p>
@@ -3350,7 +3351,7 @@
           <a:p>
             <a:fld id="{9DA1BED4-5DFC-4D8B-BC40-12FD5FE4AB0F}" type="datetimeFigureOut">
               <a:rPr lang="en-US" smtClean="0"/>
-              <a:t>2/6/2026</a:t>
+              <a:t>2/9/2026</a:t>
             </a:fld>
             <a:endParaRPr lang="en-US"/>
           </a:p>
@@ -3463,7 +3464,7 @@
           <a:p>
             <a:fld id="{9DA1BED4-5DFC-4D8B-BC40-12FD5FE4AB0F}" type="datetimeFigureOut">
               <a:rPr lang="en-US" smtClean="0"/>
-              <a:t>2/6/2026</a:t>
+              <a:t>2/9/2026</a:t>
             </a:fld>
             <a:endParaRPr lang="en-US"/>
           </a:p>
@@ -3774,7 +3775,7 @@
           <a:p>
             <a:fld id="{9DA1BED4-5DFC-4D8B-BC40-12FD5FE4AB0F}" type="datetimeFigureOut">
               <a:rPr lang="en-US" smtClean="0"/>
-              <a:t>2/6/2026</a:t>
+              <a:t>2/9/2026</a:t>
             </a:fld>
             <a:endParaRPr lang="en-US"/>
           </a:p>
@@ -4062,7 +4063,7 @@
           <a:p>
             <a:fld id="{9DA1BED4-5DFC-4D8B-BC40-12FD5FE4AB0F}" type="datetimeFigureOut">
               <a:rPr lang="en-US" smtClean="0"/>
-              <a:t>2/6/2026</a:t>
+              <a:t>2/9/2026</a:t>
             </a:fld>
             <a:endParaRPr lang="en-US"/>
           </a:p>
@@ -4303,7 +4304,7 @@
           <a:p>
             <a:fld id="{9DA1BED4-5DFC-4D8B-BC40-12FD5FE4AB0F}" type="datetimeFigureOut">
               <a:rPr lang="en-US" smtClean="0"/>
-              <a:t>2/6/2026</a:t>
+              <a:t>2/9/2026</a:t>
             </a:fld>
             <a:endParaRPr lang="en-US"/>
           </a:p>
@@ -5582,6 +5583,42 @@
             <a:endParaRPr lang="en-US" sz="2400" dirty="0">
               <a:cs typeface="Poppins Light"/>
             </a:endParaRPr>
+          </a:p>
+        </p:txBody>
+      </p:sp>
+      <p:sp>
+        <p:nvSpPr>
+          <p:cNvPr id="3" name="TextBox 2">
+            <a:hlinkClick r:id="rId2"/>
+            <a:extLst>
+              <a:ext uri="{FF2B5EF4-FFF2-40B4-BE49-F238E27FC236}">
+                <a16:creationId xmlns:a16="http://schemas.microsoft.com/office/drawing/2014/main" id="{4E1EF699-73EC-2CCB-A383-D6BDA02C90D7}"/>
+              </a:ext>
+            </a:extLst>
+          </p:cNvPr>
+          <p:cNvSpPr txBox="1"/>
+          <p:nvPr/>
+        </p:nvSpPr>
+        <p:spPr>
+          <a:xfrm>
+            <a:off x="5581601" y="3429000"/>
+            <a:ext cx="752129" cy="369332"/>
+          </a:xfrm>
+          <a:prstGeom prst="rect">
+            <a:avLst/>
+          </a:prstGeom>
+          <a:noFill/>
+        </p:spPr>
+        <p:txBody>
+          <a:bodyPr wrap="none" rtlCol="0">
+            <a:spAutoFit/>
+          </a:bodyPr>
+          <a:lstStyle/>
+          <a:p>
+            <a:r>
+              <a:rPr lang="en-US" dirty="0"/>
+              <a:t>Video</a:t>
+            </a:r>
           </a:p>
         </p:txBody>
       </p:sp>
@@ -24815,10 +24852,145 @@
       </p:sp>
       <p:pic>
         <p:nvPicPr>
+          <p:cNvPr id="4" name="Picture 3">
+            <a:extLst>
+              <a:ext uri="{FF2B5EF4-FFF2-40B4-BE49-F238E27FC236}">
+                <a16:creationId xmlns:a16="http://schemas.microsoft.com/office/drawing/2014/main" id="{B983A8E7-06DE-BDA1-2797-41DB50CB64D4}"/>
+              </a:ext>
+            </a:extLst>
+          </p:cNvPr>
+          <p:cNvPicPr>
+            <a:picLocks noChangeAspect="1"/>
+          </p:cNvPicPr>
+          <p:nvPr/>
+        </p:nvPicPr>
+        <p:blipFill>
+          <a:blip r:embed="rId2"/>
+          <a:stretch>
+            <a:fillRect/>
+          </a:stretch>
+        </p:blipFill>
+        <p:spPr>
+          <a:xfrm>
+            <a:off x="9891796" y="1177742"/>
+            <a:ext cx="1246970" cy="5680258"/>
+          </a:xfrm>
+          <a:prstGeom prst="rect">
+            <a:avLst/>
+          </a:prstGeom>
+        </p:spPr>
+      </p:pic>
+    </p:spTree>
+    <p:extLst>
+      <p:ext uri="{BB962C8B-B14F-4D97-AF65-F5344CB8AC3E}">
+        <p14:creationId xmlns:p14="http://schemas.microsoft.com/office/powerpoint/2010/main" val="894645065"/>
+      </p:ext>
+    </p:extLst>
+  </p:cSld>
+  <p:clrMapOvr>
+    <a:masterClrMapping/>
+  </p:clrMapOvr>
+</p:sld>
+</file>
+
+<file path=ppt/slides/slide23.xml><?xml version="1.0" encoding="utf-8"?>
+<p:sld xmlns:a="http://schemas.openxmlformats.org/drawingml/2006/main" xmlns:r="http://schemas.openxmlformats.org/officeDocument/2006/relationships" xmlns:p="http://schemas.openxmlformats.org/presentationml/2006/main">
+  <p:cSld>
+    <p:spTree>
+      <p:nvGrpSpPr>
+        <p:cNvPr id="1" name="">
+          <a:extLst>
+            <a:ext uri="{FF2B5EF4-FFF2-40B4-BE49-F238E27FC236}">
+              <a16:creationId xmlns:a16="http://schemas.microsoft.com/office/drawing/2014/main" id="{26B1E5E4-2CE7-3F8F-D1BA-65872A250E07}"/>
+            </a:ext>
+          </a:extLst>
+        </p:cNvPr>
+        <p:cNvGrpSpPr/>
+        <p:nvPr/>
+      </p:nvGrpSpPr>
+      <p:grpSpPr>
+        <a:xfrm>
+          <a:off x="0" y="0"/>
+          <a:ext cx="0" cy="0"/>
+          <a:chOff x="0" y="0"/>
+          <a:chExt cx="0" cy="0"/>
+        </a:xfrm>
+      </p:grpSpPr>
+      <p:sp>
+        <p:nvSpPr>
+          <p:cNvPr id="2" name="Title 1">
+            <a:extLst>
+              <a:ext uri="{FF2B5EF4-FFF2-40B4-BE49-F238E27FC236}">
+                <a16:creationId xmlns:a16="http://schemas.microsoft.com/office/drawing/2014/main" id="{0B05CEBD-4008-AA8C-CE34-E2F31FDEF0A5}"/>
+              </a:ext>
+            </a:extLst>
+          </p:cNvPr>
+          <p:cNvSpPr txBox="1">
+            <a:spLocks/>
+          </p:cNvSpPr>
+          <p:nvPr/>
+        </p:nvSpPr>
+        <p:spPr>
+          <a:xfrm>
+            <a:off x="365759" y="649487"/>
+            <a:ext cx="11183815" cy="528254"/>
+          </a:xfrm>
+          <a:prstGeom prst="rect">
+            <a:avLst/>
+          </a:prstGeom>
+        </p:spPr>
+        <p:txBody>
+          <a:bodyPr vert="horz" lIns="91440" tIns="45720" rIns="91440" bIns="45720" rtlCol="0" anchor="ctr">
+            <a:noAutofit/>
+          </a:bodyPr>
+          <a:lstStyle>
+            <a:lvl1pPr algn="ctr" defTabSz="914400" rtl="0" eaLnBrk="1" latinLnBrk="0" hangingPunct="1">
+              <a:lnSpc>
+                <a:spcPct val="90000"/>
+              </a:lnSpc>
+              <a:spcBef>
+                <a:spcPct val="0"/>
+              </a:spcBef>
+              <a:buNone/>
+              <a:defRPr sz="6000" kern="1200">
+                <a:solidFill>
+                  <a:schemeClr val="tx1"/>
+                </a:solidFill>
+                <a:latin typeface="+mj-lt"/>
+                <a:ea typeface="+mj-ea"/>
+                <a:cs typeface="+mj-cs"/>
+              </a:defRPr>
+            </a:lvl1pPr>
+          </a:lstStyle>
+          <a:p>
+            <a:r>
+              <a:rPr lang="en-US" sz="2400" dirty="0" err="1">
+                <a:cs typeface="Poppins Light"/>
+              </a:rPr>
+              <a:t>HyDE</a:t>
+            </a:r>
+            <a:r>
+              <a:rPr lang="en-US" sz="2400" dirty="0">
+                <a:cs typeface="Poppins Light"/>
+              </a:rPr>
+              <a:t> Feed Recommendation - </a:t>
+            </a:r>
+            <a:r>
+              <a:rPr lang="en-US" sz="2400" dirty="0"/>
+              <a:t>System Architecture &amp; Technology Stack</a:t>
+            </a:r>
+            <a:endParaRPr lang="en-US" sz="2400" dirty="0">
+              <a:cs typeface="Poppins Light"/>
+            </a:endParaRPr>
+          </a:p>
+        </p:txBody>
+      </p:sp>
+      <p:pic>
+        <p:nvPicPr>
           <p:cNvPr id="11" name="Picture 10">
             <a:extLst>
               <a:ext uri="{FF2B5EF4-FFF2-40B4-BE49-F238E27FC236}">
-                <a16:creationId xmlns:a16="http://schemas.microsoft.com/office/drawing/2014/main" id="{D21C0A0C-BD26-ACC3-6D40-C27EA35324DE}"/>
+                <a16:creationId xmlns:a16="http://schemas.microsoft.com/office/drawing/2014/main" id="{213C6912-8935-6BE6-2C0D-0A2C720EA9CB}"/>
               </a:ext>
             </a:extLst>
           </p:cNvPr>
@@ -24846,7 +25018,7 @@
     </p:spTree>
     <p:extLst>
       <p:ext uri="{BB962C8B-B14F-4D97-AF65-F5344CB8AC3E}">
-        <p14:creationId xmlns:p14="http://schemas.microsoft.com/office/powerpoint/2010/main" val="894645065"/>
+        <p14:creationId xmlns:p14="http://schemas.microsoft.com/office/powerpoint/2010/main" val="1857116386"/>
       </p:ext>
     </p:extLst>
   </p:cSld>
@@ -24856,7 +25028,7 @@
 </p:sld>
 </file>
 
-<file path=ppt/slides/slide23.xml><?xml version="1.0" encoding="utf-8"?>
+<file path=ppt/slides/slide24.xml><?xml version="1.0" encoding="utf-8"?>
 <p:sld xmlns:a="http://schemas.openxmlformats.org/drawingml/2006/main" xmlns:r="http://schemas.openxmlformats.org/officeDocument/2006/relationships" xmlns:p="http://schemas.openxmlformats.org/presentationml/2006/main">
   <p:cSld>
     <p:spTree>
@@ -24991,7 +25163,7 @@
 </p:sld>
 </file>
 
-<file path=ppt/slides/slide24.xml><?xml version="1.0" encoding="utf-8"?>
+<file path=ppt/slides/slide25.xml><?xml version="1.0" encoding="utf-8"?>
 <p:sld xmlns:a="http://schemas.openxmlformats.org/drawingml/2006/main" xmlns:r="http://schemas.openxmlformats.org/officeDocument/2006/relationships" xmlns:p="http://schemas.openxmlformats.org/presentationml/2006/main">
   <p:cSld>
     <p:spTree>
@@ -25126,7 +25298,7 @@
 </p:sld>
 </file>
 
-<file path=ppt/slides/slide25.xml><?xml version="1.0" encoding="utf-8"?>
+<file path=ppt/slides/slide26.xml><?xml version="1.0" encoding="utf-8"?>
 <p:sld xmlns:a="http://schemas.openxmlformats.org/drawingml/2006/main" xmlns:r="http://schemas.openxmlformats.org/officeDocument/2006/relationships" xmlns:p="http://schemas.openxmlformats.org/presentationml/2006/main">
   <p:cSld>
     <p:spTree>
@@ -25261,7 +25433,7 @@
 </p:sld>
 </file>
 
-<file path=ppt/slides/slide26.xml><?xml version="1.0" encoding="utf-8"?>
+<file path=ppt/slides/slide27.xml><?xml version="1.0" encoding="utf-8"?>
 <p:sld xmlns:a="http://schemas.openxmlformats.org/drawingml/2006/main" xmlns:r="http://schemas.openxmlformats.org/officeDocument/2006/relationships" xmlns:p="http://schemas.openxmlformats.org/presentationml/2006/main">
   <p:cSld>
     <p:spTree>
@@ -25549,7 +25721,7 @@
 </p:sld>
 </file>
 
-<file path=ppt/slides/slide27.xml><?xml version="1.0" encoding="utf-8"?>
+<file path=ppt/slides/slide28.xml><?xml version="1.0" encoding="utf-8"?>
 <p:sld xmlns:a="http://schemas.openxmlformats.org/drawingml/2006/main" xmlns:r="http://schemas.openxmlformats.org/officeDocument/2006/relationships" xmlns:p="http://schemas.openxmlformats.org/presentationml/2006/main">
   <p:cSld>
     <p:spTree>
@@ -25868,7 +26040,7 @@
 </p:sld>
 </file>
 
-<file path=ppt/slides/slide28.xml><?xml version="1.0" encoding="utf-8"?>
+<file path=ppt/slides/slide29.xml><?xml version="1.0" encoding="utf-8"?>
 <p:sld xmlns:a="http://schemas.openxmlformats.org/drawingml/2006/main" xmlns:r="http://schemas.openxmlformats.org/officeDocument/2006/relationships" xmlns:p="http://schemas.openxmlformats.org/presentationml/2006/main">
   <p:cSld>
     <p:spTree>
@@ -26056,159 +26228,6 @@
     <p:extLst>
       <p:ext uri="{BB962C8B-B14F-4D97-AF65-F5344CB8AC3E}">
         <p14:creationId xmlns:p14="http://schemas.microsoft.com/office/powerpoint/2010/main" val="2789201605"/>
-      </p:ext>
-    </p:extLst>
-  </p:cSld>
-  <p:clrMapOvr>
-    <a:masterClrMapping/>
-  </p:clrMapOvr>
-</p:sld>
-</file>
-
-<file path=ppt/slides/slide29.xml><?xml version="1.0" encoding="utf-8"?>
-<p:sld xmlns:a="http://schemas.openxmlformats.org/drawingml/2006/main" xmlns:r="http://schemas.openxmlformats.org/officeDocument/2006/relationships" xmlns:p="http://schemas.openxmlformats.org/presentationml/2006/main">
-  <p:cSld>
-    <p:spTree>
-      <p:nvGrpSpPr>
-        <p:cNvPr id="1" name="">
-          <a:extLst>
-            <a:ext uri="{FF2B5EF4-FFF2-40B4-BE49-F238E27FC236}">
-              <a16:creationId xmlns:a16="http://schemas.microsoft.com/office/drawing/2014/main" id="{093446A3-8D06-E2BD-3022-2CE52E77AB1B}"/>
-            </a:ext>
-          </a:extLst>
-        </p:cNvPr>
-        <p:cNvGrpSpPr/>
-        <p:nvPr/>
-      </p:nvGrpSpPr>
-      <p:grpSpPr>
-        <a:xfrm>
-          <a:off x="0" y="0"/>
-          <a:ext cx="0" cy="0"/>
-          <a:chOff x="0" y="0"/>
-          <a:chExt cx="0" cy="0"/>
-        </a:xfrm>
-      </p:grpSpPr>
-      <p:sp>
-        <p:nvSpPr>
-          <p:cNvPr id="2" name="Title 1">
-            <a:extLst>
-              <a:ext uri="{FF2B5EF4-FFF2-40B4-BE49-F238E27FC236}">
-                <a16:creationId xmlns:a16="http://schemas.microsoft.com/office/drawing/2014/main" id="{A2167554-4189-3912-5DD1-B564582E8F20}"/>
-              </a:ext>
-            </a:extLst>
-          </p:cNvPr>
-          <p:cNvSpPr>
-            <a:spLocks noGrp="1"/>
-          </p:cNvSpPr>
-          <p:nvPr>
-            <p:ph type="title"/>
-          </p:nvPr>
-        </p:nvSpPr>
-        <p:spPr>
-          <a:xfrm>
-            <a:off x="838200" y="365126"/>
-            <a:ext cx="10515600" cy="1126050"/>
-          </a:xfrm>
-        </p:spPr>
-        <p:txBody>
-          <a:bodyPr>
-            <a:normAutofit/>
-          </a:bodyPr>
-          <a:lstStyle/>
-          <a:p>
-            <a:r>
-              <a:rPr lang="en-US" dirty="0"/>
-              <a:t>Tue,050226</a:t>
-            </a:r>
-          </a:p>
-        </p:txBody>
-      </p:sp>
-      <p:sp>
-        <p:nvSpPr>
-          <p:cNvPr id="4" name="Content Placeholder 3">
-            <a:extLst>
-              <a:ext uri="{FF2B5EF4-FFF2-40B4-BE49-F238E27FC236}">
-                <a16:creationId xmlns:a16="http://schemas.microsoft.com/office/drawing/2014/main" id="{2D7CABDD-1BA0-72C5-A353-2A5C1F281EFE}"/>
-              </a:ext>
-            </a:extLst>
-          </p:cNvPr>
-          <p:cNvSpPr>
-            <a:spLocks noGrp="1"/>
-          </p:cNvSpPr>
-          <p:nvPr>
-            <p:ph idx="1"/>
-          </p:nvPr>
-        </p:nvSpPr>
-        <p:spPr>
-          <a:xfrm>
-            <a:off x="838200" y="1491175"/>
-            <a:ext cx="10515600" cy="4867422"/>
-          </a:xfrm>
-        </p:spPr>
-        <p:txBody>
-          <a:bodyPr>
-            <a:normAutofit/>
-          </a:bodyPr>
-          <a:lstStyle/>
-          <a:p>
-            <a:r>
-              <a:rPr lang="en-US" dirty="0"/>
-              <a:t>Done</a:t>
-            </a:r>
-          </a:p>
-          <a:p>
-            <a:pPr lvl="1"/>
-            <a:r>
-              <a:rPr lang="en-US" dirty="0"/>
-              <a:t>Read and understood the QA Test Plan for the CV Evaluation Pipeline link</a:t>
-            </a:r>
-          </a:p>
-          <a:p>
-            <a:r>
-              <a:rPr lang="en-US" dirty="0"/>
-              <a:t>Todo</a:t>
-            </a:r>
-          </a:p>
-          <a:p>
-            <a:pPr lvl="1"/>
-            <a:r>
-              <a:rPr lang="en-US" dirty="0"/>
-              <a:t>Plan tasks for Sprint 11 in Jira</a:t>
-            </a:r>
-          </a:p>
-          <a:p>
-            <a:pPr lvl="1"/>
-            <a:r>
-              <a:rPr lang="en-US" dirty="0"/>
-              <a:t>Develop pipeline to bundle data for each student (Pipeline_2_user_hyde_refresh.py)</a:t>
-            </a:r>
-          </a:p>
-          <a:p>
-            <a:r>
-              <a:rPr lang="en-US" dirty="0"/>
-              <a:t>Issue</a:t>
-            </a:r>
-          </a:p>
-          <a:p>
-            <a:pPr lvl="1"/>
-            <a:r>
-              <a:rPr lang="en-US" dirty="0"/>
-              <a:t> -</a:t>
-            </a:r>
-          </a:p>
-          <a:p>
-            <a:endParaRPr lang="en-US" dirty="0"/>
-          </a:p>
-          <a:p>
-            <a:pPr lvl="1"/>
-            <a:endParaRPr lang="en-US" dirty="0"/>
-          </a:p>
-        </p:txBody>
-      </p:sp>
-    </p:spTree>
-    <p:extLst>
-      <p:ext uri="{BB962C8B-B14F-4D97-AF65-F5344CB8AC3E}">
-        <p14:creationId xmlns:p14="http://schemas.microsoft.com/office/powerpoint/2010/main" val="2709007082"/>
       </p:ext>
     </p:extLst>
   </p:cSld>
@@ -27064,6 +27083,159 @@
 </file>
 
 <file path=ppt/slides/slide30.xml><?xml version="1.0" encoding="utf-8"?>
+<p:sld xmlns:a="http://schemas.openxmlformats.org/drawingml/2006/main" xmlns:r="http://schemas.openxmlformats.org/officeDocument/2006/relationships" xmlns:p="http://schemas.openxmlformats.org/presentationml/2006/main">
+  <p:cSld>
+    <p:spTree>
+      <p:nvGrpSpPr>
+        <p:cNvPr id="1" name="">
+          <a:extLst>
+            <a:ext uri="{FF2B5EF4-FFF2-40B4-BE49-F238E27FC236}">
+              <a16:creationId xmlns:a16="http://schemas.microsoft.com/office/drawing/2014/main" id="{093446A3-8D06-E2BD-3022-2CE52E77AB1B}"/>
+            </a:ext>
+          </a:extLst>
+        </p:cNvPr>
+        <p:cNvGrpSpPr/>
+        <p:nvPr/>
+      </p:nvGrpSpPr>
+      <p:grpSpPr>
+        <a:xfrm>
+          <a:off x="0" y="0"/>
+          <a:ext cx="0" cy="0"/>
+          <a:chOff x="0" y="0"/>
+          <a:chExt cx="0" cy="0"/>
+        </a:xfrm>
+      </p:grpSpPr>
+      <p:sp>
+        <p:nvSpPr>
+          <p:cNvPr id="2" name="Title 1">
+            <a:extLst>
+              <a:ext uri="{FF2B5EF4-FFF2-40B4-BE49-F238E27FC236}">
+                <a16:creationId xmlns:a16="http://schemas.microsoft.com/office/drawing/2014/main" id="{A2167554-4189-3912-5DD1-B564582E8F20}"/>
+              </a:ext>
+            </a:extLst>
+          </p:cNvPr>
+          <p:cNvSpPr>
+            <a:spLocks noGrp="1"/>
+          </p:cNvSpPr>
+          <p:nvPr>
+            <p:ph type="title"/>
+          </p:nvPr>
+        </p:nvSpPr>
+        <p:spPr>
+          <a:xfrm>
+            <a:off x="838200" y="365126"/>
+            <a:ext cx="10515600" cy="1126050"/>
+          </a:xfrm>
+        </p:spPr>
+        <p:txBody>
+          <a:bodyPr>
+            <a:normAutofit/>
+          </a:bodyPr>
+          <a:lstStyle/>
+          <a:p>
+            <a:r>
+              <a:rPr lang="en-US" dirty="0"/>
+              <a:t>Tue,050226</a:t>
+            </a:r>
+          </a:p>
+        </p:txBody>
+      </p:sp>
+      <p:sp>
+        <p:nvSpPr>
+          <p:cNvPr id="4" name="Content Placeholder 3">
+            <a:extLst>
+              <a:ext uri="{FF2B5EF4-FFF2-40B4-BE49-F238E27FC236}">
+                <a16:creationId xmlns:a16="http://schemas.microsoft.com/office/drawing/2014/main" id="{2D7CABDD-1BA0-72C5-A353-2A5C1F281EFE}"/>
+              </a:ext>
+            </a:extLst>
+          </p:cNvPr>
+          <p:cNvSpPr>
+            <a:spLocks noGrp="1"/>
+          </p:cNvSpPr>
+          <p:nvPr>
+            <p:ph idx="1"/>
+          </p:nvPr>
+        </p:nvSpPr>
+        <p:spPr>
+          <a:xfrm>
+            <a:off x="838200" y="1491175"/>
+            <a:ext cx="10515600" cy="4867422"/>
+          </a:xfrm>
+        </p:spPr>
+        <p:txBody>
+          <a:bodyPr>
+            <a:normAutofit/>
+          </a:bodyPr>
+          <a:lstStyle/>
+          <a:p>
+            <a:r>
+              <a:rPr lang="en-US" dirty="0"/>
+              <a:t>Done</a:t>
+            </a:r>
+          </a:p>
+          <a:p>
+            <a:pPr lvl="1"/>
+            <a:r>
+              <a:rPr lang="en-US" dirty="0"/>
+              <a:t>Read and understood the QA Test Plan for the CV Evaluation Pipeline link</a:t>
+            </a:r>
+          </a:p>
+          <a:p>
+            <a:r>
+              <a:rPr lang="en-US" dirty="0"/>
+              <a:t>Todo</a:t>
+            </a:r>
+          </a:p>
+          <a:p>
+            <a:pPr lvl="1"/>
+            <a:r>
+              <a:rPr lang="en-US" dirty="0"/>
+              <a:t>Plan tasks for Sprint 11 in Jira</a:t>
+            </a:r>
+          </a:p>
+          <a:p>
+            <a:pPr lvl="1"/>
+            <a:r>
+              <a:rPr lang="en-US" dirty="0"/>
+              <a:t>Develop pipeline to bundle data for each student (Pipeline_2_user_hyde_refresh.py)</a:t>
+            </a:r>
+          </a:p>
+          <a:p>
+            <a:r>
+              <a:rPr lang="en-US" dirty="0"/>
+              <a:t>Issue</a:t>
+            </a:r>
+          </a:p>
+          <a:p>
+            <a:pPr lvl="1"/>
+            <a:r>
+              <a:rPr lang="en-US" dirty="0"/>
+              <a:t> -</a:t>
+            </a:r>
+          </a:p>
+          <a:p>
+            <a:endParaRPr lang="en-US" dirty="0"/>
+          </a:p>
+          <a:p>
+            <a:pPr lvl="1"/>
+            <a:endParaRPr lang="en-US" dirty="0"/>
+          </a:p>
+        </p:txBody>
+      </p:sp>
+    </p:spTree>
+    <p:extLst>
+      <p:ext uri="{BB962C8B-B14F-4D97-AF65-F5344CB8AC3E}">
+        <p14:creationId xmlns:p14="http://schemas.microsoft.com/office/powerpoint/2010/main" val="2709007082"/>
+      </p:ext>
+    </p:extLst>
+  </p:cSld>
+  <p:clrMapOvr>
+    <a:masterClrMapping/>
+  </p:clrMapOvr>
+</p:sld>
+</file>
+
+<file path=ppt/slides/slide31.xml><?xml version="1.0" encoding="utf-8"?>
 <p:sld xmlns:a="http://schemas.openxmlformats.org/drawingml/2006/main" xmlns:r="http://schemas.openxmlformats.org/officeDocument/2006/relationships" xmlns:p="http://schemas.openxmlformats.org/presentationml/2006/main">
   <p:cSld>
     <p:bg>
@@ -27530,7 +27702,7 @@
 </p:sld>
 </file>
 
-<file path=ppt/slides/slide31.xml><?xml version="1.0" encoding="utf-8"?>
+<file path=ppt/slides/slide32.xml><?xml version="1.0" encoding="utf-8"?>
 <p:sld xmlns:a="http://schemas.openxmlformats.org/drawingml/2006/main" xmlns:r="http://schemas.openxmlformats.org/officeDocument/2006/relationships" xmlns:p="http://schemas.openxmlformats.org/presentationml/2006/main">
   <p:cSld>
     <p:spTree>
@@ -27684,7 +27856,7 @@
 </p:sld>
 </file>
 
-<file path=ppt/slides/slide32.xml><?xml version="1.0" encoding="utf-8"?>
+<file path=ppt/slides/slide33.xml><?xml version="1.0" encoding="utf-8"?>
 <p:sld xmlns:a="http://schemas.openxmlformats.org/drawingml/2006/main" xmlns:r="http://schemas.openxmlformats.org/officeDocument/2006/relationships" xmlns:p="http://schemas.openxmlformats.org/presentationml/2006/main">
   <p:cSld>
     <p:spTree>
@@ -27855,7 +28027,7 @@
 </p:sld>
 </file>
 
-<file path=ppt/slides/slide33.xml><?xml version="1.0" encoding="utf-8"?>
+<file path=ppt/slides/slide34.xml><?xml version="1.0" encoding="utf-8"?>
 <p:sld xmlns:a="http://schemas.openxmlformats.org/drawingml/2006/main" xmlns:r="http://schemas.openxmlformats.org/officeDocument/2006/relationships" xmlns:p="http://schemas.openxmlformats.org/presentationml/2006/main">
   <p:cSld>
     <p:spTree>
@@ -28123,7 +28295,7 @@
 </p:sld>
 </file>
 
-<file path=ppt/slides/slide34.xml><?xml version="1.0" encoding="utf-8"?>
+<file path=ppt/slides/slide35.xml><?xml version="1.0" encoding="utf-8"?>
 <p:sld xmlns:a="http://schemas.openxmlformats.org/drawingml/2006/main" xmlns:r="http://schemas.openxmlformats.org/officeDocument/2006/relationships" xmlns:p="http://schemas.openxmlformats.org/presentationml/2006/main" show="0">
   <p:cSld>
     <p:spTree>
@@ -28261,7 +28433,7 @@
 </p:sld>
 </file>
 
-<file path=ppt/slides/slide35.xml><?xml version="1.0" encoding="utf-8"?>
+<file path=ppt/slides/slide36.xml><?xml version="1.0" encoding="utf-8"?>
 <p:sld xmlns:a="http://schemas.openxmlformats.org/drawingml/2006/main" xmlns:r="http://schemas.openxmlformats.org/officeDocument/2006/relationships" xmlns:p="http://schemas.openxmlformats.org/presentationml/2006/main" show="0">
   <p:cSld>
     <p:spTree>
@@ -28368,7 +28540,7 @@
 </p:sld>
 </file>
 
-<file path=ppt/slides/slide36.xml><?xml version="1.0" encoding="utf-8"?>
+<file path=ppt/slides/slide37.xml><?xml version="1.0" encoding="utf-8"?>
 <p:sld xmlns:a="http://schemas.openxmlformats.org/drawingml/2006/main" xmlns:r="http://schemas.openxmlformats.org/officeDocument/2006/relationships" xmlns:p="http://schemas.openxmlformats.org/presentationml/2006/main" show="0">
   <p:cSld>
     <p:spTree>
@@ -28723,7 +28895,7 @@
 </p:sld>
 </file>
 
-<file path=ppt/slides/slide37.xml><?xml version="1.0" encoding="utf-8"?>
+<file path=ppt/slides/slide38.xml><?xml version="1.0" encoding="utf-8"?>
 <p:sld xmlns:a="http://schemas.openxmlformats.org/drawingml/2006/main" xmlns:r="http://schemas.openxmlformats.org/officeDocument/2006/relationships" xmlns:p="http://schemas.openxmlformats.org/presentationml/2006/main" show="0">
   <p:cSld>
     <p:spTree>
@@ -29058,7 +29230,7 @@
 </p:sld>
 </file>
 
-<file path=ppt/slides/slide38.xml><?xml version="1.0" encoding="utf-8"?>
+<file path=ppt/slides/slide39.xml><?xml version="1.0" encoding="utf-8"?>
 <p:sld xmlns:a="http://schemas.openxmlformats.org/drawingml/2006/main" xmlns:r="http://schemas.openxmlformats.org/officeDocument/2006/relationships" xmlns:p="http://schemas.openxmlformats.org/presentationml/2006/main" show="0">
   <p:cSld>
     <p:spTree>
@@ -30842,139 +31014,6 @@
     <p:extLst>
       <p:ext uri="{BB962C8B-B14F-4D97-AF65-F5344CB8AC3E}">
         <p14:creationId xmlns:p14="http://schemas.microsoft.com/office/powerpoint/2010/main" val="254193437"/>
-      </p:ext>
-    </p:extLst>
-  </p:cSld>
-  <p:clrMapOvr>
-    <a:masterClrMapping/>
-  </p:clrMapOvr>
-</p:sld>
-</file>
-
-<file path=ppt/slides/slide39.xml><?xml version="1.0" encoding="utf-8"?>
-<p:sld xmlns:a="http://schemas.openxmlformats.org/drawingml/2006/main" xmlns:r="http://schemas.openxmlformats.org/officeDocument/2006/relationships" xmlns:p="http://schemas.openxmlformats.org/presentationml/2006/main" show="0">
-  <p:cSld>
-    <p:spTree>
-      <p:nvGrpSpPr>
-        <p:cNvPr id="1" name="">
-          <a:extLst>
-            <a:ext uri="{FF2B5EF4-FFF2-40B4-BE49-F238E27FC236}">
-              <a16:creationId xmlns:a16="http://schemas.microsoft.com/office/drawing/2014/main" id="{56FD6E4F-886B-CC67-1C51-230A6575C4F5}"/>
-            </a:ext>
-          </a:extLst>
-        </p:cNvPr>
-        <p:cNvGrpSpPr/>
-        <p:nvPr/>
-      </p:nvGrpSpPr>
-      <p:grpSpPr>
-        <a:xfrm>
-          <a:off x="0" y="0"/>
-          <a:ext cx="0" cy="0"/>
-          <a:chOff x="0" y="0"/>
-          <a:chExt cx="0" cy="0"/>
-        </a:xfrm>
-      </p:grpSpPr>
-      <p:sp>
-        <p:nvSpPr>
-          <p:cNvPr id="24" name="Title 1">
-            <a:extLst>
-              <a:ext uri="{FF2B5EF4-FFF2-40B4-BE49-F238E27FC236}">
-                <a16:creationId xmlns:a16="http://schemas.microsoft.com/office/drawing/2014/main" id="{4999BE93-6CCF-E4B7-5BF4-0E87CB925488}"/>
-              </a:ext>
-            </a:extLst>
-          </p:cNvPr>
-          <p:cNvSpPr txBox="1">
-            <a:spLocks/>
-          </p:cNvSpPr>
-          <p:nvPr/>
-        </p:nvSpPr>
-        <p:spPr>
-          <a:xfrm>
-            <a:off x="838200" y="333595"/>
-            <a:ext cx="10515600" cy="528254"/>
-          </a:xfrm>
-          <a:prstGeom prst="rect">
-            <a:avLst/>
-          </a:prstGeom>
-        </p:spPr>
-        <p:txBody>
-          <a:bodyPr vert="horz" lIns="91440" tIns="45720" rIns="91440" bIns="45720" rtlCol="0" anchor="ctr">
-            <a:normAutofit/>
-          </a:bodyPr>
-          <a:lstStyle>
-            <a:lvl1pPr algn="ctr" defTabSz="914400" rtl="0" eaLnBrk="1" latinLnBrk="0" hangingPunct="1">
-              <a:lnSpc>
-                <a:spcPct val="90000"/>
-              </a:lnSpc>
-              <a:spcBef>
-                <a:spcPct val="0"/>
-              </a:spcBef>
-              <a:buNone/>
-              <a:defRPr sz="6000" kern="1200">
-                <a:solidFill>
-                  <a:schemeClr val="tx1"/>
-                </a:solidFill>
-                <a:latin typeface="+mj-lt"/>
-                <a:ea typeface="+mj-ea"/>
-                <a:cs typeface="+mj-cs"/>
-              </a:defRPr>
-            </a:lvl1pPr>
-          </a:lstStyle>
-          <a:p>
-            <a:r>
-              <a:rPr lang="en-US" sz="2400" dirty="0" err="1">
-                <a:cs typeface="Poppins Light"/>
-              </a:rPr>
-              <a:t>HyDE</a:t>
-            </a:r>
-            <a:r>
-              <a:rPr lang="en-US" sz="2400" dirty="0">
-                <a:cs typeface="Poppins Light"/>
-              </a:rPr>
-              <a:t> feed recommendation </a:t>
-            </a:r>
-            <a:r>
-              <a:rPr lang="en-TH" sz="2400" dirty="0"/>
-              <a:t>– System Overview</a:t>
-            </a:r>
-            <a:endParaRPr lang="en-US" dirty="0"/>
-          </a:p>
-        </p:txBody>
-      </p:sp>
-      <p:pic>
-        <p:nvPicPr>
-          <p:cNvPr id="9" name="Picture 8">
-            <a:extLst>
-              <a:ext uri="{FF2B5EF4-FFF2-40B4-BE49-F238E27FC236}">
-                <a16:creationId xmlns:a16="http://schemas.microsoft.com/office/drawing/2014/main" id="{1BCDCDA4-6B4B-3FE4-35D5-F0B4A7FC4FEB}"/>
-              </a:ext>
-            </a:extLst>
-          </p:cNvPr>
-          <p:cNvPicPr>
-            <a:picLocks noChangeAspect="1"/>
-          </p:cNvPicPr>
-          <p:nvPr/>
-        </p:nvPicPr>
-        <p:blipFill>
-          <a:blip r:embed="rId2"/>
-          <a:stretch>
-            <a:fillRect/>
-          </a:stretch>
-        </p:blipFill>
-        <p:spPr>
-          <a:xfrm>
-            <a:off x="1552066" y="1202535"/>
-            <a:ext cx="9087867" cy="5109853"/>
-          </a:xfrm>
-          <a:prstGeom prst="rect">
-            <a:avLst/>
-          </a:prstGeom>
-        </p:spPr>
-      </p:pic>
-    </p:spTree>
-    <p:extLst>
-      <p:ext uri="{BB962C8B-B14F-4D97-AF65-F5344CB8AC3E}">
-        <p14:creationId xmlns:p14="http://schemas.microsoft.com/office/powerpoint/2010/main" val="232173016"/>
       </p:ext>
     </p:extLst>
   </p:cSld>
@@ -31311,6 +31350,139 @@
         <p:cNvPr id="1" name="">
           <a:extLst>
             <a:ext uri="{FF2B5EF4-FFF2-40B4-BE49-F238E27FC236}">
+              <a16:creationId xmlns:a16="http://schemas.microsoft.com/office/drawing/2014/main" id="{56FD6E4F-886B-CC67-1C51-230A6575C4F5}"/>
+            </a:ext>
+          </a:extLst>
+        </p:cNvPr>
+        <p:cNvGrpSpPr/>
+        <p:nvPr/>
+      </p:nvGrpSpPr>
+      <p:grpSpPr>
+        <a:xfrm>
+          <a:off x="0" y="0"/>
+          <a:ext cx="0" cy="0"/>
+          <a:chOff x="0" y="0"/>
+          <a:chExt cx="0" cy="0"/>
+        </a:xfrm>
+      </p:grpSpPr>
+      <p:sp>
+        <p:nvSpPr>
+          <p:cNvPr id="24" name="Title 1">
+            <a:extLst>
+              <a:ext uri="{FF2B5EF4-FFF2-40B4-BE49-F238E27FC236}">
+                <a16:creationId xmlns:a16="http://schemas.microsoft.com/office/drawing/2014/main" id="{4999BE93-6CCF-E4B7-5BF4-0E87CB925488}"/>
+              </a:ext>
+            </a:extLst>
+          </p:cNvPr>
+          <p:cNvSpPr txBox="1">
+            <a:spLocks/>
+          </p:cNvSpPr>
+          <p:nvPr/>
+        </p:nvSpPr>
+        <p:spPr>
+          <a:xfrm>
+            <a:off x="838200" y="333595"/>
+            <a:ext cx="10515600" cy="528254"/>
+          </a:xfrm>
+          <a:prstGeom prst="rect">
+            <a:avLst/>
+          </a:prstGeom>
+        </p:spPr>
+        <p:txBody>
+          <a:bodyPr vert="horz" lIns="91440" tIns="45720" rIns="91440" bIns="45720" rtlCol="0" anchor="ctr">
+            <a:normAutofit/>
+          </a:bodyPr>
+          <a:lstStyle>
+            <a:lvl1pPr algn="ctr" defTabSz="914400" rtl="0" eaLnBrk="1" latinLnBrk="0" hangingPunct="1">
+              <a:lnSpc>
+                <a:spcPct val="90000"/>
+              </a:lnSpc>
+              <a:spcBef>
+                <a:spcPct val="0"/>
+              </a:spcBef>
+              <a:buNone/>
+              <a:defRPr sz="6000" kern="1200">
+                <a:solidFill>
+                  <a:schemeClr val="tx1"/>
+                </a:solidFill>
+                <a:latin typeface="+mj-lt"/>
+                <a:ea typeface="+mj-ea"/>
+                <a:cs typeface="+mj-cs"/>
+              </a:defRPr>
+            </a:lvl1pPr>
+          </a:lstStyle>
+          <a:p>
+            <a:r>
+              <a:rPr lang="en-US" sz="2400" dirty="0" err="1">
+                <a:cs typeface="Poppins Light"/>
+              </a:rPr>
+              <a:t>HyDE</a:t>
+            </a:r>
+            <a:r>
+              <a:rPr lang="en-US" sz="2400" dirty="0">
+                <a:cs typeface="Poppins Light"/>
+              </a:rPr>
+              <a:t> feed recommendation </a:t>
+            </a:r>
+            <a:r>
+              <a:rPr lang="en-TH" sz="2400" dirty="0"/>
+              <a:t>– System Overview</a:t>
+            </a:r>
+            <a:endParaRPr lang="en-US" dirty="0"/>
+          </a:p>
+        </p:txBody>
+      </p:sp>
+      <p:pic>
+        <p:nvPicPr>
+          <p:cNvPr id="9" name="Picture 8">
+            <a:extLst>
+              <a:ext uri="{FF2B5EF4-FFF2-40B4-BE49-F238E27FC236}">
+                <a16:creationId xmlns:a16="http://schemas.microsoft.com/office/drawing/2014/main" id="{1BCDCDA4-6B4B-3FE4-35D5-F0B4A7FC4FEB}"/>
+              </a:ext>
+            </a:extLst>
+          </p:cNvPr>
+          <p:cNvPicPr>
+            <a:picLocks noChangeAspect="1"/>
+          </p:cNvPicPr>
+          <p:nvPr/>
+        </p:nvPicPr>
+        <p:blipFill>
+          <a:blip r:embed="rId2"/>
+          <a:stretch>
+            <a:fillRect/>
+          </a:stretch>
+        </p:blipFill>
+        <p:spPr>
+          <a:xfrm>
+            <a:off x="1552066" y="1202535"/>
+            <a:ext cx="9087867" cy="5109853"/>
+          </a:xfrm>
+          <a:prstGeom prst="rect">
+            <a:avLst/>
+          </a:prstGeom>
+        </p:spPr>
+      </p:pic>
+    </p:spTree>
+    <p:extLst>
+      <p:ext uri="{BB962C8B-B14F-4D97-AF65-F5344CB8AC3E}">
+        <p14:creationId xmlns:p14="http://schemas.microsoft.com/office/powerpoint/2010/main" val="232173016"/>
+      </p:ext>
+    </p:extLst>
+  </p:cSld>
+  <p:clrMapOvr>
+    <a:masterClrMapping/>
+  </p:clrMapOvr>
+</p:sld>
+</file>
+
+<file path=ppt/slides/slide41.xml><?xml version="1.0" encoding="utf-8"?>
+<p:sld xmlns:a="http://schemas.openxmlformats.org/drawingml/2006/main" xmlns:r="http://schemas.openxmlformats.org/officeDocument/2006/relationships" xmlns:p="http://schemas.openxmlformats.org/presentationml/2006/main" show="0">
+  <p:cSld>
+    <p:spTree>
+      <p:nvGrpSpPr>
+        <p:cNvPr id="1" name="">
+          <a:extLst>
+            <a:ext uri="{FF2B5EF4-FFF2-40B4-BE49-F238E27FC236}">
               <a16:creationId xmlns:a16="http://schemas.microsoft.com/office/drawing/2014/main" id="{66165DDE-FB04-76D7-3668-1C8FFAC2B32A}"/>
             </a:ext>
           </a:extLst>
@@ -31430,7 +31602,7 @@
 </p:sld>
 </file>
 
-<file path=ppt/slides/slide41.xml><?xml version="1.0" encoding="utf-8"?>
+<file path=ppt/slides/slide42.xml><?xml version="1.0" encoding="utf-8"?>
 <p:sld xmlns:a="http://schemas.openxmlformats.org/drawingml/2006/main" xmlns:r="http://schemas.openxmlformats.org/officeDocument/2006/relationships" xmlns:p="http://schemas.openxmlformats.org/presentationml/2006/main" show="0">
   <p:cSld>
     <p:spTree>
@@ -31557,7 +31729,7 @@
 </p:sld>
 </file>
 
-<file path=ppt/slides/slide42.xml><?xml version="1.0" encoding="utf-8"?>
+<file path=ppt/slides/slide43.xml><?xml version="1.0" encoding="utf-8"?>
 <p:sld xmlns:a="http://schemas.openxmlformats.org/drawingml/2006/main" xmlns:r="http://schemas.openxmlformats.org/officeDocument/2006/relationships" xmlns:p="http://schemas.openxmlformats.org/presentationml/2006/main" show="0">
   <p:cSld>
     <p:spTree>
@@ -31738,7 +31910,7 @@
 </p:sld>
 </file>
 
-<file path=ppt/slides/slide43.xml><?xml version="1.0" encoding="utf-8"?>
+<file path=ppt/slides/slide44.xml><?xml version="1.0" encoding="utf-8"?>
 <p:sld xmlns:a="http://schemas.openxmlformats.org/drawingml/2006/main" xmlns:r="http://schemas.openxmlformats.org/officeDocument/2006/relationships" xmlns:p="http://schemas.openxmlformats.org/presentationml/2006/main" show="0">
   <p:cSld>
     <p:spTree>
@@ -31998,7 +32170,7 @@
 </p:sld>
 </file>
 
-<file path=ppt/slides/slide44.xml><?xml version="1.0" encoding="utf-8"?>
+<file path=ppt/slides/slide45.xml><?xml version="1.0" encoding="utf-8"?>
 <p:sld xmlns:a="http://schemas.openxmlformats.org/drawingml/2006/main" xmlns:r="http://schemas.openxmlformats.org/officeDocument/2006/relationships" xmlns:p="http://schemas.openxmlformats.org/presentationml/2006/main" show="0">
   <p:cSld>
     <p:spTree>

</xml_diff>